<commit_message>
Add editorial web case page, rebound-sim deck slide, and rebuild workflow
- src/web_deck.py renders outputs/duran_case.html: a self-contained
  editorial long-read (all nine figures base64-embedded, ~1MB) covering
  the outlier question, results-vs-process, the 2026 anomaly, the real
  erosion, the two-scenario rebound simulation, valuation timing, the
  outfield logjam, and the hold/deal-in-offseason bottom line; wired
  into run_all.py after the memo.
- deck/build_deck.py gains a rebound-math slide after "Don't sell low"
  (69% vs 47% rebound odds, $22M vs $18M offseason value, honesty line);
  deck is now 11 slides, existing slides untouched.
- .github/workflows/rebuild-web.yml regenerates the page on pushes that
  touch the build script, figures, or config.

Co-Authored-By: Claude Fable 5 <noreply@anthropic.com>
</commit_message>
<xml_diff>
--- a/outputs/Red_Sox_Outfield_Strategy.pptx
+++ b/outputs/Red_Sox_Outfield_Strategy.pptx
@@ -15,6 +15,7 @@
     <p:sldId id="263" r:id="rId14"/>
     <p:sldId id="264" r:id="rId15"/>
     <p:sldId id="265" r:id="rId16"/>
+    <p:sldId id="266" r:id="rId17"/>
   </p:sldIdLst>
   <p:sldSz cx="12191695" cy="6858000" type="screen4x3"/>
   <p:notesSz cx="6858000" cy="9144000"/>
@@ -3350,6 +3351,780 @@
     <p:bg>
       <p:bgPr>
         <a:solidFill>
+          <a:srgbClr val="F4F5F7"/>
+        </a:solidFill>
+        <a:effectLst/>
+      </p:bgPr>
+    </p:bg>
+    <p:spTree>
+      <p:nvGrpSpPr>
+        <p:cNvPr id="1" name=""/>
+        <p:cNvGrpSpPr/>
+        <p:nvPr/>
+      </p:nvGrpSpPr>
+      <p:grpSpPr/>
+      <p:sp>
+        <p:nvSpPr>
+          <p:cNvPr id="2" name="TextBox 1"/>
+          <p:cNvSpPr txBox="1"/>
+          <p:nvPr/>
+        </p:nvSpPr>
+        <p:spPr>
+          <a:xfrm>
+            <a:off x="566928" y="384048"/>
+            <a:ext cx="10058400" cy="274320"/>
+          </a:xfrm>
+          <a:prstGeom prst="rect">
+            <a:avLst/>
+          </a:prstGeom>
+          <a:noFill/>
+        </p:spPr>
+        <p:txBody>
+          <a:bodyPr wrap="square" anchor="t" lIns="0" rIns="0" tIns="0" bIns="0">
+            <a:spAutoFit/>
+          </a:bodyPr>
+          <a:lstStyle/>
+          <a:p>
+            <a:pPr algn="l">
+              <a:lnSpc>
+                <a:spcPct val="100000"/>
+              </a:lnSpc>
+              <a:spcAft>
+                <a:spcPts val="0"/>
+              </a:spcAft>
+            </a:pPr>
+            <a:r>
+              <a:rPr sz="1250" b="1" i="0">
+                <a:solidFill>
+                  <a:srgbClr val="BD3039"/>
+                </a:solidFill>
+                <a:latin typeface="Calibri"/>
+              </a:rPr>
+              <a:t>THE SEQUENCE</a:t>
+            </a:r>
+          </a:p>
+        </p:txBody>
+      </p:sp>
+      <p:sp>
+        <p:nvSpPr>
+          <p:cNvPr id="3" name="TextBox 2"/>
+          <p:cNvSpPr txBox="1"/>
+          <p:nvPr/>
+        </p:nvSpPr>
+        <p:spPr>
+          <a:xfrm>
+            <a:off x="566928" y="658368"/>
+            <a:ext cx="11064240" cy="868680"/>
+          </a:xfrm>
+          <a:prstGeom prst="rect">
+            <a:avLst/>
+          </a:prstGeom>
+          <a:noFill/>
+        </p:spPr>
+        <p:txBody>
+          <a:bodyPr wrap="square" anchor="t" lIns="0" rIns="0" tIns="0" bIns="0">
+            <a:spAutoFit/>
+          </a:bodyPr>
+          <a:lstStyle/>
+          <a:p>
+            <a:pPr algn="l">
+              <a:lnSpc>
+                <a:spcPct val="100000"/>
+              </a:lnSpc>
+              <a:spcAft>
+                <a:spcPts val="0"/>
+              </a:spcAft>
+            </a:pPr>
+            <a:r>
+              <a:rPr sz="3000" b="1" i="0">
+                <a:solidFill>
+                  <a:srgbClr val="0C2340"/>
+                </a:solidFill>
+                <a:latin typeface="Cambria"/>
+              </a:rPr>
+              <a:t>Solve it this winter, from a position of strength</a:t>
+            </a:r>
+          </a:p>
+        </p:txBody>
+      </p:sp>
+      <p:sp>
+        <p:nvSpPr>
+          <p:cNvPr id="4" name="Oval 3"/>
+          <p:cNvSpPr/>
+          <p:nvPr/>
+        </p:nvSpPr>
+        <p:spPr>
+          <a:xfrm>
+            <a:off x="640080" y="1801368"/>
+            <a:ext cx="457200" cy="457200"/>
+          </a:xfrm>
+          <a:prstGeom prst="ellipse">
+            <a:avLst/>
+          </a:prstGeom>
+          <a:solidFill>
+            <a:srgbClr val="BD3039"/>
+          </a:solidFill>
+          <a:ln>
+            <a:noFill/>
+          </a:ln>
+          <a:effectLst/>
+        </p:spPr>
+        <p:style>
+          <a:lnRef idx="1">
+            <a:schemeClr val="accent1"/>
+          </a:lnRef>
+          <a:fillRef idx="3">
+            <a:schemeClr val="accent1"/>
+          </a:fillRef>
+          <a:effectRef idx="2">
+            <a:schemeClr val="accent1"/>
+          </a:effectRef>
+          <a:fontRef idx="minor">
+            <a:schemeClr val="lt1"/>
+          </a:fontRef>
+        </p:style>
+        <p:txBody>
+          <a:bodyPr rtlCol="0" anchor="ctr" wrap="none"/>
+          <a:lstStyle/>
+          <a:p>
+            <a:pPr algn="ctr"/>
+            <a:r>
+              <a:rPr sz="1800" b="1">
+                <a:solidFill>
+                  <a:srgbClr val="FFFFFF"/>
+                </a:solidFill>
+                <a:latin typeface="Cambria"/>
+              </a:rPr>
+              <a:t>1</a:t>
+            </a:r>
+          </a:p>
+        </p:txBody>
+      </p:sp>
+      <p:sp>
+        <p:nvSpPr>
+          <p:cNvPr id="5" name="TextBox 4"/>
+          <p:cNvSpPr txBox="1"/>
+          <p:nvPr/>
+        </p:nvSpPr>
+        <p:spPr>
+          <a:xfrm>
+            <a:off x="1280160" y="1783080"/>
+            <a:ext cx="6126480" cy="1005840"/>
+          </a:xfrm>
+          <a:prstGeom prst="rect">
+            <a:avLst/>
+          </a:prstGeom>
+          <a:noFill/>
+        </p:spPr>
+        <p:txBody>
+          <a:bodyPr wrap="square" anchor="t" lIns="0" rIns="0" tIns="0" bIns="0">
+            <a:spAutoFit/>
+          </a:bodyPr>
+          <a:lstStyle/>
+          <a:p>
+            <a:pPr algn="l">
+              <a:lnSpc>
+                <a:spcPct val="108000"/>
+              </a:lnSpc>
+              <a:spcAft>
+                <a:spcPts val="200"/>
+              </a:spcAft>
+            </a:pPr>
+            <a:r>
+              <a:rPr sz="1700" b="1" i="0">
+                <a:solidFill>
+                  <a:srgbClr val="0C2340"/>
+                </a:solidFill>
+                <a:latin typeface="Cambria"/>
+              </a:rPr>
+              <a:t>Hold through 2026</a:t>
+            </a:r>
+          </a:p>
+          <a:p>
+            <a:pPr algn="l">
+              <a:lnSpc>
+                <a:spcPct val="108000"/>
+              </a:lnSpc>
+              <a:spcAft>
+                <a:spcPts val="200"/>
+              </a:spcAft>
+            </a:pPr>
+            <a:r>
+              <a:rPr sz="1350" b="0" i="0">
+                <a:solidFill>
+                  <a:srgbClr val="6B7280"/>
+                </a:solidFill>
+                <a:latin typeface="Calibri"/>
+              </a:rPr>
+              <a:t>No contention urgency and Anthony hurt — keep Duran's bat, let his value rebound off an unlucky first half.</a:t>
+            </a:r>
+          </a:p>
+        </p:txBody>
+      </p:sp>
+      <p:sp>
+        <p:nvSpPr>
+          <p:cNvPr id="6" name="Oval 5"/>
+          <p:cNvSpPr/>
+          <p:nvPr/>
+        </p:nvSpPr>
+        <p:spPr>
+          <a:xfrm>
+            <a:off x="640080" y="2971800"/>
+            <a:ext cx="457200" cy="457200"/>
+          </a:xfrm>
+          <a:prstGeom prst="ellipse">
+            <a:avLst/>
+          </a:prstGeom>
+          <a:solidFill>
+            <a:srgbClr val="BD3039"/>
+          </a:solidFill>
+          <a:ln>
+            <a:noFill/>
+          </a:ln>
+          <a:effectLst/>
+        </p:spPr>
+        <p:style>
+          <a:lnRef idx="1">
+            <a:schemeClr val="accent1"/>
+          </a:lnRef>
+          <a:fillRef idx="3">
+            <a:schemeClr val="accent1"/>
+          </a:fillRef>
+          <a:effectRef idx="2">
+            <a:schemeClr val="accent1"/>
+          </a:effectRef>
+          <a:fontRef idx="minor">
+            <a:schemeClr val="lt1"/>
+          </a:fontRef>
+        </p:style>
+        <p:txBody>
+          <a:bodyPr rtlCol="0" anchor="ctr" wrap="none"/>
+          <a:lstStyle/>
+          <a:p>
+            <a:pPr algn="ctr"/>
+            <a:r>
+              <a:rPr sz="1800" b="1">
+                <a:solidFill>
+                  <a:srgbClr val="FFFFFF"/>
+                </a:solidFill>
+                <a:latin typeface="Cambria"/>
+              </a:rPr>
+              <a:t>2</a:t>
+            </a:r>
+          </a:p>
+        </p:txBody>
+      </p:sp>
+      <p:sp>
+        <p:nvSpPr>
+          <p:cNvPr id="7" name="TextBox 6"/>
+          <p:cNvSpPr txBox="1"/>
+          <p:nvPr/>
+        </p:nvSpPr>
+        <p:spPr>
+          <a:xfrm>
+            <a:off x="1280160" y="2953512"/>
+            <a:ext cx="6126480" cy="1005840"/>
+          </a:xfrm>
+          <a:prstGeom prst="rect">
+            <a:avLst/>
+          </a:prstGeom>
+          <a:noFill/>
+        </p:spPr>
+        <p:txBody>
+          <a:bodyPr wrap="square" anchor="t" lIns="0" rIns="0" tIns="0" bIns="0">
+            <a:spAutoFit/>
+          </a:bodyPr>
+          <a:lstStyle/>
+          <a:p>
+            <a:pPr algn="l">
+              <a:lnSpc>
+                <a:spcPct val="108000"/>
+              </a:lnSpc>
+              <a:spcAft>
+                <a:spcPts val="200"/>
+              </a:spcAft>
+            </a:pPr>
+            <a:r>
+              <a:rPr sz="1700" b="1" i="0">
+                <a:solidFill>
+                  <a:srgbClr val="0C2340"/>
+                </a:solidFill>
+                <a:latin typeface="Cambria"/>
+              </a:rPr>
+              <a:t>Deal Duran in the offseason</a:t>
+            </a:r>
+          </a:p>
+          <a:p>
+            <a:pPr algn="l">
+              <a:lnSpc>
+                <a:spcPct val="108000"/>
+              </a:lnSpc>
+              <a:spcAft>
+                <a:spcPts val="200"/>
+              </a:spcAft>
+            </a:pPr>
+            <a:r>
+              <a:rPr sz="1350" b="0" i="0">
+                <a:solidFill>
+                  <a:srgbClr val="6B7280"/>
+                </a:solidFill>
+                <a:latin typeface="Calibri"/>
+              </a:rPr>
+              <a:t>Anthony's healthy (jam returns), value restored. Trade him — plus Yoshida money — for controllable bats, not arms.</a:t>
+            </a:r>
+          </a:p>
+        </p:txBody>
+      </p:sp>
+      <p:sp>
+        <p:nvSpPr>
+          <p:cNvPr id="8" name="Oval 7"/>
+          <p:cNvSpPr/>
+          <p:nvPr/>
+        </p:nvSpPr>
+        <p:spPr>
+          <a:xfrm>
+            <a:off x="640080" y="4142231"/>
+            <a:ext cx="457200" cy="457200"/>
+          </a:xfrm>
+          <a:prstGeom prst="ellipse">
+            <a:avLst/>
+          </a:prstGeom>
+          <a:solidFill>
+            <a:srgbClr val="BD3039"/>
+          </a:solidFill>
+          <a:ln>
+            <a:noFill/>
+          </a:ln>
+          <a:effectLst/>
+        </p:spPr>
+        <p:style>
+          <a:lnRef idx="1">
+            <a:schemeClr val="accent1"/>
+          </a:lnRef>
+          <a:fillRef idx="3">
+            <a:schemeClr val="accent1"/>
+          </a:fillRef>
+          <a:effectRef idx="2">
+            <a:schemeClr val="accent1"/>
+          </a:effectRef>
+          <a:fontRef idx="minor">
+            <a:schemeClr val="lt1"/>
+          </a:fontRef>
+        </p:style>
+        <p:txBody>
+          <a:bodyPr rtlCol="0" anchor="ctr" wrap="none"/>
+          <a:lstStyle/>
+          <a:p>
+            <a:pPr algn="ctr"/>
+            <a:r>
+              <a:rPr sz="1800" b="1">
+                <a:solidFill>
+                  <a:srgbClr val="FFFFFF"/>
+                </a:solidFill>
+                <a:latin typeface="Cambria"/>
+              </a:rPr>
+              <a:t>3</a:t>
+            </a:r>
+          </a:p>
+        </p:txBody>
+      </p:sp>
+      <p:sp>
+        <p:nvSpPr>
+          <p:cNvPr id="9" name="TextBox 8"/>
+          <p:cNvSpPr txBox="1"/>
+          <p:nvPr/>
+        </p:nvSpPr>
+        <p:spPr>
+          <a:xfrm>
+            <a:off x="1280160" y="4123944"/>
+            <a:ext cx="6126480" cy="1005840"/>
+          </a:xfrm>
+          <a:prstGeom prst="rect">
+            <a:avLst/>
+          </a:prstGeom>
+          <a:noFill/>
+        </p:spPr>
+        <p:txBody>
+          <a:bodyPr wrap="square" anchor="t" lIns="0" rIns="0" tIns="0" bIns="0">
+            <a:spAutoFit/>
+          </a:bodyPr>
+          <a:lstStyle/>
+          <a:p>
+            <a:pPr algn="l">
+              <a:lnSpc>
+                <a:spcPct val="108000"/>
+              </a:lnSpc>
+              <a:spcAft>
+                <a:spcPts val="200"/>
+              </a:spcAft>
+            </a:pPr>
+            <a:r>
+              <a:rPr sz="1700" b="1" i="0">
+                <a:solidFill>
+                  <a:srgbClr val="0C2340"/>
+                </a:solidFill>
+                <a:latin typeface="Cambria"/>
+              </a:rPr>
+              <a:t>Run it back in 2027</a:t>
+            </a:r>
+          </a:p>
+          <a:p>
+            <a:pPr algn="l">
+              <a:lnSpc>
+                <a:spcPct val="108000"/>
+              </a:lnSpc>
+              <a:spcAft>
+                <a:spcPts val="200"/>
+              </a:spcAft>
+            </a:pPr>
+            <a:r>
+              <a:rPr sz="1350" b="0" i="0">
+                <a:solidFill>
+                  <a:srgbClr val="6B7280"/>
+                </a:solidFill>
+                <a:latin typeface="Calibri"/>
+              </a:rPr>
+              <a:t>OF = Anthony / Rafaela / Abreu; strong rotation intact; DH opens after 2027. A cheaper, younger, more balanced roster.</a:t>
+            </a:r>
+          </a:p>
+        </p:txBody>
+      </p:sp>
+      <p:sp>
+        <p:nvSpPr>
+          <p:cNvPr id="10" name="Rounded Rectangle 9"/>
+          <p:cNvSpPr/>
+          <p:nvPr/>
+        </p:nvSpPr>
+        <p:spPr>
+          <a:xfrm>
+            <a:off x="7818120" y="1783080"/>
+            <a:ext cx="3794760" cy="3337560"/>
+          </a:xfrm>
+          <a:prstGeom prst="roundRect">
+            <a:avLst>
+              <a:gd name="adj" fmla="val 8000"/>
+            </a:avLst>
+          </a:prstGeom>
+          <a:solidFill>
+            <a:srgbClr val="0C2340"/>
+          </a:solidFill>
+          <a:ln>
+            <a:noFill/>
+          </a:ln>
+          <a:effectLst/>
+        </p:spPr>
+        <p:style>
+          <a:lnRef idx="1">
+            <a:schemeClr val="accent1"/>
+          </a:lnRef>
+          <a:fillRef idx="3">
+            <a:schemeClr val="accent1"/>
+          </a:fillRef>
+          <a:effectRef idx="2">
+            <a:schemeClr val="accent1"/>
+          </a:effectRef>
+          <a:fontRef idx="minor">
+            <a:schemeClr val="lt1"/>
+          </a:fontRef>
+        </p:style>
+        <p:txBody>
+          <a:bodyPr rtlCol="0" anchor="ctr"/>
+          <a:lstStyle/>
+          <a:p>
+            <a:pPr algn="ctr"/>
+          </a:p>
+        </p:txBody>
+      </p:sp>
+      <p:sp>
+        <p:nvSpPr>
+          <p:cNvPr id="11" name="TextBox 10"/>
+          <p:cNvSpPr txBox="1"/>
+          <p:nvPr/>
+        </p:nvSpPr>
+        <p:spPr>
+          <a:xfrm>
+            <a:off x="8092440" y="2011680"/>
+            <a:ext cx="3291840" cy="365760"/>
+          </a:xfrm>
+          <a:prstGeom prst="rect">
+            <a:avLst/>
+          </a:prstGeom>
+          <a:noFill/>
+        </p:spPr>
+        <p:txBody>
+          <a:bodyPr wrap="square" anchor="t" lIns="0" rIns="0" tIns="0" bIns="0">
+            <a:spAutoFit/>
+          </a:bodyPr>
+          <a:lstStyle/>
+          <a:p>
+            <a:pPr algn="l">
+              <a:lnSpc>
+                <a:spcPct val="100000"/>
+              </a:lnSpc>
+              <a:spcAft>
+                <a:spcPts val="0"/>
+              </a:spcAft>
+            </a:pPr>
+            <a:r>
+              <a:rPr sz="1250" b="1" i="0">
+                <a:solidFill>
+                  <a:srgbClr val="C9D2E3"/>
+                </a:solidFill>
+                <a:latin typeface="Calibri"/>
+              </a:rPr>
+              <a:t>THE RETURN</a:t>
+            </a:r>
+          </a:p>
+        </p:txBody>
+      </p:sp>
+      <p:sp>
+        <p:nvSpPr>
+          <p:cNvPr id="12" name="TextBox 11"/>
+          <p:cNvSpPr txBox="1"/>
+          <p:nvPr/>
+        </p:nvSpPr>
+        <p:spPr>
+          <a:xfrm>
+            <a:off x="8092440" y="2487168"/>
+            <a:ext cx="3291840" cy="914400"/>
+          </a:xfrm>
+          <a:prstGeom prst="rect">
+            <a:avLst/>
+          </a:prstGeom>
+          <a:noFill/>
+        </p:spPr>
+        <p:txBody>
+          <a:bodyPr wrap="square" anchor="t" lIns="0" rIns="0" tIns="0" bIns="0">
+            <a:spAutoFit/>
+          </a:bodyPr>
+          <a:lstStyle/>
+          <a:p>
+            <a:pPr algn="l">
+              <a:lnSpc>
+                <a:spcPct val="105000"/>
+              </a:lnSpc>
+              <a:spcAft>
+                <a:spcPts val="200"/>
+              </a:spcAft>
+            </a:pPr>
+            <a:r>
+              <a:rPr sz="1300" b="1" i="0">
+                <a:solidFill>
+                  <a:srgbClr val="F0B8BC"/>
+                </a:solidFill>
+                <a:latin typeface="Calibri"/>
+              </a:rPr>
+              <a:t>Sell now (nadir)</a:t>
+            </a:r>
+          </a:p>
+          <a:p>
+            <a:pPr algn="l">
+              <a:lnSpc>
+                <a:spcPct val="105000"/>
+              </a:lnSpc>
+              <a:spcAft>
+                <a:spcPts val="200"/>
+              </a:spcAft>
+            </a:pPr>
+            <a:r>
+              <a:rPr sz="1400" b="0" i="0">
+                <a:solidFill>
+                  <a:srgbClr val="FFFFFF"/>
+                </a:solidFill>
+                <a:latin typeface="Calibri"/>
+              </a:rPr>
+              <a:t>~$10–15M · a 45-FV bat</a:t>
+            </a:r>
+          </a:p>
+        </p:txBody>
+      </p:sp>
+      <p:sp>
+        <p:nvSpPr>
+          <p:cNvPr id="13" name="TextBox 12"/>
+          <p:cNvSpPr txBox="1"/>
+          <p:nvPr/>
+        </p:nvSpPr>
+        <p:spPr>
+          <a:xfrm>
+            <a:off x="8092440" y="3520440"/>
+            <a:ext cx="3291840" cy="1005840"/>
+          </a:xfrm>
+          <a:prstGeom prst="rect">
+            <a:avLst/>
+          </a:prstGeom>
+          <a:noFill/>
+        </p:spPr>
+        <p:txBody>
+          <a:bodyPr wrap="square" anchor="t" lIns="0" rIns="0" tIns="0" bIns="0">
+            <a:spAutoFit/>
+          </a:bodyPr>
+          <a:lstStyle/>
+          <a:p>
+            <a:pPr algn="l">
+              <a:lnSpc>
+                <a:spcPct val="105000"/>
+              </a:lnSpc>
+              <a:spcAft>
+                <a:spcPts val="200"/>
+              </a:spcAft>
+            </a:pPr>
+            <a:r>
+              <a:rPr sz="1300" b="1" i="0">
+                <a:solidFill>
+                  <a:srgbClr val="A9E5B5"/>
+                </a:solidFill>
+                <a:latin typeface="Calibri"/>
+              </a:rPr>
+              <a:t>Sell after rebound</a:t>
+            </a:r>
+          </a:p>
+          <a:p>
+            <a:pPr algn="l">
+              <a:lnSpc>
+                <a:spcPct val="105000"/>
+              </a:lnSpc>
+              <a:spcAft>
+                <a:spcPts val="200"/>
+              </a:spcAft>
+            </a:pPr>
+            <a:r>
+              <a:rPr sz="1400" b="0" i="0">
+                <a:solidFill>
+                  <a:srgbClr val="FFFFFF"/>
+                </a:solidFill>
+                <a:latin typeface="Calibri"/>
+              </a:rPr>
+              <a:t>~$28M · a 50-FV, top-100</a:t>
+            </a:r>
+          </a:p>
+          <a:p>
+            <a:pPr algn="l">
+              <a:lnSpc>
+                <a:spcPct val="105000"/>
+              </a:lnSpc>
+              <a:spcAft>
+                <a:spcPts val="200"/>
+              </a:spcAft>
+            </a:pPr>
+            <a:r>
+              <a:rPr sz="1400" b="0" i="0">
+                <a:solidFill>
+                  <a:srgbClr val="FFFFFF"/>
+                </a:solidFill>
+                <a:latin typeface="Calibri"/>
+              </a:rPr>
+              <a:t>controllable talent</a:t>
+            </a:r>
+          </a:p>
+        </p:txBody>
+      </p:sp>
+      <p:sp>
+        <p:nvSpPr>
+          <p:cNvPr id="14" name="TextBox 13"/>
+          <p:cNvSpPr txBox="1"/>
+          <p:nvPr/>
+        </p:nvSpPr>
+        <p:spPr>
+          <a:xfrm>
+            <a:off x="8092440" y="4617720"/>
+            <a:ext cx="3291840" cy="457200"/>
+          </a:xfrm>
+          <a:prstGeom prst="rect">
+            <a:avLst/>
+          </a:prstGeom>
+          <a:noFill/>
+        </p:spPr>
+        <p:txBody>
+          <a:bodyPr wrap="square" anchor="t" lIns="0" rIns="0" tIns="0" bIns="0">
+            <a:spAutoFit/>
+          </a:bodyPr>
+          <a:lstStyle/>
+          <a:p>
+            <a:pPr algn="l">
+              <a:lnSpc>
+                <a:spcPct val="105000"/>
+              </a:lnSpc>
+              <a:spcAft>
+                <a:spcPts val="400"/>
+              </a:spcAft>
+            </a:pPr>
+            <a:r>
+              <a:rPr sz="1150" b="0" i="1">
+                <a:solidFill>
+                  <a:srgbClr val="C9D2E3"/>
+                </a:solidFill>
+                <a:latin typeface="Calibri"/>
+              </a:rPr>
+              <a:t>One grade of return = the reason to wait.</a:t>
+            </a:r>
+          </a:p>
+        </p:txBody>
+      </p:sp>
+      <p:sp>
+        <p:nvSpPr>
+          <p:cNvPr id="15" name="TextBox 14"/>
+          <p:cNvSpPr txBox="1"/>
+          <p:nvPr/>
+        </p:nvSpPr>
+        <p:spPr>
+          <a:xfrm>
+            <a:off x="566928" y="6510528"/>
+            <a:ext cx="11064240" cy="274320"/>
+          </a:xfrm>
+          <a:prstGeom prst="rect">
+            <a:avLst/>
+          </a:prstGeom>
+          <a:noFill/>
+        </p:spPr>
+        <p:txBody>
+          <a:bodyPr wrap="square" anchor="t" lIns="0" rIns="0" tIns="0" bIns="0">
+            <a:spAutoFit/>
+          </a:bodyPr>
+          <a:lstStyle/>
+          <a:p>
+            <a:pPr algn="l">
+              <a:lnSpc>
+                <a:spcPct val="100000"/>
+              </a:lnSpc>
+              <a:spcAft>
+                <a:spcPts val="0"/>
+              </a:spcAft>
+            </a:pPr>
+            <a:r>
+              <a:rPr sz="900" b="0" i="0">
+                <a:solidFill>
+                  <a:srgbClr val="6B7280"/>
+                </a:solidFill>
+                <a:latin typeface="Calibri"/>
+              </a:rPr>
+              <a:t>Boston Red Sox · Outfield Strategy</a:t>
+            </a:r>
+            <a:r>
+              <a:rPr sz="900" b="0" i="0">
+                <a:solidFill>
+                  <a:srgbClr val="6B7280"/>
+                </a:solidFill>
+                <a:latin typeface="Calibri"/>
+              </a:rPr>
+              <a:t>      Analysis: Statcast / FanGraphs / MLB Stats API · salary Spotrac · July 2026</a:t>
+            </a:r>
+          </a:p>
+        </p:txBody>
+      </p:sp>
+    </p:spTree>
+  </p:cSld>
+  <p:clrMapOvr>
+    <a:masterClrMapping/>
+  </p:clrMapOvr>
+</p:sld>
+</file>
+
+<file path=ppt/slides/slide11.xml><?xml version="1.0" encoding="utf-8"?>
+<p:sld xmlns:a="http://schemas.openxmlformats.org/drawingml/2006/main" xmlns:p="http://schemas.openxmlformats.org/presentationml/2006/main" xmlns:r="http://schemas.openxmlformats.org/officeDocument/2006/relationships">
+  <p:cSld>
+    <p:bg>
+      <p:bgPr>
+        <a:solidFill>
           <a:srgbClr val="0C2340"/>
         </a:solidFill>
         <a:effectLst/>
@@ -7049,7 +7824,7 @@
                 </a:solidFill>
                 <a:latin typeface="Calibri"/>
               </a:rPr>
-              <a:t>CONTEXT</a:t>
+              <a:t>THE REBOUND MATH</a:t>
             </a:r>
           </a:p>
         </p:txBody>
@@ -7091,14 +7866,14 @@
                 </a:solidFill>
                 <a:latin typeface="Cambria"/>
               </a:rPr>
-              <a:t>Aging doesn't explain the drop — regression and luck do</a:t>
+              <a:t>10,000 simulations: the rebound is likely — unless the erosion is real</a:t>
             </a:r>
           </a:p>
         </p:txBody>
       </p:sp>
       <p:pic>
         <p:nvPicPr>
-          <p:cNvPr id="4" name="Picture 3" descr="04_age_curve_overlay.png"/>
+          <p:cNvPr id="4" name="Picture 3" descr="09_rebound_probability.png"/>
           <p:cNvPicPr>
             <a:picLocks noChangeAspect="1"/>
           </p:cNvPicPr>
@@ -7112,8 +7887,8 @@
         </p:blipFill>
         <p:spPr>
           <a:xfrm>
-            <a:off x="2811779" y="1508760"/>
-            <a:ext cx="6583680" cy="4114800"/>
+            <a:off x="365760" y="1554480"/>
+            <a:ext cx="7589520" cy="3274998"/>
           </a:xfrm>
           <a:prstGeom prst="rect">
             <a:avLst/>
@@ -7128,7 +7903,249 @@
         </p:nvSpPr>
         <p:spPr>
           <a:xfrm>
-            <a:off x="566928" y="5806440"/>
+            <a:off x="8229600" y="1645920"/>
+            <a:ext cx="3383280" cy="320040"/>
+          </a:xfrm>
+          <a:prstGeom prst="rect">
+            <a:avLst/>
+          </a:prstGeom>
+          <a:noFill/>
+        </p:spPr>
+        <p:txBody>
+          <a:bodyPr wrap="square" anchor="t" lIns="0" rIns="0" tIns="0" bIns="0">
+            <a:spAutoFit/>
+          </a:bodyPr>
+          <a:lstStyle/>
+          <a:p>
+            <a:pPr algn="l">
+              <a:lnSpc>
+                <a:spcPct val="100000"/>
+              </a:lnSpc>
+              <a:spcAft>
+                <a:spcPts val="0"/>
+              </a:spcAft>
+            </a:pPr>
+            <a:r>
+              <a:rPr sz="1150" b="1" i="0">
+                <a:solidFill>
+                  <a:srgbClr val="6B7280"/>
+                </a:solidFill>
+                <a:latin typeface="Calibri"/>
+              </a:rPr>
+              <a:t>P(REST-OF-SEASON wRC+ ≥ 100)</a:t>
+            </a:r>
+          </a:p>
+        </p:txBody>
+      </p:sp>
+      <p:sp>
+        <p:nvSpPr>
+          <p:cNvPr id="6" name="TextBox 5"/>
+          <p:cNvSpPr txBox="1"/>
+          <p:nvPr/>
+        </p:nvSpPr>
+        <p:spPr>
+          <a:xfrm>
+            <a:off x="8229600" y="1965960"/>
+            <a:ext cx="3383280" cy="777240"/>
+          </a:xfrm>
+          <a:prstGeom prst="rect">
+            <a:avLst/>
+          </a:prstGeom>
+          <a:noFill/>
+        </p:spPr>
+        <p:txBody>
+          <a:bodyPr wrap="square" anchor="t" lIns="0" rIns="0" tIns="0" bIns="0">
+            <a:spAutoFit/>
+          </a:bodyPr>
+          <a:lstStyle/>
+          <a:p>
+            <a:pPr algn="l">
+              <a:lnSpc>
+                <a:spcPct val="100000"/>
+              </a:lnSpc>
+              <a:spcAft>
+                <a:spcPts val="200"/>
+              </a:spcAft>
+            </a:pPr>
+            <a:r>
+              <a:rPr sz="3400" b="1" i="0">
+                <a:solidFill>
+                  <a:srgbClr val="2E7D32"/>
+                </a:solidFill>
+                <a:latin typeface="Cambria"/>
+              </a:rPr>
+              <a:t>69%</a:t>
+            </a:r>
+            <a:r>
+              <a:rPr sz="1250" b="0" i="0">
+                <a:solidFill>
+                  <a:srgbClr val="6B7280"/>
+                </a:solidFill>
+                <a:latin typeface="Calibri"/>
+              </a:rPr>
+              <a:t>  healthy prior</a:t>
+            </a:r>
+          </a:p>
+          <a:p>
+            <a:pPr algn="l">
+              <a:lnSpc>
+                <a:spcPct val="100000"/>
+              </a:lnSpc>
+              <a:spcAft>
+                <a:spcPts val="200"/>
+              </a:spcAft>
+            </a:pPr>
+            <a:r>
+              <a:rPr sz="3400" b="1" i="0">
+                <a:solidFill>
+                  <a:srgbClr val="BD3039"/>
+                </a:solidFill>
+                <a:latin typeface="Cambria"/>
+              </a:rPr>
+              <a:t>47%</a:t>
+            </a:r>
+            <a:r>
+              <a:rPr sz="1250" b="0" i="0">
+                <a:solidFill>
+                  <a:srgbClr val="6B7280"/>
+                </a:solidFill>
+                <a:latin typeface="Calibri"/>
+              </a:rPr>
+              <a:t>  erosion-blended</a:t>
+            </a:r>
+          </a:p>
+        </p:txBody>
+      </p:sp>
+      <p:sp>
+        <p:nvSpPr>
+          <p:cNvPr id="7" name="TextBox 6"/>
+          <p:cNvSpPr txBox="1"/>
+          <p:nvPr/>
+        </p:nvSpPr>
+        <p:spPr>
+          <a:xfrm>
+            <a:off x="8229600" y="3520440"/>
+            <a:ext cx="3383280" cy="320040"/>
+          </a:xfrm>
+          <a:prstGeom prst="rect">
+            <a:avLst/>
+          </a:prstGeom>
+          <a:noFill/>
+        </p:spPr>
+        <p:txBody>
+          <a:bodyPr wrap="square" anchor="t" lIns="0" rIns="0" tIns="0" bIns="0">
+            <a:spAutoFit/>
+          </a:bodyPr>
+          <a:lstStyle/>
+          <a:p>
+            <a:pPr algn="l">
+              <a:lnSpc>
+                <a:spcPct val="100000"/>
+              </a:lnSpc>
+              <a:spcAft>
+                <a:spcPts val="0"/>
+              </a:spcAft>
+            </a:pPr>
+            <a:r>
+              <a:rPr sz="1150" b="1" i="0">
+                <a:solidFill>
+                  <a:srgbClr val="6B7280"/>
+                </a:solidFill>
+                <a:latin typeface="Calibri"/>
+              </a:rPr>
+              <a:t>EXPECTED OFFSEASON TRADE VALUE</a:t>
+            </a:r>
+          </a:p>
+        </p:txBody>
+      </p:sp>
+      <p:sp>
+        <p:nvSpPr>
+          <p:cNvPr id="8" name="TextBox 7"/>
+          <p:cNvSpPr txBox="1"/>
+          <p:nvPr/>
+        </p:nvSpPr>
+        <p:spPr>
+          <a:xfrm>
+            <a:off x="8229600" y="3840480"/>
+            <a:ext cx="3383280" cy="731520"/>
+          </a:xfrm>
+          <a:prstGeom prst="rect">
+            <a:avLst/>
+          </a:prstGeom>
+          <a:noFill/>
+        </p:spPr>
+        <p:txBody>
+          <a:bodyPr wrap="square" anchor="t" lIns="0" rIns="0" tIns="0" bIns="0">
+            <a:spAutoFit/>
+          </a:bodyPr>
+          <a:lstStyle/>
+          <a:p>
+            <a:pPr algn="l">
+              <a:lnSpc>
+                <a:spcPct val="105000"/>
+              </a:lnSpc>
+              <a:spcAft>
+                <a:spcPts val="200"/>
+              </a:spcAft>
+            </a:pPr>
+            <a:r>
+              <a:rPr sz="2400" b="1" i="0">
+                <a:solidFill>
+                  <a:srgbClr val="0C2340"/>
+                </a:solidFill>
+                <a:latin typeface="Cambria"/>
+              </a:rPr>
+              <a:t>$22M</a:t>
+            </a:r>
+            <a:r>
+              <a:rPr sz="1300" b="0" i="0">
+                <a:solidFill>
+                  <a:srgbClr val="6B7280"/>
+                </a:solidFill>
+                <a:latin typeface="Calibri"/>
+              </a:rPr>
+              <a:t> vs </a:t>
+            </a:r>
+            <a:r>
+              <a:rPr sz="2400" b="1" i="0">
+                <a:solidFill>
+                  <a:srgbClr val="0C2340"/>
+                </a:solidFill>
+                <a:latin typeface="Cambria"/>
+              </a:rPr>
+              <a:t>$18M</a:t>
+            </a:r>
+          </a:p>
+          <a:p>
+            <a:pPr algn="l">
+              <a:lnSpc>
+                <a:spcPct val="105000"/>
+              </a:lnSpc>
+              <a:spcAft>
+                <a:spcPts val="200"/>
+              </a:spcAft>
+            </a:pPr>
+            <a:r>
+              <a:rPr sz="1150" b="0" i="0">
+                <a:solidFill>
+                  <a:srgbClr val="6B7280"/>
+                </a:solidFill>
+                <a:latin typeface="Calibri"/>
+              </a:rPr>
+              <a:t>either way, well above the ~$10M a July sale fetches</a:t>
+            </a:r>
+          </a:p>
+        </p:txBody>
+      </p:sp>
+      <p:sp>
+        <p:nvSpPr>
+          <p:cNvPr id="9" name="TextBox 8"/>
+          <p:cNvSpPr txBox="1"/>
+          <p:nvPr/>
+        </p:nvSpPr>
+        <p:spPr>
+          <a:xfrm>
+            <a:off x="566928" y="5623560"/>
             <a:ext cx="11064240" cy="640080"/>
           </a:xfrm>
           <a:prstGeom prst="rect">
@@ -7144,36 +8161,36 @@
           <a:p>
             <a:pPr algn="l">
               <a:lnSpc>
-                <a:spcPct val="110000"/>
+                <a:spcPct val="112000"/>
               </a:lnSpc>
               <a:spcAft>
                 <a:spcPts val="400"/>
               </a:spcAft>
             </a:pPr>
             <a:r>
-              <a:rPr sz="1400" b="0" i="0">
+              <a:rPr sz="1350" b="1" i="0">
+                <a:solidFill>
+                  <a:srgbClr val="BD3039"/>
+                </a:solidFill>
+                <a:latin typeface="Calibri"/>
+              </a:rPr>
+              <a:t>The honest line: </a:t>
+            </a:r>
+            <a:r>
+              <a:rPr sz="1350" b="0" i="0">
                 <a:solidFill>
                   <a:srgbClr val="20232A"/>
                 </a:solidFill>
                 <a:latin typeface="Calibri"/>
               </a:rPr>
-              <a:t>2024 → 2026 wRC+ fell ~70 points; a normal age 27→29 curve predicts only ~7. </a:t>
-            </a:r>
-            <a:r>
-              <a:rPr sz="1400" b="1" i="0">
-                <a:solidFill>
-                  <a:srgbClr val="0C2340"/>
-                </a:solidFill>
-                <a:latin typeface="Calibri"/>
-              </a:rPr>
-              <a:t>The gap is mean-reversion from an inflated peak plus a 2026 bad-luck tail — not skill cliff.</a:t>
-            </a:r>
-          </a:p>
-        </p:txBody>
-      </p:sp>
-      <p:sp>
-        <p:nvSpPr>
-          <p:cNvPr id="6" name="TextBox 5"/>
+              <a:t>the 22-point probability gap is the price of the worse chase / whiff / hard-hit rates. Hold-through-2026 survives the erosion stress test — but with less confidence in the rebound narrative itself.</a:t>
+            </a:r>
+          </a:p>
+        </p:txBody>
+      </p:sp>
+      <p:sp>
+        <p:nvSpPr>
+          <p:cNvPr id="10" name="TextBox 9"/>
           <p:cNvSpPr txBox="1"/>
           <p:nvPr/>
         </p:nvSpPr>
@@ -7285,7 +8302,7 @@
                 </a:solidFill>
                 <a:latin typeface="Calibri"/>
               </a:rPr>
-              <a:t>WHAT TO GET BACK</a:t>
+              <a:t>CONTEXT</a:t>
             </a:r>
           </a:p>
         </p:txBody>
@@ -7327,20 +8344,44 @@
                 </a:solidFill>
                 <a:latin typeface="Cambria"/>
               </a:rPr>
-              <a:t>Pitching is the strength — spend the surplus on offense</a:t>
-            </a:r>
-          </a:p>
-        </p:txBody>
-      </p:sp>
-      <p:sp>
-        <p:nvSpPr>
-          <p:cNvPr id="4" name="TextBox 3"/>
-          <p:cNvSpPr txBox="1"/>
-          <p:nvPr/>
-        </p:nvSpPr>
-        <p:spPr>
-          <a:xfrm>
-            <a:off x="566928" y="1572768"/>
+              <a:t>Aging doesn't explain the drop — regression and luck do</a:t>
+            </a:r>
+          </a:p>
+        </p:txBody>
+      </p:sp>
+      <p:pic>
+        <p:nvPicPr>
+          <p:cNvPr id="4" name="Picture 3" descr="04_age_curve_overlay.png"/>
+          <p:cNvPicPr>
+            <a:picLocks noChangeAspect="1"/>
+          </p:cNvPicPr>
+          <p:nvPr/>
+        </p:nvPicPr>
+        <p:blipFill>
+          <a:blip r:embed="rId2"/>
+          <a:stretch>
+            <a:fillRect/>
+          </a:stretch>
+        </p:blipFill>
+        <p:spPr>
+          <a:xfrm>
+            <a:off x="2811779" y="1508760"/>
+            <a:ext cx="6583680" cy="4114800"/>
+          </a:xfrm>
+          <a:prstGeom prst="rect">
+            <a:avLst/>
+          </a:prstGeom>
+        </p:spPr>
+      </p:pic>
+      <p:sp>
+        <p:nvSpPr>
+          <p:cNvPr id="5" name="TextBox 4"/>
+          <p:cNvSpPr txBox="1"/>
+          <p:nvPr/>
+        </p:nvSpPr>
+        <p:spPr>
+          <a:xfrm>
+            <a:off x="566928" y="5806440"/>
             <a:ext cx="11064240" cy="640080"/>
           </a:xfrm>
           <a:prstGeom prst="rect">
@@ -7356,633 +8397,36 @@
           <a:p>
             <a:pPr algn="l">
               <a:lnSpc>
-                <a:spcPct val="112000"/>
+                <a:spcPct val="110000"/>
               </a:lnSpc>
               <a:spcAft>
                 <a:spcPts val="400"/>
               </a:spcAft>
             </a:pPr>
             <a:r>
-              <a:rPr sz="1450" b="0" i="0">
+              <a:rPr sz="1400" b="0" i="0">
                 <a:solidFill>
                   <a:srgbClr val="20232A"/>
                 </a:solidFill>
                 <a:latin typeface="Calibri"/>
               </a:rPr>
-              <a:t>With a top-10 rotation (3.76 ERA) already carrying the club, trading bats for arms is backwards. Convert the outfield surplus into what's thin:</a:t>
-            </a:r>
-          </a:p>
-        </p:txBody>
-      </p:sp>
-      <p:sp>
-        <p:nvSpPr>
-          <p:cNvPr id="5" name="Rounded Rectangle 4"/>
-          <p:cNvSpPr/>
-          <p:nvPr/>
-        </p:nvSpPr>
-        <p:spPr>
-          <a:xfrm>
-            <a:off x="566928" y="2468880"/>
-            <a:ext cx="3502152" cy="2514600"/>
-          </a:xfrm>
-          <a:prstGeom prst="roundRect">
-            <a:avLst>
-              <a:gd name="adj" fmla="val 8000"/>
-            </a:avLst>
-          </a:prstGeom>
-          <a:solidFill>
-            <a:srgbClr val="FFFFFF"/>
-          </a:solidFill>
-          <a:ln w="12700">
-            <a:solidFill>
-              <a:srgbClr val="D7DAE0"/>
-            </a:solidFill>
-          </a:ln>
-          <a:effectLst/>
-        </p:spPr>
-        <p:style>
-          <a:lnRef idx="1">
-            <a:schemeClr val="accent1"/>
-          </a:lnRef>
-          <a:fillRef idx="3">
-            <a:schemeClr val="accent1"/>
-          </a:fillRef>
-          <a:effectRef idx="2">
-            <a:schemeClr val="accent1"/>
-          </a:effectRef>
-          <a:fontRef idx="minor">
-            <a:schemeClr val="lt1"/>
-          </a:fontRef>
-        </p:style>
-        <p:txBody>
-          <a:bodyPr rtlCol="0" anchor="ctr"/>
-          <a:lstStyle/>
-          <a:p>
-            <a:pPr algn="ctr"/>
-          </a:p>
-        </p:txBody>
-      </p:sp>
-      <p:sp>
-        <p:nvSpPr>
-          <p:cNvPr id="6" name="Oval 5"/>
-          <p:cNvSpPr/>
-          <p:nvPr/>
-        </p:nvSpPr>
-        <p:spPr>
-          <a:xfrm>
-            <a:off x="841247" y="2724912"/>
-            <a:ext cx="384048" cy="384048"/>
-          </a:xfrm>
-          <a:prstGeom prst="ellipse">
-            <a:avLst/>
-          </a:prstGeom>
-          <a:solidFill>
-            <a:srgbClr val="2E7D32"/>
-          </a:solidFill>
-          <a:ln>
-            <a:noFill/>
-          </a:ln>
-          <a:effectLst/>
-        </p:spPr>
-        <p:style>
-          <a:lnRef idx="1">
-            <a:schemeClr val="accent1"/>
-          </a:lnRef>
-          <a:fillRef idx="3">
-            <a:schemeClr val="accent1"/>
-          </a:fillRef>
-          <a:effectRef idx="2">
-            <a:schemeClr val="accent1"/>
-          </a:effectRef>
-          <a:fontRef idx="minor">
-            <a:schemeClr val="lt1"/>
-          </a:fontRef>
-        </p:style>
-        <p:txBody>
-          <a:bodyPr rtlCol="0" anchor="ctr" wrap="none"/>
-          <a:lstStyle/>
-          <a:p>
-            <a:pPr algn="ctr"/>
-            <a:r>
-              <a:rPr sz="1600" b="1">
-                <a:solidFill>
-                  <a:srgbClr val="FFFFFF"/>
-                </a:solidFill>
-                <a:latin typeface="Cambria"/>
-              </a:rPr>
-              <a:t>1</a:t>
-            </a:r>
-          </a:p>
-        </p:txBody>
-      </p:sp>
-      <p:sp>
-        <p:nvSpPr>
-          <p:cNvPr id="7" name="TextBox 6"/>
-          <p:cNvSpPr txBox="1"/>
-          <p:nvPr/>
-        </p:nvSpPr>
-        <p:spPr>
-          <a:xfrm>
-            <a:off x="841247" y="3310128"/>
-            <a:ext cx="2999232" cy="411480"/>
-          </a:xfrm>
-          <a:prstGeom prst="rect">
-            <a:avLst/>
-          </a:prstGeom>
-          <a:noFill/>
-        </p:spPr>
-        <p:txBody>
-          <a:bodyPr wrap="square" anchor="t" lIns="0" rIns="0" tIns="0" bIns="0">
-            <a:spAutoFit/>
-          </a:bodyPr>
-          <a:lstStyle/>
-          <a:p>
-            <a:pPr algn="l">
-              <a:lnSpc>
-                <a:spcPct val="100000"/>
-              </a:lnSpc>
-              <a:spcAft>
-                <a:spcPts val="0"/>
-              </a:spcAft>
-            </a:pPr>
-            <a:r>
-              <a:rPr sz="1600" b="1" i="0">
+              <a:t>2024 → 2026 wRC+ fell ~70 points; a normal age 27→29 curve predicts only ~7. </a:t>
+            </a:r>
+            <a:r>
+              <a:rPr sz="1400" b="1" i="0">
                 <a:solidFill>
                   <a:srgbClr val="0C2340"/>
                 </a:solidFill>
-                <a:latin typeface="Cambria"/>
-              </a:rPr>
-              <a:t>Controllable bats</a:t>
-            </a:r>
-          </a:p>
-        </p:txBody>
-      </p:sp>
-      <p:sp>
-        <p:nvSpPr>
-          <p:cNvPr id="8" name="TextBox 7"/>
-          <p:cNvSpPr txBox="1"/>
-          <p:nvPr/>
-        </p:nvSpPr>
-        <p:spPr>
-          <a:xfrm>
-            <a:off x="841247" y="3767328"/>
-            <a:ext cx="2999232" cy="1097280"/>
-          </a:xfrm>
-          <a:prstGeom prst="rect">
-            <a:avLst/>
-          </a:prstGeom>
-          <a:noFill/>
-        </p:spPr>
-        <p:txBody>
-          <a:bodyPr wrap="square" anchor="t" lIns="0" rIns="0" tIns="0" bIns="0">
-            <a:spAutoFit/>
-          </a:bodyPr>
-          <a:lstStyle/>
-          <a:p>
-            <a:pPr algn="l">
-              <a:lnSpc>
-                <a:spcPct val="110000"/>
-              </a:lnSpc>
-              <a:spcAft>
-                <a:spcPts val="400"/>
-              </a:spcAft>
-            </a:pPr>
-            <a:r>
-              <a:rPr sz="1280" b="0" i="0">
-                <a:solidFill>
-                  <a:srgbClr val="6B7280"/>
-                </a:solidFill>
-                <a:latin typeface="Calibri"/>
-              </a:rPr>
-              <a:t>Young, cost-controlled position players to fix an inconsistent lineup and lengthen it around the core.</a:t>
-            </a:r>
-          </a:p>
-        </p:txBody>
-      </p:sp>
-      <p:sp>
-        <p:nvSpPr>
-          <p:cNvPr id="9" name="Rounded Rectangle 8"/>
-          <p:cNvSpPr/>
-          <p:nvPr/>
-        </p:nvSpPr>
-        <p:spPr>
-          <a:xfrm>
-            <a:off x="4352544" y="2468880"/>
-            <a:ext cx="3502152" cy="2514600"/>
-          </a:xfrm>
-          <a:prstGeom prst="roundRect">
-            <a:avLst>
-              <a:gd name="adj" fmla="val 8000"/>
-            </a:avLst>
-          </a:prstGeom>
-          <a:solidFill>
-            <a:srgbClr val="FFFFFF"/>
-          </a:solidFill>
-          <a:ln w="12700">
-            <a:solidFill>
-              <a:srgbClr val="D7DAE0"/>
-            </a:solidFill>
-          </a:ln>
-          <a:effectLst/>
-        </p:spPr>
-        <p:style>
-          <a:lnRef idx="1">
-            <a:schemeClr val="accent1"/>
-          </a:lnRef>
-          <a:fillRef idx="3">
-            <a:schemeClr val="accent1"/>
-          </a:fillRef>
-          <a:effectRef idx="2">
-            <a:schemeClr val="accent1"/>
-          </a:effectRef>
-          <a:fontRef idx="minor">
-            <a:schemeClr val="lt1"/>
-          </a:fontRef>
-        </p:style>
-        <p:txBody>
-          <a:bodyPr rtlCol="0" anchor="ctr"/>
-          <a:lstStyle/>
-          <a:p>
-            <a:pPr algn="ctr"/>
-          </a:p>
-        </p:txBody>
-      </p:sp>
-      <p:sp>
-        <p:nvSpPr>
-          <p:cNvPr id="10" name="Oval 9"/>
-          <p:cNvSpPr/>
-          <p:nvPr/>
-        </p:nvSpPr>
-        <p:spPr>
-          <a:xfrm>
-            <a:off x="4626864" y="2724912"/>
-            <a:ext cx="384048" cy="384048"/>
-          </a:xfrm>
-          <a:prstGeom prst="ellipse">
-            <a:avLst/>
-          </a:prstGeom>
-          <a:solidFill>
-            <a:srgbClr val="0C2340"/>
-          </a:solidFill>
-          <a:ln>
-            <a:noFill/>
-          </a:ln>
-          <a:effectLst/>
-        </p:spPr>
-        <p:style>
-          <a:lnRef idx="1">
-            <a:schemeClr val="accent1"/>
-          </a:lnRef>
-          <a:fillRef idx="3">
-            <a:schemeClr val="accent1"/>
-          </a:fillRef>
-          <a:effectRef idx="2">
-            <a:schemeClr val="accent1"/>
-          </a:effectRef>
-          <a:fontRef idx="minor">
-            <a:schemeClr val="lt1"/>
-          </a:fontRef>
-        </p:style>
-        <p:txBody>
-          <a:bodyPr rtlCol="0" anchor="ctr" wrap="none"/>
-          <a:lstStyle/>
-          <a:p>
-            <a:pPr algn="ctr"/>
-            <a:r>
-              <a:rPr sz="1600" b="1">
-                <a:solidFill>
-                  <a:srgbClr val="FFFFFF"/>
-                </a:solidFill>
-                <a:latin typeface="Cambria"/>
-              </a:rPr>
-              <a:t>2</a:t>
-            </a:r>
-          </a:p>
-        </p:txBody>
-      </p:sp>
-      <p:sp>
-        <p:nvSpPr>
-          <p:cNvPr id="11" name="TextBox 10"/>
-          <p:cNvSpPr txBox="1"/>
-          <p:nvPr/>
-        </p:nvSpPr>
-        <p:spPr>
-          <a:xfrm>
-            <a:off x="4626864" y="3310128"/>
-            <a:ext cx="2999232" cy="411480"/>
-          </a:xfrm>
-          <a:prstGeom prst="rect">
-            <a:avLst/>
-          </a:prstGeom>
-          <a:noFill/>
-        </p:spPr>
-        <p:txBody>
-          <a:bodyPr wrap="square" anchor="t" lIns="0" rIns="0" tIns="0" bIns="0">
-            <a:spAutoFit/>
-          </a:bodyPr>
-          <a:lstStyle/>
-          <a:p>
-            <a:pPr algn="l">
-              <a:lnSpc>
-                <a:spcPct val="100000"/>
-              </a:lnSpc>
-              <a:spcAft>
-                <a:spcPts val="0"/>
-              </a:spcAft>
-            </a:pPr>
-            <a:r>
-              <a:rPr sz="1600" b="1" i="0">
-                <a:solidFill>
-                  <a:srgbClr val="0C2340"/>
-                </a:solidFill>
-                <a:latin typeface="Cambria"/>
-              </a:rPr>
-              <a:t>Best talent / upside</a:t>
-            </a:r>
-          </a:p>
-        </p:txBody>
-      </p:sp>
-      <p:sp>
-        <p:nvSpPr>
-          <p:cNvPr id="12" name="TextBox 11"/>
-          <p:cNvSpPr txBox="1"/>
-          <p:nvPr/>
-        </p:nvSpPr>
-        <p:spPr>
-          <a:xfrm>
-            <a:off x="4626864" y="3767328"/>
-            <a:ext cx="2999232" cy="1097280"/>
-          </a:xfrm>
-          <a:prstGeom prst="rect">
-            <a:avLst/>
-          </a:prstGeom>
-          <a:noFill/>
-        </p:spPr>
-        <p:txBody>
-          <a:bodyPr wrap="square" anchor="t" lIns="0" rIns="0" tIns="0" bIns="0">
-            <a:spAutoFit/>
-          </a:bodyPr>
-          <a:lstStyle/>
-          <a:p>
-            <a:pPr algn="l">
-              <a:lnSpc>
-                <a:spcPct val="110000"/>
-              </a:lnSpc>
-              <a:spcAft>
-                <a:spcPts val="400"/>
-              </a:spcAft>
-            </a:pPr>
-            <a:r>
-              <a:rPr sz="1280" b="0" i="0">
-                <a:solidFill>
-                  <a:srgbClr val="6B7280"/>
-                </a:solidFill>
-                <a:latin typeface="Calibri"/>
-              </a:rPr>
-              <a:t>In a retool you take the best player, not the positional patch — prospects and MLB-ready youth over rentals.</a:t>
-            </a:r>
-          </a:p>
-        </p:txBody>
-      </p:sp>
-      <p:sp>
-        <p:nvSpPr>
-          <p:cNvPr id="13" name="Rounded Rectangle 12"/>
-          <p:cNvSpPr/>
-          <p:nvPr/>
-        </p:nvSpPr>
-        <p:spPr>
-          <a:xfrm>
-            <a:off x="8138159" y="2468880"/>
-            <a:ext cx="3502152" cy="2514600"/>
-          </a:xfrm>
-          <a:prstGeom prst="roundRect">
-            <a:avLst>
-              <a:gd name="adj" fmla="val 8000"/>
-            </a:avLst>
-          </a:prstGeom>
-          <a:solidFill>
-            <a:srgbClr val="FFFFFF"/>
-          </a:solidFill>
-          <a:ln w="12700">
-            <a:solidFill>
-              <a:srgbClr val="D7DAE0"/>
-            </a:solidFill>
-          </a:ln>
-          <a:effectLst/>
-        </p:spPr>
-        <p:style>
-          <a:lnRef idx="1">
-            <a:schemeClr val="accent1"/>
-          </a:lnRef>
-          <a:fillRef idx="3">
-            <a:schemeClr val="accent1"/>
-          </a:fillRef>
-          <a:effectRef idx="2">
-            <a:schemeClr val="accent1"/>
-          </a:effectRef>
-          <a:fontRef idx="minor">
-            <a:schemeClr val="lt1"/>
-          </a:fontRef>
-        </p:style>
-        <p:txBody>
-          <a:bodyPr rtlCol="0" anchor="ctr"/>
-          <a:lstStyle/>
-          <a:p>
-            <a:pPr algn="ctr"/>
-          </a:p>
-        </p:txBody>
-      </p:sp>
-      <p:sp>
-        <p:nvSpPr>
-          <p:cNvPr id="14" name="Oval 13"/>
-          <p:cNvSpPr/>
-          <p:nvPr/>
-        </p:nvSpPr>
-        <p:spPr>
-          <a:xfrm>
-            <a:off x="8412480" y="2724912"/>
-            <a:ext cx="384048" cy="384048"/>
-          </a:xfrm>
-          <a:prstGeom prst="ellipse">
-            <a:avLst/>
-          </a:prstGeom>
-          <a:solidFill>
-            <a:srgbClr val="B7892F"/>
-          </a:solidFill>
-          <a:ln>
-            <a:noFill/>
-          </a:ln>
-          <a:effectLst/>
-        </p:spPr>
-        <p:style>
-          <a:lnRef idx="1">
-            <a:schemeClr val="accent1"/>
-          </a:lnRef>
-          <a:fillRef idx="3">
-            <a:schemeClr val="accent1"/>
-          </a:fillRef>
-          <a:effectRef idx="2">
-            <a:schemeClr val="accent1"/>
-          </a:effectRef>
-          <a:fontRef idx="minor">
-            <a:schemeClr val="lt1"/>
-          </a:fontRef>
-        </p:style>
-        <p:txBody>
-          <a:bodyPr rtlCol="0" anchor="ctr" wrap="none"/>
-          <a:lstStyle/>
-          <a:p>
-            <a:pPr algn="ctr"/>
-            <a:r>
-              <a:rPr sz="1600" b="1">
-                <a:solidFill>
-                  <a:srgbClr val="FFFFFF"/>
-                </a:solidFill>
-                <a:latin typeface="Cambria"/>
-              </a:rPr>
-              <a:t>3</a:t>
-            </a:r>
-          </a:p>
-        </p:txBody>
-      </p:sp>
-      <p:sp>
-        <p:nvSpPr>
-          <p:cNvPr id="15" name="TextBox 14"/>
-          <p:cNvSpPr txBox="1"/>
-          <p:nvPr/>
-        </p:nvSpPr>
-        <p:spPr>
-          <a:xfrm>
-            <a:off x="8412480" y="3310128"/>
-            <a:ext cx="2999232" cy="411480"/>
-          </a:xfrm>
-          <a:prstGeom prst="rect">
-            <a:avLst/>
-          </a:prstGeom>
-          <a:noFill/>
-        </p:spPr>
-        <p:txBody>
-          <a:bodyPr wrap="square" anchor="t" lIns="0" rIns="0" tIns="0" bIns="0">
-            <a:spAutoFit/>
-          </a:bodyPr>
-          <a:lstStyle/>
-          <a:p>
-            <a:pPr algn="l">
-              <a:lnSpc>
-                <a:spcPct val="100000"/>
-              </a:lnSpc>
-              <a:spcAft>
-                <a:spcPts val="0"/>
-              </a:spcAft>
-            </a:pPr>
-            <a:r>
-              <a:rPr sz="1600" b="1" i="0">
-                <a:solidFill>
-                  <a:srgbClr val="0C2340"/>
-                </a:solidFill>
-                <a:latin typeface="Cambria"/>
-              </a:rPr>
-              <a:t>Salary relief</a:t>
-            </a:r>
-          </a:p>
-        </p:txBody>
-      </p:sp>
-      <p:sp>
-        <p:nvSpPr>
-          <p:cNvPr id="16" name="TextBox 15"/>
-          <p:cNvSpPr txBox="1"/>
-          <p:nvPr/>
-        </p:nvSpPr>
-        <p:spPr>
-          <a:xfrm>
-            <a:off x="8412480" y="3767328"/>
-            <a:ext cx="2999232" cy="1097280"/>
-          </a:xfrm>
-          <a:prstGeom prst="rect">
-            <a:avLst/>
-          </a:prstGeom>
-          <a:noFill/>
-        </p:spPr>
-        <p:txBody>
-          <a:bodyPr wrap="square" anchor="t" lIns="0" rIns="0" tIns="0" bIns="0">
-            <a:spAutoFit/>
-          </a:bodyPr>
-          <a:lstStyle/>
-          <a:p>
-            <a:pPr algn="l">
-              <a:lnSpc>
-                <a:spcPct val="110000"/>
-              </a:lnSpc>
-              <a:spcAft>
-                <a:spcPts val="400"/>
-              </a:spcAft>
-            </a:pPr>
-            <a:r>
-              <a:rPr sz="1280" b="0" i="0">
-                <a:solidFill>
-                  <a:srgbClr val="6B7280"/>
-                </a:solidFill>
-                <a:latin typeface="Calibri"/>
-              </a:rPr>
-              <a:t>Attach Yoshida money where possible; free payroll for the 2027 window.</a:t>
-            </a:r>
-          </a:p>
-        </p:txBody>
-      </p:sp>
-      <p:sp>
-        <p:nvSpPr>
-          <p:cNvPr id="17" name="TextBox 16"/>
-          <p:cNvSpPr txBox="1"/>
-          <p:nvPr/>
-        </p:nvSpPr>
-        <p:spPr>
-          <a:xfrm>
-            <a:off x="566928" y="5257800"/>
-            <a:ext cx="11064240" cy="457200"/>
-          </a:xfrm>
-          <a:prstGeom prst="rect">
-            <a:avLst/>
-          </a:prstGeom>
-          <a:noFill/>
-        </p:spPr>
-        <p:txBody>
-          <a:bodyPr wrap="square" anchor="t" lIns="0" rIns="0" tIns="0" bIns="0">
-            <a:spAutoFit/>
-          </a:bodyPr>
-          <a:lstStyle/>
-          <a:p>
-            <a:pPr algn="l">
-              <a:lnSpc>
-                <a:spcPct val="100000"/>
-              </a:lnSpc>
-              <a:spcAft>
-                <a:spcPts val="0"/>
-              </a:spcAft>
-            </a:pPr>
-            <a:r>
-              <a:rPr sz="1400" b="1" i="1">
-                <a:solidFill>
-                  <a:srgbClr val="0C2340"/>
-                </a:solidFill>
-                <a:latin typeface="Calibri"/>
-              </a:rPr>
-              <a:t>Keep the arms. Cash the outfield. </a:t>
-            </a:r>
-            <a:r>
-              <a:rPr sz="1400" b="0" i="1">
-                <a:solidFill>
-                  <a:srgbClr val="6B7280"/>
-                </a:solidFill>
-                <a:latin typeface="Calibri"/>
-              </a:rPr>
-              <a:t>Build the 2027 lineup, don't rent the 2026 one.</a:t>
-            </a:r>
-          </a:p>
-        </p:txBody>
-      </p:sp>
-      <p:sp>
-        <p:nvSpPr>
-          <p:cNvPr id="18" name="TextBox 17"/>
+                <a:latin typeface="Calibri"/>
+              </a:rPr>
+              <a:t>The gap is mean-reversion from an inflated peak plus a 2026 bad-luck tail — not skill cliff.</a:t>
+            </a:r>
+          </a:p>
+        </p:txBody>
+      </p:sp>
+      <p:sp>
+        <p:nvSpPr>
+          <p:cNvPr id="6" name="TextBox 5"/>
           <p:cNvSpPr txBox="1"/>
           <p:nvPr/>
         </p:nvSpPr>
@@ -8094,7 +8538,7 @@
                 </a:solidFill>
                 <a:latin typeface="Calibri"/>
               </a:rPr>
-              <a:t>THE MARKET</a:t>
+              <a:t>WHAT TO GET BACK</a:t>
             </a:r>
           </a:p>
         </p:txBody>
@@ -8136,96 +8580,76 @@
                 </a:solidFill>
                 <a:latin typeface="Cambria"/>
               </a:rPr>
-              <a:t>Who pays: contenders with a hole in the outfield</a:t>
-            </a:r>
-          </a:p>
-        </p:txBody>
-      </p:sp>
-      <p:pic>
-        <p:nvPicPr>
-          <p:cNvPr id="4" name="Picture 3" descr="08_trade_fit_targets.png"/>
-          <p:cNvPicPr>
-            <a:picLocks noChangeAspect="1"/>
-          </p:cNvPicPr>
-          <p:nvPr/>
-        </p:nvPicPr>
-        <p:blipFill>
-          <a:blip r:embed="rId2"/>
-          <a:stretch>
-            <a:fillRect/>
-          </a:stretch>
-        </p:blipFill>
-        <p:spPr>
-          <a:xfrm>
-            <a:off x="757237" y="1463040"/>
-            <a:ext cx="6715125" cy="4297680"/>
-          </a:xfrm>
-          <a:prstGeom prst="rect">
-            <a:avLst/>
-          </a:prstGeom>
-        </p:spPr>
-      </p:pic>
-      <p:sp>
-        <p:nvSpPr>
-          <p:cNvPr id="5" name="TextBox 4"/>
-          <p:cNvSpPr txBox="1"/>
-          <p:nvPr/>
-        </p:nvSpPr>
-        <p:spPr>
-          <a:xfrm>
-            <a:off x="8183879" y="1691640"/>
-            <a:ext cx="3657600" cy="457200"/>
-          </a:xfrm>
-          <a:prstGeom prst="rect">
-            <a:avLst/>
-          </a:prstGeom>
-          <a:noFill/>
-        </p:spPr>
-        <p:txBody>
-          <a:bodyPr wrap="square" anchor="t" lIns="0" rIns="0" tIns="0" bIns="0">
-            <a:spAutoFit/>
-          </a:bodyPr>
-          <a:lstStyle/>
-          <a:p>
-            <a:pPr algn="l">
-              <a:lnSpc>
-                <a:spcPct val="100000"/>
-              </a:lnSpc>
-              <a:spcAft>
-                <a:spcPts val="0"/>
-              </a:spcAft>
-            </a:pPr>
-            <a:r>
-              <a:rPr sz="1500" b="1" i="0">
-                <a:solidFill>
-                  <a:srgbClr val="0C2340"/>
-                </a:solidFill>
-                <a:latin typeface="Cambria"/>
-              </a:rPr>
-              <a:t>Best-fit buyers</a:t>
-            </a:r>
-          </a:p>
-        </p:txBody>
-      </p:sp>
-      <p:sp>
-        <p:nvSpPr>
-          <p:cNvPr id="6" name="Oval 5"/>
+              <a:t>Pitching is the strength — spend the surplus on offense</a:t>
+            </a:r>
+          </a:p>
+        </p:txBody>
+      </p:sp>
+      <p:sp>
+        <p:nvSpPr>
+          <p:cNvPr id="4" name="TextBox 3"/>
+          <p:cNvSpPr txBox="1"/>
+          <p:nvPr/>
+        </p:nvSpPr>
+        <p:spPr>
+          <a:xfrm>
+            <a:off x="566928" y="1572768"/>
+            <a:ext cx="11064240" cy="640080"/>
+          </a:xfrm>
+          <a:prstGeom prst="rect">
+            <a:avLst/>
+          </a:prstGeom>
+          <a:noFill/>
+        </p:spPr>
+        <p:txBody>
+          <a:bodyPr wrap="square" anchor="t" lIns="0" rIns="0" tIns="0" bIns="0">
+            <a:spAutoFit/>
+          </a:bodyPr>
+          <a:lstStyle/>
+          <a:p>
+            <a:pPr algn="l">
+              <a:lnSpc>
+                <a:spcPct val="112000"/>
+              </a:lnSpc>
+              <a:spcAft>
+                <a:spcPts val="400"/>
+              </a:spcAft>
+            </a:pPr>
+            <a:r>
+              <a:rPr sz="1450" b="0" i="0">
+                <a:solidFill>
+                  <a:srgbClr val="20232A"/>
+                </a:solidFill>
+                <a:latin typeface="Calibri"/>
+              </a:rPr>
+              <a:t>With a top-10 rotation (3.76 ERA) already carrying the club, trading bats for arms is backwards. Convert the outfield surplus into what's thin:</a:t>
+            </a:r>
+          </a:p>
+        </p:txBody>
+      </p:sp>
+      <p:sp>
+        <p:nvSpPr>
+          <p:cNvPr id="5" name="Rounded Rectangle 4"/>
           <p:cNvSpPr/>
           <p:nvPr/>
         </p:nvSpPr>
         <p:spPr>
           <a:xfrm>
-            <a:off x="8183879" y="2221991"/>
-            <a:ext cx="128016" cy="128016"/>
-          </a:xfrm>
-          <a:prstGeom prst="ellipse">
-            <a:avLst/>
+            <a:off x="566928" y="2468880"/>
+            <a:ext cx="3502152" cy="2514600"/>
+          </a:xfrm>
+          <a:prstGeom prst="roundRect">
+            <a:avLst>
+              <a:gd name="adj" fmla="val 8000"/>
+            </a:avLst>
           </a:prstGeom>
           <a:solidFill>
-            <a:srgbClr val="BD3039"/>
+            <a:srgbClr val="FFFFFF"/>
           </a:solidFill>
-          <a:ln>
-            <a:noFill/>
+          <a:ln w="12700">
+            <a:solidFill>
+              <a:srgbClr val="D7DAE0"/>
+            </a:solidFill>
           </a:ln>
           <a:effectLst/>
         </p:spPr>
@@ -8253,71 +8677,20 @@
       </p:sp>
       <p:sp>
         <p:nvSpPr>
-          <p:cNvPr id="7" name="TextBox 6"/>
-          <p:cNvSpPr txBox="1"/>
-          <p:nvPr/>
-        </p:nvSpPr>
-        <p:spPr>
-          <a:xfrm>
-            <a:off x="8439911" y="2194560"/>
-            <a:ext cx="3566160" cy="457200"/>
-          </a:xfrm>
-          <a:prstGeom prst="rect">
-            <a:avLst/>
-          </a:prstGeom>
-          <a:noFill/>
-        </p:spPr>
-        <p:txBody>
-          <a:bodyPr wrap="square" anchor="t" lIns="0" rIns="0" tIns="0" bIns="0">
-            <a:spAutoFit/>
-          </a:bodyPr>
-          <a:lstStyle/>
-          <a:p>
-            <a:pPr algn="l">
-              <a:lnSpc>
-                <a:spcPct val="100000"/>
-              </a:lnSpc>
-              <a:spcAft>
-                <a:spcPts val="0"/>
-              </a:spcAft>
-            </a:pPr>
-            <a:r>
-              <a:rPr sz="1400" b="1" i="0">
-                <a:solidFill>
-                  <a:srgbClr val="0C2340"/>
-                </a:solidFill>
-                <a:latin typeface="Calibri"/>
-              </a:rPr>
-              <a:t>Phillies  </a:t>
-            </a:r>
-            <a:r>
-              <a:rPr sz="1200" b="0" i="0">
-                <a:solidFill>
-                  <a:srgbClr val="6B7280"/>
-                </a:solidFill>
-                <a:latin typeface="Calibri"/>
-              </a:rPr>
-              <a:t>contender, 88 OF wRC+</a:t>
-            </a:r>
-          </a:p>
-        </p:txBody>
-      </p:sp>
-      <p:sp>
-        <p:nvSpPr>
-          <p:cNvPr id="8" name="Oval 7"/>
+          <p:cNvPr id="6" name="Oval 5"/>
           <p:cNvSpPr/>
           <p:nvPr/>
         </p:nvSpPr>
         <p:spPr>
           <a:xfrm>
-            <a:off x="8183879" y="2788920"/>
-            <a:ext cx="128016" cy="128016"/>
+            <a:off x="841247" y="2724912"/>
+            <a:ext cx="384048" cy="384048"/>
           </a:xfrm>
           <a:prstGeom prst="ellipse">
             <a:avLst/>
           </a:prstGeom>
           <a:solidFill>
-            <a:srgbClr val="BD3039"/>
+            <a:srgbClr val="2E7D32"/>
           </a:solidFill>
           <a:ln>
             <a:noFill/>
@@ -8339,23 +8712,32 @@
           </a:fontRef>
         </p:style>
         <p:txBody>
-          <a:bodyPr rtlCol="0" anchor="ctr"/>
+          <a:bodyPr rtlCol="0" anchor="ctr" wrap="none"/>
           <a:lstStyle/>
           <a:p>
             <a:pPr algn="ctr"/>
-          </a:p>
-        </p:txBody>
-      </p:sp>
-      <p:sp>
-        <p:nvSpPr>
-          <p:cNvPr id="9" name="TextBox 8"/>
-          <p:cNvSpPr txBox="1"/>
-          <p:nvPr/>
-        </p:nvSpPr>
-        <p:spPr>
-          <a:xfrm>
-            <a:off x="8439911" y="2761488"/>
-            <a:ext cx="3566160" cy="457200"/>
+            <a:r>
+              <a:rPr sz="1600" b="1">
+                <a:solidFill>
+                  <a:srgbClr val="FFFFFF"/>
+                </a:solidFill>
+                <a:latin typeface="Cambria"/>
+              </a:rPr>
+              <a:t>1</a:t>
+            </a:r>
+          </a:p>
+        </p:txBody>
+      </p:sp>
+      <p:sp>
+        <p:nvSpPr>
+          <p:cNvPr id="7" name="TextBox 6"/>
+          <p:cNvSpPr txBox="1"/>
+          <p:nvPr/>
+        </p:nvSpPr>
+        <p:spPr>
+          <a:xfrm>
+            <a:off x="841247" y="3310128"/>
+            <a:ext cx="2999232" cy="411480"/>
           </a:xfrm>
           <a:prstGeom prst="rect">
             <a:avLst/>
@@ -8377,45 +8759,82 @@
               </a:spcAft>
             </a:pPr>
             <a:r>
-              <a:rPr sz="1400" b="1" i="0">
+              <a:rPr sz="1600" b="1" i="0">
                 <a:solidFill>
                   <a:srgbClr val="0C2340"/>
                 </a:solidFill>
-                <a:latin typeface="Calibri"/>
-              </a:rPr>
-              <a:t>Rays  </a:t>
-            </a:r>
-            <a:r>
-              <a:rPr sz="1200" b="0" i="0">
+                <a:latin typeface="Cambria"/>
+              </a:rPr>
+              <a:t>Controllable bats</a:t>
+            </a:r>
+          </a:p>
+        </p:txBody>
+      </p:sp>
+      <p:sp>
+        <p:nvSpPr>
+          <p:cNvPr id="8" name="TextBox 7"/>
+          <p:cNvSpPr txBox="1"/>
+          <p:nvPr/>
+        </p:nvSpPr>
+        <p:spPr>
+          <a:xfrm>
+            <a:off x="841247" y="3767328"/>
+            <a:ext cx="2999232" cy="1097280"/>
+          </a:xfrm>
+          <a:prstGeom prst="rect">
+            <a:avLst/>
+          </a:prstGeom>
+          <a:noFill/>
+        </p:spPr>
+        <p:txBody>
+          <a:bodyPr wrap="square" anchor="t" lIns="0" rIns="0" tIns="0" bIns="0">
+            <a:spAutoFit/>
+          </a:bodyPr>
+          <a:lstStyle/>
+          <a:p>
+            <a:pPr algn="l">
+              <a:lnSpc>
+                <a:spcPct val="110000"/>
+              </a:lnSpc>
+              <a:spcAft>
+                <a:spcPts val="400"/>
+              </a:spcAft>
+            </a:pPr>
+            <a:r>
+              <a:rPr sz="1280" b="0" i="0">
                 <a:solidFill>
                   <a:srgbClr val="6B7280"/>
                 </a:solidFill>
                 <a:latin typeface="Calibri"/>
               </a:rPr>
-              <a:t>.602, weak OF</a:t>
-            </a:r>
-          </a:p>
-        </p:txBody>
-      </p:sp>
-      <p:sp>
-        <p:nvSpPr>
-          <p:cNvPr id="10" name="Oval 9"/>
+              <a:t>Young, cost-controlled position players to fix an inconsistent lineup and lengthen it around the core.</a:t>
+            </a:r>
+          </a:p>
+        </p:txBody>
+      </p:sp>
+      <p:sp>
+        <p:nvSpPr>
+          <p:cNvPr id="9" name="Rounded Rectangle 8"/>
           <p:cNvSpPr/>
           <p:nvPr/>
         </p:nvSpPr>
         <p:spPr>
           <a:xfrm>
-            <a:off x="8183879" y="3355847"/>
-            <a:ext cx="128016" cy="128016"/>
-          </a:xfrm>
-          <a:prstGeom prst="ellipse">
-            <a:avLst/>
+            <a:off x="4352544" y="2468880"/>
+            <a:ext cx="3502152" cy="2514600"/>
+          </a:xfrm>
+          <a:prstGeom prst="roundRect">
+            <a:avLst>
+              <a:gd name="adj" fmla="val 8000"/>
+            </a:avLst>
           </a:prstGeom>
           <a:solidFill>
-            <a:srgbClr val="BD3039"/>
+            <a:srgbClr val="FFFFFF"/>
           </a:solidFill>
-          <a:ln>
-            <a:noFill/>
+          <a:ln w="12700">
+            <a:solidFill>
+              <a:srgbClr val="D7DAE0"/>
+            </a:solidFill>
           </a:ln>
           <a:effectLst/>
         </p:spPr>
@@ -8443,71 +8862,20 @@
       </p:sp>
       <p:sp>
         <p:nvSpPr>
-          <p:cNvPr id="11" name="TextBox 10"/>
-          <p:cNvSpPr txBox="1"/>
-          <p:nvPr/>
-        </p:nvSpPr>
-        <p:spPr>
-          <a:xfrm>
-            <a:off x="8439911" y="3328415"/>
-            <a:ext cx="3566160" cy="457200"/>
-          </a:xfrm>
-          <a:prstGeom prst="rect">
-            <a:avLst/>
-          </a:prstGeom>
-          <a:noFill/>
-        </p:spPr>
-        <p:txBody>
-          <a:bodyPr wrap="square" anchor="t" lIns="0" rIns="0" tIns="0" bIns="0">
-            <a:spAutoFit/>
-          </a:bodyPr>
-          <a:lstStyle/>
-          <a:p>
-            <a:pPr algn="l">
-              <a:lnSpc>
-                <a:spcPct val="100000"/>
-              </a:lnSpc>
-              <a:spcAft>
-                <a:spcPts val="0"/>
-              </a:spcAft>
-            </a:pPr>
-            <a:r>
-              <a:rPr sz="1400" b="1" i="0">
-                <a:solidFill>
-                  <a:srgbClr val="0C2340"/>
-                </a:solidFill>
-                <a:latin typeface="Calibri"/>
-              </a:rPr>
-              <a:t>Marlins  </a:t>
-            </a:r>
-            <a:r>
-              <a:rPr sz="1200" b="0" i="0">
-                <a:solidFill>
-                  <a:srgbClr val="6B7280"/>
-                </a:solidFill>
-                <a:latin typeface="Calibri"/>
-              </a:rPr>
-              <a:t>in the hunt, thin OF</a:t>
-            </a:r>
-          </a:p>
-        </p:txBody>
-      </p:sp>
-      <p:sp>
-        <p:nvSpPr>
-          <p:cNvPr id="12" name="Oval 11"/>
+          <p:cNvPr id="10" name="Oval 9"/>
           <p:cNvSpPr/>
           <p:nvPr/>
         </p:nvSpPr>
         <p:spPr>
           <a:xfrm>
-            <a:off x="8183879" y="3922776"/>
-            <a:ext cx="128016" cy="128016"/>
+            <a:off x="4626864" y="2724912"/>
+            <a:ext cx="384048" cy="384048"/>
           </a:xfrm>
           <a:prstGeom prst="ellipse">
             <a:avLst/>
           </a:prstGeom>
           <a:solidFill>
-            <a:srgbClr val="BD3039"/>
+            <a:srgbClr val="0C2340"/>
           </a:solidFill>
           <a:ln>
             <a:noFill/>
@@ -8529,6 +8897,147 @@
           </a:fontRef>
         </p:style>
         <p:txBody>
+          <a:bodyPr rtlCol="0" anchor="ctr" wrap="none"/>
+          <a:lstStyle/>
+          <a:p>
+            <a:pPr algn="ctr"/>
+            <a:r>
+              <a:rPr sz="1600" b="1">
+                <a:solidFill>
+                  <a:srgbClr val="FFFFFF"/>
+                </a:solidFill>
+                <a:latin typeface="Cambria"/>
+              </a:rPr>
+              <a:t>2</a:t>
+            </a:r>
+          </a:p>
+        </p:txBody>
+      </p:sp>
+      <p:sp>
+        <p:nvSpPr>
+          <p:cNvPr id="11" name="TextBox 10"/>
+          <p:cNvSpPr txBox="1"/>
+          <p:nvPr/>
+        </p:nvSpPr>
+        <p:spPr>
+          <a:xfrm>
+            <a:off x="4626864" y="3310128"/>
+            <a:ext cx="2999232" cy="411480"/>
+          </a:xfrm>
+          <a:prstGeom prst="rect">
+            <a:avLst/>
+          </a:prstGeom>
+          <a:noFill/>
+        </p:spPr>
+        <p:txBody>
+          <a:bodyPr wrap="square" anchor="t" lIns="0" rIns="0" tIns="0" bIns="0">
+            <a:spAutoFit/>
+          </a:bodyPr>
+          <a:lstStyle/>
+          <a:p>
+            <a:pPr algn="l">
+              <a:lnSpc>
+                <a:spcPct val="100000"/>
+              </a:lnSpc>
+              <a:spcAft>
+                <a:spcPts val="0"/>
+              </a:spcAft>
+            </a:pPr>
+            <a:r>
+              <a:rPr sz="1600" b="1" i="0">
+                <a:solidFill>
+                  <a:srgbClr val="0C2340"/>
+                </a:solidFill>
+                <a:latin typeface="Cambria"/>
+              </a:rPr>
+              <a:t>Best talent / upside</a:t>
+            </a:r>
+          </a:p>
+        </p:txBody>
+      </p:sp>
+      <p:sp>
+        <p:nvSpPr>
+          <p:cNvPr id="12" name="TextBox 11"/>
+          <p:cNvSpPr txBox="1"/>
+          <p:nvPr/>
+        </p:nvSpPr>
+        <p:spPr>
+          <a:xfrm>
+            <a:off x="4626864" y="3767328"/>
+            <a:ext cx="2999232" cy="1097280"/>
+          </a:xfrm>
+          <a:prstGeom prst="rect">
+            <a:avLst/>
+          </a:prstGeom>
+          <a:noFill/>
+        </p:spPr>
+        <p:txBody>
+          <a:bodyPr wrap="square" anchor="t" lIns="0" rIns="0" tIns="0" bIns="0">
+            <a:spAutoFit/>
+          </a:bodyPr>
+          <a:lstStyle/>
+          <a:p>
+            <a:pPr algn="l">
+              <a:lnSpc>
+                <a:spcPct val="110000"/>
+              </a:lnSpc>
+              <a:spcAft>
+                <a:spcPts val="400"/>
+              </a:spcAft>
+            </a:pPr>
+            <a:r>
+              <a:rPr sz="1280" b="0" i="0">
+                <a:solidFill>
+                  <a:srgbClr val="6B7280"/>
+                </a:solidFill>
+                <a:latin typeface="Calibri"/>
+              </a:rPr>
+              <a:t>In a retool you take the best player, not the positional patch — prospects and MLB-ready youth over rentals.</a:t>
+            </a:r>
+          </a:p>
+        </p:txBody>
+      </p:sp>
+      <p:sp>
+        <p:nvSpPr>
+          <p:cNvPr id="13" name="Rounded Rectangle 12"/>
+          <p:cNvSpPr/>
+          <p:nvPr/>
+        </p:nvSpPr>
+        <p:spPr>
+          <a:xfrm>
+            <a:off x="8138159" y="2468880"/>
+            <a:ext cx="3502152" cy="2514600"/>
+          </a:xfrm>
+          <a:prstGeom prst="roundRect">
+            <a:avLst>
+              <a:gd name="adj" fmla="val 8000"/>
+            </a:avLst>
+          </a:prstGeom>
+          <a:solidFill>
+            <a:srgbClr val="FFFFFF"/>
+          </a:solidFill>
+          <a:ln w="12700">
+            <a:solidFill>
+              <a:srgbClr val="D7DAE0"/>
+            </a:solidFill>
+          </a:ln>
+          <a:effectLst/>
+        </p:spPr>
+        <p:style>
+          <a:lnRef idx="1">
+            <a:schemeClr val="accent1"/>
+          </a:lnRef>
+          <a:fillRef idx="3">
+            <a:schemeClr val="accent1"/>
+          </a:fillRef>
+          <a:effectRef idx="2">
+            <a:schemeClr val="accent1"/>
+          </a:effectRef>
+          <a:fontRef idx="minor">
+            <a:schemeClr val="lt1"/>
+          </a:fontRef>
+        </p:style>
+        <p:txBody>
           <a:bodyPr rtlCol="0" anchor="ctr"/>
           <a:lstStyle/>
           <a:p>
@@ -8538,14 +9047,67 @@
       </p:sp>
       <p:sp>
         <p:nvSpPr>
-          <p:cNvPr id="13" name="TextBox 12"/>
-          <p:cNvSpPr txBox="1"/>
-          <p:nvPr/>
-        </p:nvSpPr>
-        <p:spPr>
-          <a:xfrm>
-            <a:off x="8439911" y="3895344"/>
-            <a:ext cx="3566160" cy="457200"/>
+          <p:cNvPr id="14" name="Oval 13"/>
+          <p:cNvSpPr/>
+          <p:nvPr/>
+        </p:nvSpPr>
+        <p:spPr>
+          <a:xfrm>
+            <a:off x="8412480" y="2724912"/>
+            <a:ext cx="384048" cy="384048"/>
+          </a:xfrm>
+          <a:prstGeom prst="ellipse">
+            <a:avLst/>
+          </a:prstGeom>
+          <a:solidFill>
+            <a:srgbClr val="B7892F"/>
+          </a:solidFill>
+          <a:ln>
+            <a:noFill/>
+          </a:ln>
+          <a:effectLst/>
+        </p:spPr>
+        <p:style>
+          <a:lnRef idx="1">
+            <a:schemeClr val="accent1"/>
+          </a:lnRef>
+          <a:fillRef idx="3">
+            <a:schemeClr val="accent1"/>
+          </a:fillRef>
+          <a:effectRef idx="2">
+            <a:schemeClr val="accent1"/>
+          </a:effectRef>
+          <a:fontRef idx="minor">
+            <a:schemeClr val="lt1"/>
+          </a:fontRef>
+        </p:style>
+        <p:txBody>
+          <a:bodyPr rtlCol="0" anchor="ctr" wrap="none"/>
+          <a:lstStyle/>
+          <a:p>
+            <a:pPr algn="ctr"/>
+            <a:r>
+              <a:rPr sz="1600" b="1">
+                <a:solidFill>
+                  <a:srgbClr val="FFFFFF"/>
+                </a:solidFill>
+                <a:latin typeface="Cambria"/>
+              </a:rPr>
+              <a:t>3</a:t>
+            </a:r>
+          </a:p>
+        </p:txBody>
+      </p:sp>
+      <p:sp>
+        <p:nvSpPr>
+          <p:cNvPr id="15" name="TextBox 14"/>
+          <p:cNvSpPr txBox="1"/>
+          <p:nvPr/>
+        </p:nvSpPr>
+        <p:spPr>
+          <a:xfrm>
+            <a:off x="8412480" y="3310128"/>
+            <a:ext cx="2999232" cy="411480"/>
           </a:xfrm>
           <a:prstGeom prst="rect">
             <a:avLst/>
@@ -8567,89 +9129,113 @@
               </a:spcAft>
             </a:pPr>
             <a:r>
-              <a:rPr sz="1400" b="1" i="0">
+              <a:rPr sz="1600" b="1" i="0">
                 <a:solidFill>
                   <a:srgbClr val="0C2340"/>
                 </a:solidFill>
-                <a:latin typeface="Calibri"/>
-              </a:rPr>
-              <a:t>Guardians  </a:t>
-            </a:r>
-            <a:r>
-              <a:rPr sz="1200" b="0" i="0">
+                <a:latin typeface="Cambria"/>
+              </a:rPr>
+              <a:t>Salary relief</a:t>
+            </a:r>
+          </a:p>
+        </p:txBody>
+      </p:sp>
+      <p:sp>
+        <p:nvSpPr>
+          <p:cNvPr id="16" name="TextBox 15"/>
+          <p:cNvSpPr txBox="1"/>
+          <p:nvPr/>
+        </p:nvSpPr>
+        <p:spPr>
+          <a:xfrm>
+            <a:off x="8412480" y="3767328"/>
+            <a:ext cx="2999232" cy="1097280"/>
+          </a:xfrm>
+          <a:prstGeom prst="rect">
+            <a:avLst/>
+          </a:prstGeom>
+          <a:noFill/>
+        </p:spPr>
+        <p:txBody>
+          <a:bodyPr wrap="square" anchor="t" lIns="0" rIns="0" tIns="0" bIns="0">
+            <a:spAutoFit/>
+          </a:bodyPr>
+          <a:lstStyle/>
+          <a:p>
+            <a:pPr algn="l">
+              <a:lnSpc>
+                <a:spcPct val="110000"/>
+              </a:lnSpc>
+              <a:spcAft>
+                <a:spcPts val="400"/>
+              </a:spcAft>
+            </a:pPr>
+            <a:r>
+              <a:rPr sz="1280" b="0" i="0">
                 <a:solidFill>
                   <a:srgbClr val="6B7280"/>
                 </a:solidFill>
                 <a:latin typeface="Calibri"/>
               </a:rPr>
-              <a:t>contender, OF need</a:t>
-            </a:r>
-          </a:p>
-        </p:txBody>
-      </p:sp>
-      <p:sp>
-        <p:nvSpPr>
-          <p:cNvPr id="14" name="TextBox 13"/>
-          <p:cNvSpPr txBox="1"/>
-          <p:nvPr/>
-        </p:nvSpPr>
-        <p:spPr>
-          <a:xfrm>
-            <a:off x="8183879" y="4709160"/>
-            <a:ext cx="3657600" cy="1005840"/>
-          </a:xfrm>
-          <a:prstGeom prst="rect">
-            <a:avLst/>
-          </a:prstGeom>
-          <a:noFill/>
-        </p:spPr>
-        <p:txBody>
-          <a:bodyPr wrap="square" anchor="t" lIns="0" rIns="0" tIns="0" bIns="0">
-            <a:spAutoFit/>
-          </a:bodyPr>
-          <a:lstStyle/>
-          <a:p>
-            <a:pPr algn="l">
-              <a:lnSpc>
-                <a:spcPct val="112000"/>
-              </a:lnSpc>
-              <a:spcAft>
-                <a:spcPts val="400"/>
-              </a:spcAft>
-            </a:pPr>
-            <a:r>
-              <a:rPr sz="1250" b="0" i="0">
-                <a:solidFill>
-                  <a:srgbClr val="20232A"/>
-                </a:solidFill>
-                <a:latin typeface="Calibri"/>
-              </a:rPr>
-              <a:t>Trade a redundant bat to a team that needs one — and take back the </a:t>
-            </a:r>
-            <a:r>
-              <a:rPr sz="1250" b="1" i="0">
-                <a:solidFill>
-                  <a:srgbClr val="2E7D32"/>
-                </a:solidFill>
-                <a:latin typeface="Calibri"/>
-              </a:rPr>
-              <a:t>hitting/youth</a:t>
-            </a:r>
-            <a:r>
-              <a:rPr sz="1250" b="0" i="0">
-                <a:solidFill>
-                  <a:srgbClr val="20232A"/>
-                </a:solidFill>
-                <a:latin typeface="Calibri"/>
-              </a:rPr>
-              <a:t> Boston is short on.</a:t>
-            </a:r>
-          </a:p>
-        </p:txBody>
-      </p:sp>
-      <p:sp>
-        <p:nvSpPr>
-          <p:cNvPr id="15" name="TextBox 14"/>
+              <a:t>Attach Yoshida money where possible; free payroll for the 2027 window.</a:t>
+            </a:r>
+          </a:p>
+        </p:txBody>
+      </p:sp>
+      <p:sp>
+        <p:nvSpPr>
+          <p:cNvPr id="17" name="TextBox 16"/>
+          <p:cNvSpPr txBox="1"/>
+          <p:nvPr/>
+        </p:nvSpPr>
+        <p:spPr>
+          <a:xfrm>
+            <a:off x="566928" y="5257800"/>
+            <a:ext cx="11064240" cy="457200"/>
+          </a:xfrm>
+          <a:prstGeom prst="rect">
+            <a:avLst/>
+          </a:prstGeom>
+          <a:noFill/>
+        </p:spPr>
+        <p:txBody>
+          <a:bodyPr wrap="square" anchor="t" lIns="0" rIns="0" tIns="0" bIns="0">
+            <a:spAutoFit/>
+          </a:bodyPr>
+          <a:lstStyle/>
+          <a:p>
+            <a:pPr algn="l">
+              <a:lnSpc>
+                <a:spcPct val="100000"/>
+              </a:lnSpc>
+              <a:spcAft>
+                <a:spcPts val="0"/>
+              </a:spcAft>
+            </a:pPr>
+            <a:r>
+              <a:rPr sz="1400" b="1" i="1">
+                <a:solidFill>
+                  <a:srgbClr val="0C2340"/>
+                </a:solidFill>
+                <a:latin typeface="Calibri"/>
+              </a:rPr>
+              <a:t>Keep the arms. Cash the outfield. </a:t>
+            </a:r>
+            <a:r>
+              <a:rPr sz="1400" b="0" i="1">
+                <a:solidFill>
+                  <a:srgbClr val="6B7280"/>
+                </a:solidFill>
+                <a:latin typeface="Calibri"/>
+              </a:rPr>
+              <a:t>Build the 2027 lineup, don't rent the 2026 one.</a:t>
+            </a:r>
+          </a:p>
+        </p:txBody>
+      </p:sp>
+      <p:sp>
+        <p:nvSpPr>
+          <p:cNvPr id="18" name="TextBox 17"/>
           <p:cNvSpPr txBox="1"/>
           <p:nvPr/>
         </p:nvSpPr>
@@ -8761,7 +9347,7 @@
                 </a:solidFill>
                 <a:latin typeface="Calibri"/>
               </a:rPr>
-              <a:t>THE SEQUENCE</a:t>
+              <a:t>THE MARKET</a:t>
             </a:r>
           </a:p>
         </p:txBody>
@@ -8803,21 +9389,87 @@
                 </a:solidFill>
                 <a:latin typeface="Cambria"/>
               </a:rPr>
-              <a:t>Solve it this winter, from a position of strength</a:t>
-            </a:r>
-          </a:p>
-        </p:txBody>
-      </p:sp>
-      <p:sp>
-        <p:nvSpPr>
-          <p:cNvPr id="4" name="Oval 3"/>
+              <a:t>Who pays: contenders with a hole in the outfield</a:t>
+            </a:r>
+          </a:p>
+        </p:txBody>
+      </p:sp>
+      <p:pic>
+        <p:nvPicPr>
+          <p:cNvPr id="4" name="Picture 3" descr="08_trade_fit_targets.png"/>
+          <p:cNvPicPr>
+            <a:picLocks noChangeAspect="1"/>
+          </p:cNvPicPr>
+          <p:nvPr/>
+        </p:nvPicPr>
+        <p:blipFill>
+          <a:blip r:embed="rId2"/>
+          <a:stretch>
+            <a:fillRect/>
+          </a:stretch>
+        </p:blipFill>
+        <p:spPr>
+          <a:xfrm>
+            <a:off x="757237" y="1463040"/>
+            <a:ext cx="6715125" cy="4297680"/>
+          </a:xfrm>
+          <a:prstGeom prst="rect">
+            <a:avLst/>
+          </a:prstGeom>
+        </p:spPr>
+      </p:pic>
+      <p:sp>
+        <p:nvSpPr>
+          <p:cNvPr id="5" name="TextBox 4"/>
+          <p:cNvSpPr txBox="1"/>
+          <p:nvPr/>
+        </p:nvSpPr>
+        <p:spPr>
+          <a:xfrm>
+            <a:off x="8183879" y="1691640"/>
+            <a:ext cx="3657600" cy="457200"/>
+          </a:xfrm>
+          <a:prstGeom prst="rect">
+            <a:avLst/>
+          </a:prstGeom>
+          <a:noFill/>
+        </p:spPr>
+        <p:txBody>
+          <a:bodyPr wrap="square" anchor="t" lIns="0" rIns="0" tIns="0" bIns="0">
+            <a:spAutoFit/>
+          </a:bodyPr>
+          <a:lstStyle/>
+          <a:p>
+            <a:pPr algn="l">
+              <a:lnSpc>
+                <a:spcPct val="100000"/>
+              </a:lnSpc>
+              <a:spcAft>
+                <a:spcPts val="0"/>
+              </a:spcAft>
+            </a:pPr>
+            <a:r>
+              <a:rPr sz="1500" b="1" i="0">
+                <a:solidFill>
+                  <a:srgbClr val="0C2340"/>
+                </a:solidFill>
+                <a:latin typeface="Cambria"/>
+              </a:rPr>
+              <a:t>Best-fit buyers</a:t>
+            </a:r>
+          </a:p>
+        </p:txBody>
+      </p:sp>
+      <p:sp>
+        <p:nvSpPr>
+          <p:cNvPr id="6" name="Oval 5"/>
           <p:cNvSpPr/>
           <p:nvPr/>
         </p:nvSpPr>
         <p:spPr>
           <a:xfrm>
-            <a:off x="640080" y="1801368"/>
-            <a:ext cx="457200" cy="457200"/>
+            <a:off x="8183879" y="2221991"/>
+            <a:ext cx="128016" cy="128016"/>
           </a:xfrm>
           <a:prstGeom prst="ellipse">
             <a:avLst/>
@@ -8845,93 +9497,74 @@
           </a:fontRef>
         </p:style>
         <p:txBody>
-          <a:bodyPr rtlCol="0" anchor="ctr" wrap="none"/>
+          <a:bodyPr rtlCol="0" anchor="ctr"/>
           <a:lstStyle/>
           <a:p>
             <a:pPr algn="ctr"/>
-            <a:r>
-              <a:rPr sz="1800" b="1">
-                <a:solidFill>
-                  <a:srgbClr val="FFFFFF"/>
-                </a:solidFill>
-                <a:latin typeface="Cambria"/>
-              </a:rPr>
-              <a:t>1</a:t>
-            </a:r>
-          </a:p>
-        </p:txBody>
-      </p:sp>
-      <p:sp>
-        <p:nvSpPr>
-          <p:cNvPr id="5" name="TextBox 4"/>
-          <p:cNvSpPr txBox="1"/>
-          <p:nvPr/>
-        </p:nvSpPr>
-        <p:spPr>
-          <a:xfrm>
-            <a:off x="1280160" y="1783080"/>
-            <a:ext cx="6126480" cy="1005840"/>
-          </a:xfrm>
-          <a:prstGeom prst="rect">
-            <a:avLst/>
-          </a:prstGeom>
-          <a:noFill/>
-        </p:spPr>
-        <p:txBody>
-          <a:bodyPr wrap="square" anchor="t" lIns="0" rIns="0" tIns="0" bIns="0">
-            <a:spAutoFit/>
-          </a:bodyPr>
-          <a:lstStyle/>
-          <a:p>
-            <a:pPr algn="l">
-              <a:lnSpc>
-                <a:spcPct val="108000"/>
-              </a:lnSpc>
-              <a:spcAft>
-                <a:spcPts val="200"/>
-              </a:spcAft>
-            </a:pPr>
-            <a:r>
-              <a:rPr sz="1700" b="1" i="0">
+          </a:p>
+        </p:txBody>
+      </p:sp>
+      <p:sp>
+        <p:nvSpPr>
+          <p:cNvPr id="7" name="TextBox 6"/>
+          <p:cNvSpPr txBox="1"/>
+          <p:nvPr/>
+        </p:nvSpPr>
+        <p:spPr>
+          <a:xfrm>
+            <a:off x="8439911" y="2194560"/>
+            <a:ext cx="3566160" cy="457200"/>
+          </a:xfrm>
+          <a:prstGeom prst="rect">
+            <a:avLst/>
+          </a:prstGeom>
+          <a:noFill/>
+        </p:spPr>
+        <p:txBody>
+          <a:bodyPr wrap="square" anchor="t" lIns="0" rIns="0" tIns="0" bIns="0">
+            <a:spAutoFit/>
+          </a:bodyPr>
+          <a:lstStyle/>
+          <a:p>
+            <a:pPr algn="l">
+              <a:lnSpc>
+                <a:spcPct val="100000"/>
+              </a:lnSpc>
+              <a:spcAft>
+                <a:spcPts val="0"/>
+              </a:spcAft>
+            </a:pPr>
+            <a:r>
+              <a:rPr sz="1400" b="1" i="0">
                 <a:solidFill>
                   <a:srgbClr val="0C2340"/>
                 </a:solidFill>
-                <a:latin typeface="Cambria"/>
-              </a:rPr>
-              <a:t>Hold through 2026</a:t>
-            </a:r>
-          </a:p>
-          <a:p>
-            <a:pPr algn="l">
-              <a:lnSpc>
-                <a:spcPct val="108000"/>
-              </a:lnSpc>
-              <a:spcAft>
-                <a:spcPts val="200"/>
-              </a:spcAft>
-            </a:pPr>
-            <a:r>
-              <a:rPr sz="1350" b="0" i="0">
+                <a:latin typeface="Calibri"/>
+              </a:rPr>
+              <a:t>Phillies  </a:t>
+            </a:r>
+            <a:r>
+              <a:rPr sz="1200" b="0" i="0">
                 <a:solidFill>
                   <a:srgbClr val="6B7280"/>
                 </a:solidFill>
                 <a:latin typeface="Calibri"/>
               </a:rPr>
-              <a:t>No contention urgency and Anthony hurt — keep Duran's bat, let his value rebound off an unlucky first half.</a:t>
-            </a:r>
-          </a:p>
-        </p:txBody>
-      </p:sp>
-      <p:sp>
-        <p:nvSpPr>
-          <p:cNvPr id="6" name="Oval 5"/>
+              <a:t>contender, 88 OF wRC+</a:t>
+            </a:r>
+          </a:p>
+        </p:txBody>
+      </p:sp>
+      <p:sp>
+        <p:nvSpPr>
+          <p:cNvPr id="8" name="Oval 7"/>
           <p:cNvSpPr/>
           <p:nvPr/>
         </p:nvSpPr>
         <p:spPr>
           <a:xfrm>
-            <a:off x="640080" y="2971800"/>
-            <a:ext cx="457200" cy="457200"/>
+            <a:off x="8183879" y="2788920"/>
+            <a:ext cx="128016" cy="128016"/>
           </a:xfrm>
           <a:prstGeom prst="ellipse">
             <a:avLst/>
@@ -8959,93 +9592,74 @@
           </a:fontRef>
         </p:style>
         <p:txBody>
-          <a:bodyPr rtlCol="0" anchor="ctr" wrap="none"/>
+          <a:bodyPr rtlCol="0" anchor="ctr"/>
           <a:lstStyle/>
           <a:p>
             <a:pPr algn="ctr"/>
-            <a:r>
-              <a:rPr sz="1800" b="1">
-                <a:solidFill>
-                  <a:srgbClr val="FFFFFF"/>
-                </a:solidFill>
-                <a:latin typeface="Cambria"/>
-              </a:rPr>
-              <a:t>2</a:t>
-            </a:r>
-          </a:p>
-        </p:txBody>
-      </p:sp>
-      <p:sp>
-        <p:nvSpPr>
-          <p:cNvPr id="7" name="TextBox 6"/>
-          <p:cNvSpPr txBox="1"/>
-          <p:nvPr/>
-        </p:nvSpPr>
-        <p:spPr>
-          <a:xfrm>
-            <a:off x="1280160" y="2953512"/>
-            <a:ext cx="6126480" cy="1005840"/>
-          </a:xfrm>
-          <a:prstGeom prst="rect">
-            <a:avLst/>
-          </a:prstGeom>
-          <a:noFill/>
-        </p:spPr>
-        <p:txBody>
-          <a:bodyPr wrap="square" anchor="t" lIns="0" rIns="0" tIns="0" bIns="0">
-            <a:spAutoFit/>
-          </a:bodyPr>
-          <a:lstStyle/>
-          <a:p>
-            <a:pPr algn="l">
-              <a:lnSpc>
-                <a:spcPct val="108000"/>
-              </a:lnSpc>
-              <a:spcAft>
-                <a:spcPts val="200"/>
-              </a:spcAft>
-            </a:pPr>
-            <a:r>
-              <a:rPr sz="1700" b="1" i="0">
+          </a:p>
+        </p:txBody>
+      </p:sp>
+      <p:sp>
+        <p:nvSpPr>
+          <p:cNvPr id="9" name="TextBox 8"/>
+          <p:cNvSpPr txBox="1"/>
+          <p:nvPr/>
+        </p:nvSpPr>
+        <p:spPr>
+          <a:xfrm>
+            <a:off x="8439911" y="2761488"/>
+            <a:ext cx="3566160" cy="457200"/>
+          </a:xfrm>
+          <a:prstGeom prst="rect">
+            <a:avLst/>
+          </a:prstGeom>
+          <a:noFill/>
+        </p:spPr>
+        <p:txBody>
+          <a:bodyPr wrap="square" anchor="t" lIns="0" rIns="0" tIns="0" bIns="0">
+            <a:spAutoFit/>
+          </a:bodyPr>
+          <a:lstStyle/>
+          <a:p>
+            <a:pPr algn="l">
+              <a:lnSpc>
+                <a:spcPct val="100000"/>
+              </a:lnSpc>
+              <a:spcAft>
+                <a:spcPts val="0"/>
+              </a:spcAft>
+            </a:pPr>
+            <a:r>
+              <a:rPr sz="1400" b="1" i="0">
                 <a:solidFill>
                   <a:srgbClr val="0C2340"/>
                 </a:solidFill>
-                <a:latin typeface="Cambria"/>
-              </a:rPr>
-              <a:t>Deal Duran in the offseason</a:t>
-            </a:r>
-          </a:p>
-          <a:p>
-            <a:pPr algn="l">
-              <a:lnSpc>
-                <a:spcPct val="108000"/>
-              </a:lnSpc>
-              <a:spcAft>
-                <a:spcPts val="200"/>
-              </a:spcAft>
-            </a:pPr>
-            <a:r>
-              <a:rPr sz="1350" b="0" i="0">
+                <a:latin typeface="Calibri"/>
+              </a:rPr>
+              <a:t>Rays  </a:t>
+            </a:r>
+            <a:r>
+              <a:rPr sz="1200" b="0" i="0">
                 <a:solidFill>
                   <a:srgbClr val="6B7280"/>
                 </a:solidFill>
                 <a:latin typeface="Calibri"/>
               </a:rPr>
-              <a:t>Anthony's healthy (jam returns), value restored. Trade him — plus Yoshida money — for controllable bats, not arms.</a:t>
-            </a:r>
-          </a:p>
-        </p:txBody>
-      </p:sp>
-      <p:sp>
-        <p:nvSpPr>
-          <p:cNvPr id="8" name="Oval 7"/>
+              <a:t>.602, weak OF</a:t>
+            </a:r>
+          </a:p>
+        </p:txBody>
+      </p:sp>
+      <p:sp>
+        <p:nvSpPr>
+          <p:cNvPr id="10" name="Oval 9"/>
           <p:cNvSpPr/>
           <p:nvPr/>
         </p:nvSpPr>
         <p:spPr>
           <a:xfrm>
-            <a:off x="640080" y="4142231"/>
-            <a:ext cx="457200" cy="457200"/>
+            <a:off x="8183879" y="3355847"/>
+            <a:ext cx="128016" cy="128016"/>
           </a:xfrm>
           <a:prstGeom prst="ellipse">
             <a:avLst/>
@@ -9073,101 +9687,80 @@
           </a:fontRef>
         </p:style>
         <p:txBody>
-          <a:bodyPr rtlCol="0" anchor="ctr" wrap="none"/>
+          <a:bodyPr rtlCol="0" anchor="ctr"/>
           <a:lstStyle/>
           <a:p>
             <a:pPr algn="ctr"/>
-            <a:r>
-              <a:rPr sz="1800" b="1">
-                <a:solidFill>
-                  <a:srgbClr val="FFFFFF"/>
-                </a:solidFill>
-                <a:latin typeface="Cambria"/>
-              </a:rPr>
-              <a:t>3</a:t>
-            </a:r>
-          </a:p>
-        </p:txBody>
-      </p:sp>
-      <p:sp>
-        <p:nvSpPr>
-          <p:cNvPr id="9" name="TextBox 8"/>
-          <p:cNvSpPr txBox="1"/>
-          <p:nvPr/>
-        </p:nvSpPr>
-        <p:spPr>
-          <a:xfrm>
-            <a:off x="1280160" y="4123944"/>
-            <a:ext cx="6126480" cy="1005840"/>
-          </a:xfrm>
-          <a:prstGeom prst="rect">
-            <a:avLst/>
-          </a:prstGeom>
-          <a:noFill/>
-        </p:spPr>
-        <p:txBody>
-          <a:bodyPr wrap="square" anchor="t" lIns="0" rIns="0" tIns="0" bIns="0">
-            <a:spAutoFit/>
-          </a:bodyPr>
-          <a:lstStyle/>
-          <a:p>
-            <a:pPr algn="l">
-              <a:lnSpc>
-                <a:spcPct val="108000"/>
-              </a:lnSpc>
-              <a:spcAft>
-                <a:spcPts val="200"/>
-              </a:spcAft>
-            </a:pPr>
-            <a:r>
-              <a:rPr sz="1700" b="1" i="0">
+          </a:p>
+        </p:txBody>
+      </p:sp>
+      <p:sp>
+        <p:nvSpPr>
+          <p:cNvPr id="11" name="TextBox 10"/>
+          <p:cNvSpPr txBox="1"/>
+          <p:nvPr/>
+        </p:nvSpPr>
+        <p:spPr>
+          <a:xfrm>
+            <a:off x="8439911" y="3328415"/>
+            <a:ext cx="3566160" cy="457200"/>
+          </a:xfrm>
+          <a:prstGeom prst="rect">
+            <a:avLst/>
+          </a:prstGeom>
+          <a:noFill/>
+        </p:spPr>
+        <p:txBody>
+          <a:bodyPr wrap="square" anchor="t" lIns="0" rIns="0" tIns="0" bIns="0">
+            <a:spAutoFit/>
+          </a:bodyPr>
+          <a:lstStyle/>
+          <a:p>
+            <a:pPr algn="l">
+              <a:lnSpc>
+                <a:spcPct val="100000"/>
+              </a:lnSpc>
+              <a:spcAft>
+                <a:spcPts val="0"/>
+              </a:spcAft>
+            </a:pPr>
+            <a:r>
+              <a:rPr sz="1400" b="1" i="0">
                 <a:solidFill>
                   <a:srgbClr val="0C2340"/>
                 </a:solidFill>
-                <a:latin typeface="Cambria"/>
-              </a:rPr>
-              <a:t>Run it back in 2027</a:t>
-            </a:r>
-          </a:p>
-          <a:p>
-            <a:pPr algn="l">
-              <a:lnSpc>
-                <a:spcPct val="108000"/>
-              </a:lnSpc>
-              <a:spcAft>
-                <a:spcPts val="200"/>
-              </a:spcAft>
-            </a:pPr>
-            <a:r>
-              <a:rPr sz="1350" b="0" i="0">
+                <a:latin typeface="Calibri"/>
+              </a:rPr>
+              <a:t>Marlins  </a:t>
+            </a:r>
+            <a:r>
+              <a:rPr sz="1200" b="0" i="0">
                 <a:solidFill>
                   <a:srgbClr val="6B7280"/>
                 </a:solidFill>
                 <a:latin typeface="Calibri"/>
               </a:rPr>
-              <a:t>OF = Anthony / Rafaela / Abreu; strong rotation intact; DH opens after 2027. A cheaper, younger, more balanced roster.</a:t>
-            </a:r>
-          </a:p>
-        </p:txBody>
-      </p:sp>
-      <p:sp>
-        <p:nvSpPr>
-          <p:cNvPr id="10" name="Rounded Rectangle 9"/>
+              <a:t>in the hunt, thin OF</a:t>
+            </a:r>
+          </a:p>
+        </p:txBody>
+      </p:sp>
+      <p:sp>
+        <p:nvSpPr>
+          <p:cNvPr id="12" name="Oval 11"/>
           <p:cNvSpPr/>
           <p:nvPr/>
         </p:nvSpPr>
         <p:spPr>
           <a:xfrm>
-            <a:off x="7818120" y="1783080"/>
-            <a:ext cx="3794760" cy="3337560"/>
-          </a:xfrm>
-          <a:prstGeom prst="roundRect">
-            <a:avLst>
-              <a:gd name="adj" fmla="val 8000"/>
-            </a:avLst>
+            <a:off x="8183879" y="3922776"/>
+            <a:ext cx="128016" cy="128016"/>
+          </a:xfrm>
+          <a:prstGeom prst="ellipse">
+            <a:avLst/>
           </a:prstGeom>
           <a:solidFill>
-            <a:srgbClr val="0C2340"/>
+            <a:srgbClr val="BD3039"/>
           </a:solidFill>
           <a:ln>
             <a:noFill/>
@@ -9198,14 +9791,14 @@
       </p:sp>
       <p:sp>
         <p:nvSpPr>
-          <p:cNvPr id="11" name="TextBox 10"/>
-          <p:cNvSpPr txBox="1"/>
-          <p:nvPr/>
-        </p:nvSpPr>
-        <p:spPr>
-          <a:xfrm>
-            <a:off x="8092440" y="2011680"/>
-            <a:ext cx="3291840" cy="365760"/>
+          <p:cNvPr id="13" name="TextBox 12"/>
+          <p:cNvSpPr txBox="1"/>
+          <p:nvPr/>
+        </p:nvSpPr>
+        <p:spPr>
+          <a:xfrm>
+            <a:off x="8439911" y="3895344"/>
+            <a:ext cx="3566160" cy="457200"/>
           </a:xfrm>
           <a:prstGeom prst="rect">
             <a:avLst/>
@@ -9227,196 +9820,82 @@
               </a:spcAft>
             </a:pPr>
             <a:r>
+              <a:rPr sz="1400" b="1" i="0">
+                <a:solidFill>
+                  <a:srgbClr val="0C2340"/>
+                </a:solidFill>
+                <a:latin typeface="Calibri"/>
+              </a:rPr>
+              <a:t>Guardians  </a:t>
+            </a:r>
+            <a:r>
+              <a:rPr sz="1200" b="0" i="0">
+                <a:solidFill>
+                  <a:srgbClr val="6B7280"/>
+                </a:solidFill>
+                <a:latin typeface="Calibri"/>
+              </a:rPr>
+              <a:t>contender, OF need</a:t>
+            </a:r>
+          </a:p>
+        </p:txBody>
+      </p:sp>
+      <p:sp>
+        <p:nvSpPr>
+          <p:cNvPr id="14" name="TextBox 13"/>
+          <p:cNvSpPr txBox="1"/>
+          <p:nvPr/>
+        </p:nvSpPr>
+        <p:spPr>
+          <a:xfrm>
+            <a:off x="8183879" y="4709160"/>
+            <a:ext cx="3657600" cy="1005840"/>
+          </a:xfrm>
+          <a:prstGeom prst="rect">
+            <a:avLst/>
+          </a:prstGeom>
+          <a:noFill/>
+        </p:spPr>
+        <p:txBody>
+          <a:bodyPr wrap="square" anchor="t" lIns="0" rIns="0" tIns="0" bIns="0">
+            <a:spAutoFit/>
+          </a:bodyPr>
+          <a:lstStyle/>
+          <a:p>
+            <a:pPr algn="l">
+              <a:lnSpc>
+                <a:spcPct val="112000"/>
+              </a:lnSpc>
+              <a:spcAft>
+                <a:spcPts val="400"/>
+              </a:spcAft>
+            </a:pPr>
+            <a:r>
+              <a:rPr sz="1250" b="0" i="0">
+                <a:solidFill>
+                  <a:srgbClr val="20232A"/>
+                </a:solidFill>
+                <a:latin typeface="Calibri"/>
+              </a:rPr>
+              <a:t>Trade a redundant bat to a team that needs one — and take back the </a:t>
+            </a:r>
+            <a:r>
               <a:rPr sz="1250" b="1" i="0">
                 <a:solidFill>
-                  <a:srgbClr val="C9D2E3"/>
-                </a:solidFill>
-                <a:latin typeface="Calibri"/>
-              </a:rPr>
-              <a:t>THE RETURN</a:t>
-            </a:r>
-          </a:p>
-        </p:txBody>
-      </p:sp>
-      <p:sp>
-        <p:nvSpPr>
-          <p:cNvPr id="12" name="TextBox 11"/>
-          <p:cNvSpPr txBox="1"/>
-          <p:nvPr/>
-        </p:nvSpPr>
-        <p:spPr>
-          <a:xfrm>
-            <a:off x="8092440" y="2487168"/>
-            <a:ext cx="3291840" cy="914400"/>
-          </a:xfrm>
-          <a:prstGeom prst="rect">
-            <a:avLst/>
-          </a:prstGeom>
-          <a:noFill/>
-        </p:spPr>
-        <p:txBody>
-          <a:bodyPr wrap="square" anchor="t" lIns="0" rIns="0" tIns="0" bIns="0">
-            <a:spAutoFit/>
-          </a:bodyPr>
-          <a:lstStyle/>
-          <a:p>
-            <a:pPr algn="l">
-              <a:lnSpc>
-                <a:spcPct val="105000"/>
-              </a:lnSpc>
-              <a:spcAft>
-                <a:spcPts val="200"/>
-              </a:spcAft>
-            </a:pPr>
-            <a:r>
-              <a:rPr sz="1300" b="1" i="0">
-                <a:solidFill>
-                  <a:srgbClr val="F0B8BC"/>
-                </a:solidFill>
-                <a:latin typeface="Calibri"/>
-              </a:rPr>
-              <a:t>Sell now (nadir)</a:t>
-            </a:r>
-          </a:p>
-          <a:p>
-            <a:pPr algn="l">
-              <a:lnSpc>
-                <a:spcPct val="105000"/>
-              </a:lnSpc>
-              <a:spcAft>
-                <a:spcPts val="200"/>
-              </a:spcAft>
-            </a:pPr>
-            <a:r>
-              <a:rPr sz="1400" b="0" i="0">
-                <a:solidFill>
-                  <a:srgbClr val="FFFFFF"/>
-                </a:solidFill>
-                <a:latin typeface="Calibri"/>
-              </a:rPr>
-              <a:t>~$10–15M · a 45-FV bat</a:t>
-            </a:r>
-          </a:p>
-        </p:txBody>
-      </p:sp>
-      <p:sp>
-        <p:nvSpPr>
-          <p:cNvPr id="13" name="TextBox 12"/>
-          <p:cNvSpPr txBox="1"/>
-          <p:nvPr/>
-        </p:nvSpPr>
-        <p:spPr>
-          <a:xfrm>
-            <a:off x="8092440" y="3520440"/>
-            <a:ext cx="3291840" cy="1005840"/>
-          </a:xfrm>
-          <a:prstGeom prst="rect">
-            <a:avLst/>
-          </a:prstGeom>
-          <a:noFill/>
-        </p:spPr>
-        <p:txBody>
-          <a:bodyPr wrap="square" anchor="t" lIns="0" rIns="0" tIns="0" bIns="0">
-            <a:spAutoFit/>
-          </a:bodyPr>
-          <a:lstStyle/>
-          <a:p>
-            <a:pPr algn="l">
-              <a:lnSpc>
-                <a:spcPct val="105000"/>
-              </a:lnSpc>
-              <a:spcAft>
-                <a:spcPts val="200"/>
-              </a:spcAft>
-            </a:pPr>
-            <a:r>
-              <a:rPr sz="1300" b="1" i="0">
-                <a:solidFill>
-                  <a:srgbClr val="A9E5B5"/>
-                </a:solidFill>
-                <a:latin typeface="Calibri"/>
-              </a:rPr>
-              <a:t>Sell after rebound</a:t>
-            </a:r>
-          </a:p>
-          <a:p>
-            <a:pPr algn="l">
-              <a:lnSpc>
-                <a:spcPct val="105000"/>
-              </a:lnSpc>
-              <a:spcAft>
-                <a:spcPts val="200"/>
-              </a:spcAft>
-            </a:pPr>
-            <a:r>
-              <a:rPr sz="1400" b="0" i="0">
-                <a:solidFill>
-                  <a:srgbClr val="FFFFFF"/>
-                </a:solidFill>
-                <a:latin typeface="Calibri"/>
-              </a:rPr>
-              <a:t>~$28M · a 50-FV, top-100</a:t>
-            </a:r>
-          </a:p>
-          <a:p>
-            <a:pPr algn="l">
-              <a:lnSpc>
-                <a:spcPct val="105000"/>
-              </a:lnSpc>
-              <a:spcAft>
-                <a:spcPts val="200"/>
-              </a:spcAft>
-            </a:pPr>
-            <a:r>
-              <a:rPr sz="1400" b="0" i="0">
-                <a:solidFill>
-                  <a:srgbClr val="FFFFFF"/>
-                </a:solidFill>
-                <a:latin typeface="Calibri"/>
-              </a:rPr>
-              <a:t>controllable talent</a:t>
-            </a:r>
-          </a:p>
-        </p:txBody>
-      </p:sp>
-      <p:sp>
-        <p:nvSpPr>
-          <p:cNvPr id="14" name="TextBox 13"/>
-          <p:cNvSpPr txBox="1"/>
-          <p:nvPr/>
-        </p:nvSpPr>
-        <p:spPr>
-          <a:xfrm>
-            <a:off x="8092440" y="4617720"/>
-            <a:ext cx="3291840" cy="457200"/>
-          </a:xfrm>
-          <a:prstGeom prst="rect">
-            <a:avLst/>
-          </a:prstGeom>
-          <a:noFill/>
-        </p:spPr>
-        <p:txBody>
-          <a:bodyPr wrap="square" anchor="t" lIns="0" rIns="0" tIns="0" bIns="0">
-            <a:spAutoFit/>
-          </a:bodyPr>
-          <a:lstStyle/>
-          <a:p>
-            <a:pPr algn="l">
-              <a:lnSpc>
-                <a:spcPct val="105000"/>
-              </a:lnSpc>
-              <a:spcAft>
-                <a:spcPts val="400"/>
-              </a:spcAft>
-            </a:pPr>
-            <a:r>
-              <a:rPr sz="1150" b="0" i="1">
-                <a:solidFill>
-                  <a:srgbClr val="C9D2E3"/>
-                </a:solidFill>
-                <a:latin typeface="Calibri"/>
-              </a:rPr>
-              <a:t>One grade of return = the reason to wait.</a:t>
+                  <a:srgbClr val="2E7D32"/>
+                </a:solidFill>
+                <a:latin typeface="Calibri"/>
+              </a:rPr>
+              <a:t>hitting/youth</a:t>
+            </a:r>
+            <a:r>
+              <a:rPr sz="1250" b="0" i="0">
+                <a:solidFill>
+                  <a:srgbClr val="20232A"/>
+                </a:solidFill>
+                <a:latin typeface="Calibri"/>
+              </a:rPr>
+              <a:t> Boston is short on.</a:t>
             </a:r>
           </a:p>
         </p:txBody>

</xml_diff>

<commit_message>
Integrate erosion + backtest + pre-registration into memo, web page, deck
- decision memo: new sections 9 (bat-tracking verdict) and 10 (luck-gap
  backtest) plus a pre-registered-predictions section; regenerated.
- web page: new sections 05 'The Tiebreaker' and 07 'The Backtest' with
  figures 10-11 embedded, sections renumbered 01-10, pre-registration note
  in the bottom line; regenerated (11 embedded figures).
- deck: new slide 'The bat speed says it's the approach — not the body'
  (the verdict is decisive, so it earns the slide); 12 slides total.
- run_all.py wires erosion -> luck_backtest -> preregister into the
  pipeline (--no-fetch reuses the committed Savant cache).
- README: pre-registered-predictions section, new modules/figures listed.
- data/trade_fits.csv + figure 08: routine standings refresh from the run.

Suite: 63 tests, all green.

Co-Authored-By: Claude Fable 5 <noreply@anthropic.com>
</commit_message>
<xml_diff>
--- a/outputs/Red_Sox_Outfield_Strategy.pptx
+++ b/outputs/Red_Sox_Outfield_Strategy.pptx
@@ -16,6 +16,7 @@
     <p:sldId id="264" r:id="rId15"/>
     <p:sldId id="265" r:id="rId16"/>
     <p:sldId id="266" r:id="rId17"/>
+    <p:sldId id="267" r:id="rId18"/>
   </p:sldIdLst>
   <p:sldSz cx="12191695" cy="6858000" type="screen4x3"/>
   <p:notesSz cx="6858000" cy="9144000"/>
@@ -3400,7 +3401,7 @@
                 </a:solidFill>
                 <a:latin typeface="Calibri"/>
               </a:rPr>
-              <a:t>THE SEQUENCE</a:t>
+              <a:t>THE MARKET</a:t>
             </a:r>
           </a:p>
         </p:txBody>
@@ -3442,21 +3443,87 @@
                 </a:solidFill>
                 <a:latin typeface="Cambria"/>
               </a:rPr>
-              <a:t>Solve it this winter, from a position of strength</a:t>
-            </a:r>
-          </a:p>
-        </p:txBody>
-      </p:sp>
-      <p:sp>
-        <p:nvSpPr>
-          <p:cNvPr id="4" name="Oval 3"/>
+              <a:t>Who pays: contenders with a hole in the outfield</a:t>
+            </a:r>
+          </a:p>
+        </p:txBody>
+      </p:sp>
+      <p:pic>
+        <p:nvPicPr>
+          <p:cNvPr id="4" name="Picture 3" descr="08_trade_fit_targets.png"/>
+          <p:cNvPicPr>
+            <a:picLocks noChangeAspect="1"/>
+          </p:cNvPicPr>
+          <p:nvPr/>
+        </p:nvPicPr>
+        <p:blipFill>
+          <a:blip r:embed="rId2"/>
+          <a:stretch>
+            <a:fillRect/>
+          </a:stretch>
+        </p:blipFill>
+        <p:spPr>
+          <a:xfrm>
+            <a:off x="757237" y="1463040"/>
+            <a:ext cx="6715125" cy="4297680"/>
+          </a:xfrm>
+          <a:prstGeom prst="rect">
+            <a:avLst/>
+          </a:prstGeom>
+        </p:spPr>
+      </p:pic>
+      <p:sp>
+        <p:nvSpPr>
+          <p:cNvPr id="5" name="TextBox 4"/>
+          <p:cNvSpPr txBox="1"/>
+          <p:nvPr/>
+        </p:nvSpPr>
+        <p:spPr>
+          <a:xfrm>
+            <a:off x="8183879" y="1691640"/>
+            <a:ext cx="3657600" cy="457200"/>
+          </a:xfrm>
+          <a:prstGeom prst="rect">
+            <a:avLst/>
+          </a:prstGeom>
+          <a:noFill/>
+        </p:spPr>
+        <p:txBody>
+          <a:bodyPr wrap="square" anchor="t" lIns="0" rIns="0" tIns="0" bIns="0">
+            <a:spAutoFit/>
+          </a:bodyPr>
+          <a:lstStyle/>
+          <a:p>
+            <a:pPr algn="l">
+              <a:lnSpc>
+                <a:spcPct val="100000"/>
+              </a:lnSpc>
+              <a:spcAft>
+                <a:spcPts val="0"/>
+              </a:spcAft>
+            </a:pPr>
+            <a:r>
+              <a:rPr sz="1500" b="1" i="0">
+                <a:solidFill>
+                  <a:srgbClr val="0C2340"/>
+                </a:solidFill>
+                <a:latin typeface="Cambria"/>
+              </a:rPr>
+              <a:t>Best-fit buyers</a:t>
+            </a:r>
+          </a:p>
+        </p:txBody>
+      </p:sp>
+      <p:sp>
+        <p:nvSpPr>
+          <p:cNvPr id="6" name="Oval 5"/>
           <p:cNvSpPr/>
           <p:nvPr/>
         </p:nvSpPr>
         <p:spPr>
           <a:xfrm>
-            <a:off x="640080" y="1801368"/>
-            <a:ext cx="457200" cy="457200"/>
+            <a:off x="8183879" y="2221991"/>
+            <a:ext cx="128016" cy="128016"/>
           </a:xfrm>
           <a:prstGeom prst="ellipse">
             <a:avLst/>
@@ -3484,93 +3551,74 @@
           </a:fontRef>
         </p:style>
         <p:txBody>
-          <a:bodyPr rtlCol="0" anchor="ctr" wrap="none"/>
+          <a:bodyPr rtlCol="0" anchor="ctr"/>
           <a:lstStyle/>
           <a:p>
             <a:pPr algn="ctr"/>
-            <a:r>
-              <a:rPr sz="1800" b="1">
-                <a:solidFill>
-                  <a:srgbClr val="FFFFFF"/>
-                </a:solidFill>
-                <a:latin typeface="Cambria"/>
-              </a:rPr>
-              <a:t>1</a:t>
-            </a:r>
-          </a:p>
-        </p:txBody>
-      </p:sp>
-      <p:sp>
-        <p:nvSpPr>
-          <p:cNvPr id="5" name="TextBox 4"/>
-          <p:cNvSpPr txBox="1"/>
-          <p:nvPr/>
-        </p:nvSpPr>
-        <p:spPr>
-          <a:xfrm>
-            <a:off x="1280160" y="1783080"/>
-            <a:ext cx="6126480" cy="1005840"/>
-          </a:xfrm>
-          <a:prstGeom prst="rect">
-            <a:avLst/>
-          </a:prstGeom>
-          <a:noFill/>
-        </p:spPr>
-        <p:txBody>
-          <a:bodyPr wrap="square" anchor="t" lIns="0" rIns="0" tIns="0" bIns="0">
-            <a:spAutoFit/>
-          </a:bodyPr>
-          <a:lstStyle/>
-          <a:p>
-            <a:pPr algn="l">
-              <a:lnSpc>
-                <a:spcPct val="108000"/>
-              </a:lnSpc>
-              <a:spcAft>
-                <a:spcPts val="200"/>
-              </a:spcAft>
-            </a:pPr>
-            <a:r>
-              <a:rPr sz="1700" b="1" i="0">
+          </a:p>
+        </p:txBody>
+      </p:sp>
+      <p:sp>
+        <p:nvSpPr>
+          <p:cNvPr id="7" name="TextBox 6"/>
+          <p:cNvSpPr txBox="1"/>
+          <p:nvPr/>
+        </p:nvSpPr>
+        <p:spPr>
+          <a:xfrm>
+            <a:off x="8439911" y="2194560"/>
+            <a:ext cx="3566160" cy="457200"/>
+          </a:xfrm>
+          <a:prstGeom prst="rect">
+            <a:avLst/>
+          </a:prstGeom>
+          <a:noFill/>
+        </p:spPr>
+        <p:txBody>
+          <a:bodyPr wrap="square" anchor="t" lIns="0" rIns="0" tIns="0" bIns="0">
+            <a:spAutoFit/>
+          </a:bodyPr>
+          <a:lstStyle/>
+          <a:p>
+            <a:pPr algn="l">
+              <a:lnSpc>
+                <a:spcPct val="100000"/>
+              </a:lnSpc>
+              <a:spcAft>
+                <a:spcPts val="0"/>
+              </a:spcAft>
+            </a:pPr>
+            <a:r>
+              <a:rPr sz="1400" b="1" i="0">
                 <a:solidFill>
                   <a:srgbClr val="0C2340"/>
                 </a:solidFill>
-                <a:latin typeface="Cambria"/>
-              </a:rPr>
-              <a:t>Hold through 2026</a:t>
-            </a:r>
-          </a:p>
-          <a:p>
-            <a:pPr algn="l">
-              <a:lnSpc>
-                <a:spcPct val="108000"/>
-              </a:lnSpc>
-              <a:spcAft>
-                <a:spcPts val="200"/>
-              </a:spcAft>
-            </a:pPr>
-            <a:r>
-              <a:rPr sz="1350" b="0" i="0">
+                <a:latin typeface="Calibri"/>
+              </a:rPr>
+              <a:t>Phillies  </a:t>
+            </a:r>
+            <a:r>
+              <a:rPr sz="1200" b="0" i="0">
                 <a:solidFill>
                   <a:srgbClr val="6B7280"/>
                 </a:solidFill>
                 <a:latin typeface="Calibri"/>
               </a:rPr>
-              <a:t>No contention urgency and Anthony hurt — keep Duran's bat, let his value rebound off an unlucky first half.</a:t>
-            </a:r>
-          </a:p>
-        </p:txBody>
-      </p:sp>
-      <p:sp>
-        <p:nvSpPr>
-          <p:cNvPr id="6" name="Oval 5"/>
+              <a:t>contender, 88 OF wRC+</a:t>
+            </a:r>
+          </a:p>
+        </p:txBody>
+      </p:sp>
+      <p:sp>
+        <p:nvSpPr>
+          <p:cNvPr id="8" name="Oval 7"/>
           <p:cNvSpPr/>
           <p:nvPr/>
         </p:nvSpPr>
         <p:spPr>
           <a:xfrm>
-            <a:off x="640080" y="2971800"/>
-            <a:ext cx="457200" cy="457200"/>
+            <a:off x="8183879" y="2788920"/>
+            <a:ext cx="128016" cy="128016"/>
           </a:xfrm>
           <a:prstGeom prst="ellipse">
             <a:avLst/>
@@ -3598,93 +3646,74 @@
           </a:fontRef>
         </p:style>
         <p:txBody>
-          <a:bodyPr rtlCol="0" anchor="ctr" wrap="none"/>
+          <a:bodyPr rtlCol="0" anchor="ctr"/>
           <a:lstStyle/>
           <a:p>
             <a:pPr algn="ctr"/>
-            <a:r>
-              <a:rPr sz="1800" b="1">
-                <a:solidFill>
-                  <a:srgbClr val="FFFFFF"/>
-                </a:solidFill>
-                <a:latin typeface="Cambria"/>
-              </a:rPr>
-              <a:t>2</a:t>
-            </a:r>
-          </a:p>
-        </p:txBody>
-      </p:sp>
-      <p:sp>
-        <p:nvSpPr>
-          <p:cNvPr id="7" name="TextBox 6"/>
-          <p:cNvSpPr txBox="1"/>
-          <p:nvPr/>
-        </p:nvSpPr>
-        <p:spPr>
-          <a:xfrm>
-            <a:off x="1280160" y="2953512"/>
-            <a:ext cx="6126480" cy="1005840"/>
-          </a:xfrm>
-          <a:prstGeom prst="rect">
-            <a:avLst/>
-          </a:prstGeom>
-          <a:noFill/>
-        </p:spPr>
-        <p:txBody>
-          <a:bodyPr wrap="square" anchor="t" lIns="0" rIns="0" tIns="0" bIns="0">
-            <a:spAutoFit/>
-          </a:bodyPr>
-          <a:lstStyle/>
-          <a:p>
-            <a:pPr algn="l">
-              <a:lnSpc>
-                <a:spcPct val="108000"/>
-              </a:lnSpc>
-              <a:spcAft>
-                <a:spcPts val="200"/>
-              </a:spcAft>
-            </a:pPr>
-            <a:r>
-              <a:rPr sz="1700" b="1" i="0">
+          </a:p>
+        </p:txBody>
+      </p:sp>
+      <p:sp>
+        <p:nvSpPr>
+          <p:cNvPr id="9" name="TextBox 8"/>
+          <p:cNvSpPr txBox="1"/>
+          <p:nvPr/>
+        </p:nvSpPr>
+        <p:spPr>
+          <a:xfrm>
+            <a:off x="8439911" y="2761488"/>
+            <a:ext cx="3566160" cy="457200"/>
+          </a:xfrm>
+          <a:prstGeom prst="rect">
+            <a:avLst/>
+          </a:prstGeom>
+          <a:noFill/>
+        </p:spPr>
+        <p:txBody>
+          <a:bodyPr wrap="square" anchor="t" lIns="0" rIns="0" tIns="0" bIns="0">
+            <a:spAutoFit/>
+          </a:bodyPr>
+          <a:lstStyle/>
+          <a:p>
+            <a:pPr algn="l">
+              <a:lnSpc>
+                <a:spcPct val="100000"/>
+              </a:lnSpc>
+              <a:spcAft>
+                <a:spcPts val="0"/>
+              </a:spcAft>
+            </a:pPr>
+            <a:r>
+              <a:rPr sz="1400" b="1" i="0">
                 <a:solidFill>
                   <a:srgbClr val="0C2340"/>
                 </a:solidFill>
-                <a:latin typeface="Cambria"/>
-              </a:rPr>
-              <a:t>Deal Duran in the offseason</a:t>
-            </a:r>
-          </a:p>
-          <a:p>
-            <a:pPr algn="l">
-              <a:lnSpc>
-                <a:spcPct val="108000"/>
-              </a:lnSpc>
-              <a:spcAft>
-                <a:spcPts val="200"/>
-              </a:spcAft>
-            </a:pPr>
-            <a:r>
-              <a:rPr sz="1350" b="0" i="0">
+                <a:latin typeface="Calibri"/>
+              </a:rPr>
+              <a:t>Rays  </a:t>
+            </a:r>
+            <a:r>
+              <a:rPr sz="1200" b="0" i="0">
                 <a:solidFill>
                   <a:srgbClr val="6B7280"/>
                 </a:solidFill>
                 <a:latin typeface="Calibri"/>
               </a:rPr>
-              <a:t>Anthony's healthy (jam returns), value restored. Trade him — plus Yoshida money — for controllable bats, not arms.</a:t>
-            </a:r>
-          </a:p>
-        </p:txBody>
-      </p:sp>
-      <p:sp>
-        <p:nvSpPr>
-          <p:cNvPr id="8" name="Oval 7"/>
+              <a:t>.602, weak OF</a:t>
+            </a:r>
+          </a:p>
+        </p:txBody>
+      </p:sp>
+      <p:sp>
+        <p:nvSpPr>
+          <p:cNvPr id="10" name="Oval 9"/>
           <p:cNvSpPr/>
           <p:nvPr/>
         </p:nvSpPr>
         <p:spPr>
           <a:xfrm>
-            <a:off x="640080" y="4142231"/>
-            <a:ext cx="457200" cy="457200"/>
+            <a:off x="8183879" y="3355847"/>
+            <a:ext cx="128016" cy="128016"/>
           </a:xfrm>
           <a:prstGeom prst="ellipse">
             <a:avLst/>
@@ -3712,101 +3741,80 @@
           </a:fontRef>
         </p:style>
         <p:txBody>
-          <a:bodyPr rtlCol="0" anchor="ctr" wrap="none"/>
+          <a:bodyPr rtlCol="0" anchor="ctr"/>
           <a:lstStyle/>
           <a:p>
             <a:pPr algn="ctr"/>
-            <a:r>
-              <a:rPr sz="1800" b="1">
-                <a:solidFill>
-                  <a:srgbClr val="FFFFFF"/>
-                </a:solidFill>
-                <a:latin typeface="Cambria"/>
-              </a:rPr>
-              <a:t>3</a:t>
-            </a:r>
-          </a:p>
-        </p:txBody>
-      </p:sp>
-      <p:sp>
-        <p:nvSpPr>
-          <p:cNvPr id="9" name="TextBox 8"/>
-          <p:cNvSpPr txBox="1"/>
-          <p:nvPr/>
-        </p:nvSpPr>
-        <p:spPr>
-          <a:xfrm>
-            <a:off x="1280160" y="4123944"/>
-            <a:ext cx="6126480" cy="1005840"/>
-          </a:xfrm>
-          <a:prstGeom prst="rect">
-            <a:avLst/>
-          </a:prstGeom>
-          <a:noFill/>
-        </p:spPr>
-        <p:txBody>
-          <a:bodyPr wrap="square" anchor="t" lIns="0" rIns="0" tIns="0" bIns="0">
-            <a:spAutoFit/>
-          </a:bodyPr>
-          <a:lstStyle/>
-          <a:p>
-            <a:pPr algn="l">
-              <a:lnSpc>
-                <a:spcPct val="108000"/>
-              </a:lnSpc>
-              <a:spcAft>
-                <a:spcPts val="200"/>
-              </a:spcAft>
-            </a:pPr>
-            <a:r>
-              <a:rPr sz="1700" b="1" i="0">
+          </a:p>
+        </p:txBody>
+      </p:sp>
+      <p:sp>
+        <p:nvSpPr>
+          <p:cNvPr id="11" name="TextBox 10"/>
+          <p:cNvSpPr txBox="1"/>
+          <p:nvPr/>
+        </p:nvSpPr>
+        <p:spPr>
+          <a:xfrm>
+            <a:off x="8439911" y="3328415"/>
+            <a:ext cx="3566160" cy="457200"/>
+          </a:xfrm>
+          <a:prstGeom prst="rect">
+            <a:avLst/>
+          </a:prstGeom>
+          <a:noFill/>
+        </p:spPr>
+        <p:txBody>
+          <a:bodyPr wrap="square" anchor="t" lIns="0" rIns="0" tIns="0" bIns="0">
+            <a:spAutoFit/>
+          </a:bodyPr>
+          <a:lstStyle/>
+          <a:p>
+            <a:pPr algn="l">
+              <a:lnSpc>
+                <a:spcPct val="100000"/>
+              </a:lnSpc>
+              <a:spcAft>
+                <a:spcPts val="0"/>
+              </a:spcAft>
+            </a:pPr>
+            <a:r>
+              <a:rPr sz="1400" b="1" i="0">
                 <a:solidFill>
                   <a:srgbClr val="0C2340"/>
                 </a:solidFill>
-                <a:latin typeface="Cambria"/>
-              </a:rPr>
-              <a:t>Run it back in 2027</a:t>
-            </a:r>
-          </a:p>
-          <a:p>
-            <a:pPr algn="l">
-              <a:lnSpc>
-                <a:spcPct val="108000"/>
-              </a:lnSpc>
-              <a:spcAft>
-                <a:spcPts val="200"/>
-              </a:spcAft>
-            </a:pPr>
-            <a:r>
-              <a:rPr sz="1350" b="0" i="0">
+                <a:latin typeface="Calibri"/>
+              </a:rPr>
+              <a:t>Marlins  </a:t>
+            </a:r>
+            <a:r>
+              <a:rPr sz="1200" b="0" i="0">
                 <a:solidFill>
                   <a:srgbClr val="6B7280"/>
                 </a:solidFill>
                 <a:latin typeface="Calibri"/>
               </a:rPr>
-              <a:t>OF = Anthony / Rafaela / Abreu; strong rotation intact; DH opens after 2027. A cheaper, younger, more balanced roster.</a:t>
-            </a:r>
-          </a:p>
-        </p:txBody>
-      </p:sp>
-      <p:sp>
-        <p:nvSpPr>
-          <p:cNvPr id="10" name="Rounded Rectangle 9"/>
+              <a:t>in the hunt, thin OF</a:t>
+            </a:r>
+          </a:p>
+        </p:txBody>
+      </p:sp>
+      <p:sp>
+        <p:nvSpPr>
+          <p:cNvPr id="12" name="Oval 11"/>
           <p:cNvSpPr/>
           <p:nvPr/>
         </p:nvSpPr>
         <p:spPr>
           <a:xfrm>
-            <a:off x="7818120" y="1783080"/>
-            <a:ext cx="3794760" cy="3337560"/>
-          </a:xfrm>
-          <a:prstGeom prst="roundRect">
-            <a:avLst>
-              <a:gd name="adj" fmla="val 8000"/>
-            </a:avLst>
+            <a:off x="8183879" y="3922776"/>
+            <a:ext cx="128016" cy="128016"/>
+          </a:xfrm>
+          <a:prstGeom prst="ellipse">
+            <a:avLst/>
           </a:prstGeom>
           <a:solidFill>
-            <a:srgbClr val="0C2340"/>
+            <a:srgbClr val="BD3039"/>
           </a:solidFill>
           <a:ln>
             <a:noFill/>
@@ -3837,14 +3845,14 @@
       </p:sp>
       <p:sp>
         <p:nvSpPr>
-          <p:cNvPr id="11" name="TextBox 10"/>
-          <p:cNvSpPr txBox="1"/>
-          <p:nvPr/>
-        </p:nvSpPr>
-        <p:spPr>
-          <a:xfrm>
-            <a:off x="8092440" y="2011680"/>
-            <a:ext cx="3291840" cy="365760"/>
+          <p:cNvPr id="13" name="TextBox 12"/>
+          <p:cNvSpPr txBox="1"/>
+          <p:nvPr/>
+        </p:nvSpPr>
+        <p:spPr>
+          <a:xfrm>
+            <a:off x="8439911" y="3895344"/>
+            <a:ext cx="3566160" cy="457200"/>
           </a:xfrm>
           <a:prstGeom prst="rect">
             <a:avLst/>
@@ -3866,196 +3874,82 @@
               </a:spcAft>
             </a:pPr>
             <a:r>
+              <a:rPr sz="1400" b="1" i="0">
+                <a:solidFill>
+                  <a:srgbClr val="0C2340"/>
+                </a:solidFill>
+                <a:latin typeface="Calibri"/>
+              </a:rPr>
+              <a:t>Guardians  </a:t>
+            </a:r>
+            <a:r>
+              <a:rPr sz="1200" b="0" i="0">
+                <a:solidFill>
+                  <a:srgbClr val="6B7280"/>
+                </a:solidFill>
+                <a:latin typeface="Calibri"/>
+              </a:rPr>
+              <a:t>contender, OF need</a:t>
+            </a:r>
+          </a:p>
+        </p:txBody>
+      </p:sp>
+      <p:sp>
+        <p:nvSpPr>
+          <p:cNvPr id="14" name="TextBox 13"/>
+          <p:cNvSpPr txBox="1"/>
+          <p:nvPr/>
+        </p:nvSpPr>
+        <p:spPr>
+          <a:xfrm>
+            <a:off x="8183879" y="4709160"/>
+            <a:ext cx="3657600" cy="1005840"/>
+          </a:xfrm>
+          <a:prstGeom prst="rect">
+            <a:avLst/>
+          </a:prstGeom>
+          <a:noFill/>
+        </p:spPr>
+        <p:txBody>
+          <a:bodyPr wrap="square" anchor="t" lIns="0" rIns="0" tIns="0" bIns="0">
+            <a:spAutoFit/>
+          </a:bodyPr>
+          <a:lstStyle/>
+          <a:p>
+            <a:pPr algn="l">
+              <a:lnSpc>
+                <a:spcPct val="112000"/>
+              </a:lnSpc>
+              <a:spcAft>
+                <a:spcPts val="400"/>
+              </a:spcAft>
+            </a:pPr>
+            <a:r>
+              <a:rPr sz="1250" b="0" i="0">
+                <a:solidFill>
+                  <a:srgbClr val="20232A"/>
+                </a:solidFill>
+                <a:latin typeface="Calibri"/>
+              </a:rPr>
+              <a:t>Trade a redundant bat to a team that needs one — and take back the </a:t>
+            </a:r>
+            <a:r>
               <a:rPr sz="1250" b="1" i="0">
                 <a:solidFill>
-                  <a:srgbClr val="C9D2E3"/>
-                </a:solidFill>
-                <a:latin typeface="Calibri"/>
-              </a:rPr>
-              <a:t>THE RETURN</a:t>
-            </a:r>
-          </a:p>
-        </p:txBody>
-      </p:sp>
-      <p:sp>
-        <p:nvSpPr>
-          <p:cNvPr id="12" name="TextBox 11"/>
-          <p:cNvSpPr txBox="1"/>
-          <p:nvPr/>
-        </p:nvSpPr>
-        <p:spPr>
-          <a:xfrm>
-            <a:off x="8092440" y="2487168"/>
-            <a:ext cx="3291840" cy="914400"/>
-          </a:xfrm>
-          <a:prstGeom prst="rect">
-            <a:avLst/>
-          </a:prstGeom>
-          <a:noFill/>
-        </p:spPr>
-        <p:txBody>
-          <a:bodyPr wrap="square" anchor="t" lIns="0" rIns="0" tIns="0" bIns="0">
-            <a:spAutoFit/>
-          </a:bodyPr>
-          <a:lstStyle/>
-          <a:p>
-            <a:pPr algn="l">
-              <a:lnSpc>
-                <a:spcPct val="105000"/>
-              </a:lnSpc>
-              <a:spcAft>
-                <a:spcPts val="200"/>
-              </a:spcAft>
-            </a:pPr>
-            <a:r>
-              <a:rPr sz="1300" b="1" i="0">
-                <a:solidFill>
-                  <a:srgbClr val="F0B8BC"/>
-                </a:solidFill>
-                <a:latin typeface="Calibri"/>
-              </a:rPr>
-              <a:t>Sell now (nadir)</a:t>
-            </a:r>
-          </a:p>
-          <a:p>
-            <a:pPr algn="l">
-              <a:lnSpc>
-                <a:spcPct val="105000"/>
-              </a:lnSpc>
-              <a:spcAft>
-                <a:spcPts val="200"/>
-              </a:spcAft>
-            </a:pPr>
-            <a:r>
-              <a:rPr sz="1400" b="0" i="0">
-                <a:solidFill>
-                  <a:srgbClr val="FFFFFF"/>
-                </a:solidFill>
-                <a:latin typeface="Calibri"/>
-              </a:rPr>
-              <a:t>~$10–15M · a 45-FV bat</a:t>
-            </a:r>
-          </a:p>
-        </p:txBody>
-      </p:sp>
-      <p:sp>
-        <p:nvSpPr>
-          <p:cNvPr id="13" name="TextBox 12"/>
-          <p:cNvSpPr txBox="1"/>
-          <p:nvPr/>
-        </p:nvSpPr>
-        <p:spPr>
-          <a:xfrm>
-            <a:off x="8092440" y="3520440"/>
-            <a:ext cx="3291840" cy="1005840"/>
-          </a:xfrm>
-          <a:prstGeom prst="rect">
-            <a:avLst/>
-          </a:prstGeom>
-          <a:noFill/>
-        </p:spPr>
-        <p:txBody>
-          <a:bodyPr wrap="square" anchor="t" lIns="0" rIns="0" tIns="0" bIns="0">
-            <a:spAutoFit/>
-          </a:bodyPr>
-          <a:lstStyle/>
-          <a:p>
-            <a:pPr algn="l">
-              <a:lnSpc>
-                <a:spcPct val="105000"/>
-              </a:lnSpc>
-              <a:spcAft>
-                <a:spcPts val="200"/>
-              </a:spcAft>
-            </a:pPr>
-            <a:r>
-              <a:rPr sz="1300" b="1" i="0">
-                <a:solidFill>
-                  <a:srgbClr val="A9E5B5"/>
-                </a:solidFill>
-                <a:latin typeface="Calibri"/>
-              </a:rPr>
-              <a:t>Sell after rebound</a:t>
-            </a:r>
-          </a:p>
-          <a:p>
-            <a:pPr algn="l">
-              <a:lnSpc>
-                <a:spcPct val="105000"/>
-              </a:lnSpc>
-              <a:spcAft>
-                <a:spcPts val="200"/>
-              </a:spcAft>
-            </a:pPr>
-            <a:r>
-              <a:rPr sz="1400" b="0" i="0">
-                <a:solidFill>
-                  <a:srgbClr val="FFFFFF"/>
-                </a:solidFill>
-                <a:latin typeface="Calibri"/>
-              </a:rPr>
-              <a:t>~$28M · a 50-FV, top-100</a:t>
-            </a:r>
-          </a:p>
-          <a:p>
-            <a:pPr algn="l">
-              <a:lnSpc>
-                <a:spcPct val="105000"/>
-              </a:lnSpc>
-              <a:spcAft>
-                <a:spcPts val="200"/>
-              </a:spcAft>
-            </a:pPr>
-            <a:r>
-              <a:rPr sz="1400" b="0" i="0">
-                <a:solidFill>
-                  <a:srgbClr val="FFFFFF"/>
-                </a:solidFill>
-                <a:latin typeface="Calibri"/>
-              </a:rPr>
-              <a:t>controllable talent</a:t>
-            </a:r>
-          </a:p>
-        </p:txBody>
-      </p:sp>
-      <p:sp>
-        <p:nvSpPr>
-          <p:cNvPr id="14" name="TextBox 13"/>
-          <p:cNvSpPr txBox="1"/>
-          <p:nvPr/>
-        </p:nvSpPr>
-        <p:spPr>
-          <a:xfrm>
-            <a:off x="8092440" y="4617720"/>
-            <a:ext cx="3291840" cy="457200"/>
-          </a:xfrm>
-          <a:prstGeom prst="rect">
-            <a:avLst/>
-          </a:prstGeom>
-          <a:noFill/>
-        </p:spPr>
-        <p:txBody>
-          <a:bodyPr wrap="square" anchor="t" lIns="0" rIns="0" tIns="0" bIns="0">
-            <a:spAutoFit/>
-          </a:bodyPr>
-          <a:lstStyle/>
-          <a:p>
-            <a:pPr algn="l">
-              <a:lnSpc>
-                <a:spcPct val="105000"/>
-              </a:lnSpc>
-              <a:spcAft>
-                <a:spcPts val="400"/>
-              </a:spcAft>
-            </a:pPr>
-            <a:r>
-              <a:rPr sz="1150" b="0" i="1">
-                <a:solidFill>
-                  <a:srgbClr val="C9D2E3"/>
-                </a:solidFill>
-                <a:latin typeface="Calibri"/>
-              </a:rPr>
-              <a:t>One grade of return = the reason to wait.</a:t>
+                  <a:srgbClr val="2E7D32"/>
+                </a:solidFill>
+                <a:latin typeface="Calibri"/>
+              </a:rPr>
+              <a:t>hitting/youth</a:t>
+            </a:r>
+            <a:r>
+              <a:rPr sz="1250" b="0" i="0">
+                <a:solidFill>
+                  <a:srgbClr val="20232A"/>
+                </a:solidFill>
+                <a:latin typeface="Calibri"/>
+              </a:rPr>
+              <a:t> Boston is short on.</a:t>
             </a:r>
           </a:p>
         </p:txBody>
@@ -4120,6 +4014,780 @@
 </file>
 
 <file path=ppt/slides/slide11.xml><?xml version="1.0" encoding="utf-8"?>
+<p:sld xmlns:a="http://schemas.openxmlformats.org/drawingml/2006/main" xmlns:p="http://schemas.openxmlformats.org/presentationml/2006/main" xmlns:r="http://schemas.openxmlformats.org/officeDocument/2006/relationships">
+  <p:cSld>
+    <p:bg>
+      <p:bgPr>
+        <a:solidFill>
+          <a:srgbClr val="F4F5F7"/>
+        </a:solidFill>
+        <a:effectLst/>
+      </p:bgPr>
+    </p:bg>
+    <p:spTree>
+      <p:nvGrpSpPr>
+        <p:cNvPr id="1" name=""/>
+        <p:cNvGrpSpPr/>
+        <p:nvPr/>
+      </p:nvGrpSpPr>
+      <p:grpSpPr/>
+      <p:sp>
+        <p:nvSpPr>
+          <p:cNvPr id="2" name="TextBox 1"/>
+          <p:cNvSpPr txBox="1"/>
+          <p:nvPr/>
+        </p:nvSpPr>
+        <p:spPr>
+          <a:xfrm>
+            <a:off x="566928" y="384048"/>
+            <a:ext cx="10058400" cy="274320"/>
+          </a:xfrm>
+          <a:prstGeom prst="rect">
+            <a:avLst/>
+          </a:prstGeom>
+          <a:noFill/>
+        </p:spPr>
+        <p:txBody>
+          <a:bodyPr wrap="square" anchor="t" lIns="0" rIns="0" tIns="0" bIns="0">
+            <a:spAutoFit/>
+          </a:bodyPr>
+          <a:lstStyle/>
+          <a:p>
+            <a:pPr algn="l">
+              <a:lnSpc>
+                <a:spcPct val="100000"/>
+              </a:lnSpc>
+              <a:spcAft>
+                <a:spcPts val="0"/>
+              </a:spcAft>
+            </a:pPr>
+            <a:r>
+              <a:rPr sz="1250" b="1" i="0">
+                <a:solidFill>
+                  <a:srgbClr val="BD3039"/>
+                </a:solidFill>
+                <a:latin typeface="Calibri"/>
+              </a:rPr>
+              <a:t>THE SEQUENCE</a:t>
+            </a:r>
+          </a:p>
+        </p:txBody>
+      </p:sp>
+      <p:sp>
+        <p:nvSpPr>
+          <p:cNvPr id="3" name="TextBox 2"/>
+          <p:cNvSpPr txBox="1"/>
+          <p:nvPr/>
+        </p:nvSpPr>
+        <p:spPr>
+          <a:xfrm>
+            <a:off x="566928" y="658368"/>
+            <a:ext cx="11064240" cy="868680"/>
+          </a:xfrm>
+          <a:prstGeom prst="rect">
+            <a:avLst/>
+          </a:prstGeom>
+          <a:noFill/>
+        </p:spPr>
+        <p:txBody>
+          <a:bodyPr wrap="square" anchor="t" lIns="0" rIns="0" tIns="0" bIns="0">
+            <a:spAutoFit/>
+          </a:bodyPr>
+          <a:lstStyle/>
+          <a:p>
+            <a:pPr algn="l">
+              <a:lnSpc>
+                <a:spcPct val="100000"/>
+              </a:lnSpc>
+              <a:spcAft>
+                <a:spcPts val="0"/>
+              </a:spcAft>
+            </a:pPr>
+            <a:r>
+              <a:rPr sz="3000" b="1" i="0">
+                <a:solidFill>
+                  <a:srgbClr val="0C2340"/>
+                </a:solidFill>
+                <a:latin typeface="Cambria"/>
+              </a:rPr>
+              <a:t>Solve it this winter, from a position of strength</a:t>
+            </a:r>
+          </a:p>
+        </p:txBody>
+      </p:sp>
+      <p:sp>
+        <p:nvSpPr>
+          <p:cNvPr id="4" name="Oval 3"/>
+          <p:cNvSpPr/>
+          <p:nvPr/>
+        </p:nvSpPr>
+        <p:spPr>
+          <a:xfrm>
+            <a:off x="640080" y="1801368"/>
+            <a:ext cx="457200" cy="457200"/>
+          </a:xfrm>
+          <a:prstGeom prst="ellipse">
+            <a:avLst/>
+          </a:prstGeom>
+          <a:solidFill>
+            <a:srgbClr val="BD3039"/>
+          </a:solidFill>
+          <a:ln>
+            <a:noFill/>
+          </a:ln>
+          <a:effectLst/>
+        </p:spPr>
+        <p:style>
+          <a:lnRef idx="1">
+            <a:schemeClr val="accent1"/>
+          </a:lnRef>
+          <a:fillRef idx="3">
+            <a:schemeClr val="accent1"/>
+          </a:fillRef>
+          <a:effectRef idx="2">
+            <a:schemeClr val="accent1"/>
+          </a:effectRef>
+          <a:fontRef idx="minor">
+            <a:schemeClr val="lt1"/>
+          </a:fontRef>
+        </p:style>
+        <p:txBody>
+          <a:bodyPr rtlCol="0" anchor="ctr" wrap="none"/>
+          <a:lstStyle/>
+          <a:p>
+            <a:pPr algn="ctr"/>
+            <a:r>
+              <a:rPr sz="1800" b="1">
+                <a:solidFill>
+                  <a:srgbClr val="FFFFFF"/>
+                </a:solidFill>
+                <a:latin typeface="Cambria"/>
+              </a:rPr>
+              <a:t>1</a:t>
+            </a:r>
+          </a:p>
+        </p:txBody>
+      </p:sp>
+      <p:sp>
+        <p:nvSpPr>
+          <p:cNvPr id="5" name="TextBox 4"/>
+          <p:cNvSpPr txBox="1"/>
+          <p:nvPr/>
+        </p:nvSpPr>
+        <p:spPr>
+          <a:xfrm>
+            <a:off x="1280160" y="1783080"/>
+            <a:ext cx="6126480" cy="1005840"/>
+          </a:xfrm>
+          <a:prstGeom prst="rect">
+            <a:avLst/>
+          </a:prstGeom>
+          <a:noFill/>
+        </p:spPr>
+        <p:txBody>
+          <a:bodyPr wrap="square" anchor="t" lIns="0" rIns="0" tIns="0" bIns="0">
+            <a:spAutoFit/>
+          </a:bodyPr>
+          <a:lstStyle/>
+          <a:p>
+            <a:pPr algn="l">
+              <a:lnSpc>
+                <a:spcPct val="108000"/>
+              </a:lnSpc>
+              <a:spcAft>
+                <a:spcPts val="200"/>
+              </a:spcAft>
+            </a:pPr>
+            <a:r>
+              <a:rPr sz="1700" b="1" i="0">
+                <a:solidFill>
+                  <a:srgbClr val="0C2340"/>
+                </a:solidFill>
+                <a:latin typeface="Cambria"/>
+              </a:rPr>
+              <a:t>Hold through 2026</a:t>
+            </a:r>
+          </a:p>
+          <a:p>
+            <a:pPr algn="l">
+              <a:lnSpc>
+                <a:spcPct val="108000"/>
+              </a:lnSpc>
+              <a:spcAft>
+                <a:spcPts val="200"/>
+              </a:spcAft>
+            </a:pPr>
+            <a:r>
+              <a:rPr sz="1350" b="0" i="0">
+                <a:solidFill>
+                  <a:srgbClr val="6B7280"/>
+                </a:solidFill>
+                <a:latin typeface="Calibri"/>
+              </a:rPr>
+              <a:t>No contention urgency and Anthony hurt — keep Duran's bat, let his value rebound off an unlucky first half.</a:t>
+            </a:r>
+          </a:p>
+        </p:txBody>
+      </p:sp>
+      <p:sp>
+        <p:nvSpPr>
+          <p:cNvPr id="6" name="Oval 5"/>
+          <p:cNvSpPr/>
+          <p:nvPr/>
+        </p:nvSpPr>
+        <p:spPr>
+          <a:xfrm>
+            <a:off x="640080" y="2971800"/>
+            <a:ext cx="457200" cy="457200"/>
+          </a:xfrm>
+          <a:prstGeom prst="ellipse">
+            <a:avLst/>
+          </a:prstGeom>
+          <a:solidFill>
+            <a:srgbClr val="BD3039"/>
+          </a:solidFill>
+          <a:ln>
+            <a:noFill/>
+          </a:ln>
+          <a:effectLst/>
+        </p:spPr>
+        <p:style>
+          <a:lnRef idx="1">
+            <a:schemeClr val="accent1"/>
+          </a:lnRef>
+          <a:fillRef idx="3">
+            <a:schemeClr val="accent1"/>
+          </a:fillRef>
+          <a:effectRef idx="2">
+            <a:schemeClr val="accent1"/>
+          </a:effectRef>
+          <a:fontRef idx="minor">
+            <a:schemeClr val="lt1"/>
+          </a:fontRef>
+        </p:style>
+        <p:txBody>
+          <a:bodyPr rtlCol="0" anchor="ctr" wrap="none"/>
+          <a:lstStyle/>
+          <a:p>
+            <a:pPr algn="ctr"/>
+            <a:r>
+              <a:rPr sz="1800" b="1">
+                <a:solidFill>
+                  <a:srgbClr val="FFFFFF"/>
+                </a:solidFill>
+                <a:latin typeface="Cambria"/>
+              </a:rPr>
+              <a:t>2</a:t>
+            </a:r>
+          </a:p>
+        </p:txBody>
+      </p:sp>
+      <p:sp>
+        <p:nvSpPr>
+          <p:cNvPr id="7" name="TextBox 6"/>
+          <p:cNvSpPr txBox="1"/>
+          <p:nvPr/>
+        </p:nvSpPr>
+        <p:spPr>
+          <a:xfrm>
+            <a:off x="1280160" y="2953512"/>
+            <a:ext cx="6126480" cy="1005840"/>
+          </a:xfrm>
+          <a:prstGeom prst="rect">
+            <a:avLst/>
+          </a:prstGeom>
+          <a:noFill/>
+        </p:spPr>
+        <p:txBody>
+          <a:bodyPr wrap="square" anchor="t" lIns="0" rIns="0" tIns="0" bIns="0">
+            <a:spAutoFit/>
+          </a:bodyPr>
+          <a:lstStyle/>
+          <a:p>
+            <a:pPr algn="l">
+              <a:lnSpc>
+                <a:spcPct val="108000"/>
+              </a:lnSpc>
+              <a:spcAft>
+                <a:spcPts val="200"/>
+              </a:spcAft>
+            </a:pPr>
+            <a:r>
+              <a:rPr sz="1700" b="1" i="0">
+                <a:solidFill>
+                  <a:srgbClr val="0C2340"/>
+                </a:solidFill>
+                <a:latin typeface="Cambria"/>
+              </a:rPr>
+              <a:t>Deal Duran in the offseason</a:t>
+            </a:r>
+          </a:p>
+          <a:p>
+            <a:pPr algn="l">
+              <a:lnSpc>
+                <a:spcPct val="108000"/>
+              </a:lnSpc>
+              <a:spcAft>
+                <a:spcPts val="200"/>
+              </a:spcAft>
+            </a:pPr>
+            <a:r>
+              <a:rPr sz="1350" b="0" i="0">
+                <a:solidFill>
+                  <a:srgbClr val="6B7280"/>
+                </a:solidFill>
+                <a:latin typeface="Calibri"/>
+              </a:rPr>
+              <a:t>Anthony's healthy (jam returns), value restored. Trade him — plus Yoshida money — for controllable bats, not arms.</a:t>
+            </a:r>
+          </a:p>
+        </p:txBody>
+      </p:sp>
+      <p:sp>
+        <p:nvSpPr>
+          <p:cNvPr id="8" name="Oval 7"/>
+          <p:cNvSpPr/>
+          <p:nvPr/>
+        </p:nvSpPr>
+        <p:spPr>
+          <a:xfrm>
+            <a:off x="640080" y="4142231"/>
+            <a:ext cx="457200" cy="457200"/>
+          </a:xfrm>
+          <a:prstGeom prst="ellipse">
+            <a:avLst/>
+          </a:prstGeom>
+          <a:solidFill>
+            <a:srgbClr val="BD3039"/>
+          </a:solidFill>
+          <a:ln>
+            <a:noFill/>
+          </a:ln>
+          <a:effectLst/>
+        </p:spPr>
+        <p:style>
+          <a:lnRef idx="1">
+            <a:schemeClr val="accent1"/>
+          </a:lnRef>
+          <a:fillRef idx="3">
+            <a:schemeClr val="accent1"/>
+          </a:fillRef>
+          <a:effectRef idx="2">
+            <a:schemeClr val="accent1"/>
+          </a:effectRef>
+          <a:fontRef idx="minor">
+            <a:schemeClr val="lt1"/>
+          </a:fontRef>
+        </p:style>
+        <p:txBody>
+          <a:bodyPr rtlCol="0" anchor="ctr" wrap="none"/>
+          <a:lstStyle/>
+          <a:p>
+            <a:pPr algn="ctr"/>
+            <a:r>
+              <a:rPr sz="1800" b="1">
+                <a:solidFill>
+                  <a:srgbClr val="FFFFFF"/>
+                </a:solidFill>
+                <a:latin typeface="Cambria"/>
+              </a:rPr>
+              <a:t>3</a:t>
+            </a:r>
+          </a:p>
+        </p:txBody>
+      </p:sp>
+      <p:sp>
+        <p:nvSpPr>
+          <p:cNvPr id="9" name="TextBox 8"/>
+          <p:cNvSpPr txBox="1"/>
+          <p:nvPr/>
+        </p:nvSpPr>
+        <p:spPr>
+          <a:xfrm>
+            <a:off x="1280160" y="4123944"/>
+            <a:ext cx="6126480" cy="1005840"/>
+          </a:xfrm>
+          <a:prstGeom prst="rect">
+            <a:avLst/>
+          </a:prstGeom>
+          <a:noFill/>
+        </p:spPr>
+        <p:txBody>
+          <a:bodyPr wrap="square" anchor="t" lIns="0" rIns="0" tIns="0" bIns="0">
+            <a:spAutoFit/>
+          </a:bodyPr>
+          <a:lstStyle/>
+          <a:p>
+            <a:pPr algn="l">
+              <a:lnSpc>
+                <a:spcPct val="108000"/>
+              </a:lnSpc>
+              <a:spcAft>
+                <a:spcPts val="200"/>
+              </a:spcAft>
+            </a:pPr>
+            <a:r>
+              <a:rPr sz="1700" b="1" i="0">
+                <a:solidFill>
+                  <a:srgbClr val="0C2340"/>
+                </a:solidFill>
+                <a:latin typeface="Cambria"/>
+              </a:rPr>
+              <a:t>Run it back in 2027</a:t>
+            </a:r>
+          </a:p>
+          <a:p>
+            <a:pPr algn="l">
+              <a:lnSpc>
+                <a:spcPct val="108000"/>
+              </a:lnSpc>
+              <a:spcAft>
+                <a:spcPts val="200"/>
+              </a:spcAft>
+            </a:pPr>
+            <a:r>
+              <a:rPr sz="1350" b="0" i="0">
+                <a:solidFill>
+                  <a:srgbClr val="6B7280"/>
+                </a:solidFill>
+                <a:latin typeface="Calibri"/>
+              </a:rPr>
+              <a:t>OF = Anthony / Rafaela / Abreu; strong rotation intact; DH opens after 2027. A cheaper, younger, more balanced roster.</a:t>
+            </a:r>
+          </a:p>
+        </p:txBody>
+      </p:sp>
+      <p:sp>
+        <p:nvSpPr>
+          <p:cNvPr id="10" name="Rounded Rectangle 9"/>
+          <p:cNvSpPr/>
+          <p:nvPr/>
+        </p:nvSpPr>
+        <p:spPr>
+          <a:xfrm>
+            <a:off x="7818120" y="1783080"/>
+            <a:ext cx="3794760" cy="3337560"/>
+          </a:xfrm>
+          <a:prstGeom prst="roundRect">
+            <a:avLst>
+              <a:gd name="adj" fmla="val 8000"/>
+            </a:avLst>
+          </a:prstGeom>
+          <a:solidFill>
+            <a:srgbClr val="0C2340"/>
+          </a:solidFill>
+          <a:ln>
+            <a:noFill/>
+          </a:ln>
+          <a:effectLst/>
+        </p:spPr>
+        <p:style>
+          <a:lnRef idx="1">
+            <a:schemeClr val="accent1"/>
+          </a:lnRef>
+          <a:fillRef idx="3">
+            <a:schemeClr val="accent1"/>
+          </a:fillRef>
+          <a:effectRef idx="2">
+            <a:schemeClr val="accent1"/>
+          </a:effectRef>
+          <a:fontRef idx="minor">
+            <a:schemeClr val="lt1"/>
+          </a:fontRef>
+        </p:style>
+        <p:txBody>
+          <a:bodyPr rtlCol="0" anchor="ctr"/>
+          <a:lstStyle/>
+          <a:p>
+            <a:pPr algn="ctr"/>
+          </a:p>
+        </p:txBody>
+      </p:sp>
+      <p:sp>
+        <p:nvSpPr>
+          <p:cNvPr id="11" name="TextBox 10"/>
+          <p:cNvSpPr txBox="1"/>
+          <p:nvPr/>
+        </p:nvSpPr>
+        <p:spPr>
+          <a:xfrm>
+            <a:off x="8092440" y="2011680"/>
+            <a:ext cx="3291840" cy="365760"/>
+          </a:xfrm>
+          <a:prstGeom prst="rect">
+            <a:avLst/>
+          </a:prstGeom>
+          <a:noFill/>
+        </p:spPr>
+        <p:txBody>
+          <a:bodyPr wrap="square" anchor="t" lIns="0" rIns="0" tIns="0" bIns="0">
+            <a:spAutoFit/>
+          </a:bodyPr>
+          <a:lstStyle/>
+          <a:p>
+            <a:pPr algn="l">
+              <a:lnSpc>
+                <a:spcPct val="100000"/>
+              </a:lnSpc>
+              <a:spcAft>
+                <a:spcPts val="0"/>
+              </a:spcAft>
+            </a:pPr>
+            <a:r>
+              <a:rPr sz="1250" b="1" i="0">
+                <a:solidFill>
+                  <a:srgbClr val="C9D2E3"/>
+                </a:solidFill>
+                <a:latin typeface="Calibri"/>
+              </a:rPr>
+              <a:t>THE RETURN</a:t>
+            </a:r>
+          </a:p>
+        </p:txBody>
+      </p:sp>
+      <p:sp>
+        <p:nvSpPr>
+          <p:cNvPr id="12" name="TextBox 11"/>
+          <p:cNvSpPr txBox="1"/>
+          <p:nvPr/>
+        </p:nvSpPr>
+        <p:spPr>
+          <a:xfrm>
+            <a:off x="8092440" y="2487168"/>
+            <a:ext cx="3291840" cy="914400"/>
+          </a:xfrm>
+          <a:prstGeom prst="rect">
+            <a:avLst/>
+          </a:prstGeom>
+          <a:noFill/>
+        </p:spPr>
+        <p:txBody>
+          <a:bodyPr wrap="square" anchor="t" lIns="0" rIns="0" tIns="0" bIns="0">
+            <a:spAutoFit/>
+          </a:bodyPr>
+          <a:lstStyle/>
+          <a:p>
+            <a:pPr algn="l">
+              <a:lnSpc>
+                <a:spcPct val="105000"/>
+              </a:lnSpc>
+              <a:spcAft>
+                <a:spcPts val="200"/>
+              </a:spcAft>
+            </a:pPr>
+            <a:r>
+              <a:rPr sz="1300" b="1" i="0">
+                <a:solidFill>
+                  <a:srgbClr val="F0B8BC"/>
+                </a:solidFill>
+                <a:latin typeface="Calibri"/>
+              </a:rPr>
+              <a:t>Sell now (nadir)</a:t>
+            </a:r>
+          </a:p>
+          <a:p>
+            <a:pPr algn="l">
+              <a:lnSpc>
+                <a:spcPct val="105000"/>
+              </a:lnSpc>
+              <a:spcAft>
+                <a:spcPts val="200"/>
+              </a:spcAft>
+            </a:pPr>
+            <a:r>
+              <a:rPr sz="1400" b="0" i="0">
+                <a:solidFill>
+                  <a:srgbClr val="FFFFFF"/>
+                </a:solidFill>
+                <a:latin typeface="Calibri"/>
+              </a:rPr>
+              <a:t>~$10–15M · a 45-FV bat</a:t>
+            </a:r>
+          </a:p>
+        </p:txBody>
+      </p:sp>
+      <p:sp>
+        <p:nvSpPr>
+          <p:cNvPr id="13" name="TextBox 12"/>
+          <p:cNvSpPr txBox="1"/>
+          <p:nvPr/>
+        </p:nvSpPr>
+        <p:spPr>
+          <a:xfrm>
+            <a:off x="8092440" y="3520440"/>
+            <a:ext cx="3291840" cy="1005840"/>
+          </a:xfrm>
+          <a:prstGeom prst="rect">
+            <a:avLst/>
+          </a:prstGeom>
+          <a:noFill/>
+        </p:spPr>
+        <p:txBody>
+          <a:bodyPr wrap="square" anchor="t" lIns="0" rIns="0" tIns="0" bIns="0">
+            <a:spAutoFit/>
+          </a:bodyPr>
+          <a:lstStyle/>
+          <a:p>
+            <a:pPr algn="l">
+              <a:lnSpc>
+                <a:spcPct val="105000"/>
+              </a:lnSpc>
+              <a:spcAft>
+                <a:spcPts val="200"/>
+              </a:spcAft>
+            </a:pPr>
+            <a:r>
+              <a:rPr sz="1300" b="1" i="0">
+                <a:solidFill>
+                  <a:srgbClr val="A9E5B5"/>
+                </a:solidFill>
+                <a:latin typeface="Calibri"/>
+              </a:rPr>
+              <a:t>Sell after rebound</a:t>
+            </a:r>
+          </a:p>
+          <a:p>
+            <a:pPr algn="l">
+              <a:lnSpc>
+                <a:spcPct val="105000"/>
+              </a:lnSpc>
+              <a:spcAft>
+                <a:spcPts val="200"/>
+              </a:spcAft>
+            </a:pPr>
+            <a:r>
+              <a:rPr sz="1400" b="0" i="0">
+                <a:solidFill>
+                  <a:srgbClr val="FFFFFF"/>
+                </a:solidFill>
+                <a:latin typeface="Calibri"/>
+              </a:rPr>
+              <a:t>~$28M · a 50-FV, top-100</a:t>
+            </a:r>
+          </a:p>
+          <a:p>
+            <a:pPr algn="l">
+              <a:lnSpc>
+                <a:spcPct val="105000"/>
+              </a:lnSpc>
+              <a:spcAft>
+                <a:spcPts val="200"/>
+              </a:spcAft>
+            </a:pPr>
+            <a:r>
+              <a:rPr sz="1400" b="0" i="0">
+                <a:solidFill>
+                  <a:srgbClr val="FFFFFF"/>
+                </a:solidFill>
+                <a:latin typeface="Calibri"/>
+              </a:rPr>
+              <a:t>controllable talent</a:t>
+            </a:r>
+          </a:p>
+        </p:txBody>
+      </p:sp>
+      <p:sp>
+        <p:nvSpPr>
+          <p:cNvPr id="14" name="TextBox 13"/>
+          <p:cNvSpPr txBox="1"/>
+          <p:nvPr/>
+        </p:nvSpPr>
+        <p:spPr>
+          <a:xfrm>
+            <a:off x="8092440" y="4617720"/>
+            <a:ext cx="3291840" cy="457200"/>
+          </a:xfrm>
+          <a:prstGeom prst="rect">
+            <a:avLst/>
+          </a:prstGeom>
+          <a:noFill/>
+        </p:spPr>
+        <p:txBody>
+          <a:bodyPr wrap="square" anchor="t" lIns="0" rIns="0" tIns="0" bIns="0">
+            <a:spAutoFit/>
+          </a:bodyPr>
+          <a:lstStyle/>
+          <a:p>
+            <a:pPr algn="l">
+              <a:lnSpc>
+                <a:spcPct val="105000"/>
+              </a:lnSpc>
+              <a:spcAft>
+                <a:spcPts val="400"/>
+              </a:spcAft>
+            </a:pPr>
+            <a:r>
+              <a:rPr sz="1150" b="0" i="1">
+                <a:solidFill>
+                  <a:srgbClr val="C9D2E3"/>
+                </a:solidFill>
+                <a:latin typeface="Calibri"/>
+              </a:rPr>
+              <a:t>One grade of return = the reason to wait.</a:t>
+            </a:r>
+          </a:p>
+        </p:txBody>
+      </p:sp>
+      <p:sp>
+        <p:nvSpPr>
+          <p:cNvPr id="15" name="TextBox 14"/>
+          <p:cNvSpPr txBox="1"/>
+          <p:nvPr/>
+        </p:nvSpPr>
+        <p:spPr>
+          <a:xfrm>
+            <a:off x="566928" y="6510528"/>
+            <a:ext cx="11064240" cy="274320"/>
+          </a:xfrm>
+          <a:prstGeom prst="rect">
+            <a:avLst/>
+          </a:prstGeom>
+          <a:noFill/>
+        </p:spPr>
+        <p:txBody>
+          <a:bodyPr wrap="square" anchor="t" lIns="0" rIns="0" tIns="0" bIns="0">
+            <a:spAutoFit/>
+          </a:bodyPr>
+          <a:lstStyle/>
+          <a:p>
+            <a:pPr algn="l">
+              <a:lnSpc>
+                <a:spcPct val="100000"/>
+              </a:lnSpc>
+              <a:spcAft>
+                <a:spcPts val="0"/>
+              </a:spcAft>
+            </a:pPr>
+            <a:r>
+              <a:rPr sz="900" b="0" i="0">
+                <a:solidFill>
+                  <a:srgbClr val="6B7280"/>
+                </a:solidFill>
+                <a:latin typeface="Calibri"/>
+              </a:rPr>
+              <a:t>Boston Red Sox · Outfield Strategy</a:t>
+            </a:r>
+            <a:r>
+              <a:rPr sz="900" b="0" i="0">
+                <a:solidFill>
+                  <a:srgbClr val="6B7280"/>
+                </a:solidFill>
+                <a:latin typeface="Calibri"/>
+              </a:rPr>
+              <a:t>      Analysis: Statcast / FanGraphs / MLB Stats API · salary Spotrac · July 2026</a:t>
+            </a:r>
+          </a:p>
+        </p:txBody>
+      </p:sp>
+    </p:spTree>
+  </p:cSld>
+  <p:clrMapOvr>
+    <a:masterClrMapping/>
+  </p:clrMapOvr>
+</p:sld>
+</file>
+
+<file path=ppt/slides/slide12.xml><?xml version="1.0" encoding="utf-8"?>
 <p:sld xmlns:a="http://schemas.openxmlformats.org/drawingml/2006/main" xmlns:p="http://schemas.openxmlformats.org/presentationml/2006/main" xmlns:r="http://schemas.openxmlformats.org/officeDocument/2006/relationships">
   <p:cSld>
     <p:bg>
@@ -8302,7 +8970,7 @@
                 </a:solidFill>
                 <a:latin typeface="Calibri"/>
               </a:rPr>
-              <a:t>CONTEXT</a:t>
+              <a:t>THE TIEBREAKER</a:t>
             </a:r>
           </a:p>
         </p:txBody>
@@ -8344,14 +9012,14 @@
                 </a:solidFill>
                 <a:latin typeface="Cambria"/>
               </a:rPr>
-              <a:t>Aging doesn't explain the drop — regression and luck do</a:t>
+              <a:t>The bat speed says it's the approach — not the body</a:t>
             </a:r>
           </a:p>
         </p:txBody>
       </p:sp>
       <p:pic>
         <p:nvPicPr>
-          <p:cNvPr id="4" name="Picture 3" descr="04_age_curve_overlay.png"/>
+          <p:cNvPr id="4" name="Picture 3" descr="10_erosion_decomposition.png"/>
           <p:cNvPicPr>
             <a:picLocks noChangeAspect="1"/>
           </p:cNvPicPr>
@@ -8365,8 +9033,8 @@
         </p:blipFill>
         <p:spPr>
           <a:xfrm>
-            <a:off x="2811779" y="1508760"/>
-            <a:ext cx="6583680" cy="4114800"/>
+            <a:off x="1597621" y="1554480"/>
+            <a:ext cx="8993709" cy="2926080"/>
           </a:xfrm>
           <a:prstGeom prst="rect">
             <a:avLst/>
@@ -8375,58 +9043,430 @@
       </p:pic>
       <p:sp>
         <p:nvSpPr>
-          <p:cNvPr id="5" name="TextBox 4"/>
-          <p:cNvSpPr txBox="1"/>
-          <p:nvPr/>
-        </p:nvSpPr>
-        <p:spPr>
-          <a:xfrm>
-            <a:off x="566928" y="5806440"/>
-            <a:ext cx="11064240" cy="640080"/>
-          </a:xfrm>
-          <a:prstGeom prst="rect">
-            <a:avLst/>
-          </a:prstGeom>
-          <a:noFill/>
-        </p:spPr>
-        <p:txBody>
-          <a:bodyPr wrap="square" anchor="t" lIns="0" rIns="0" tIns="0" bIns="0">
-            <a:spAutoFit/>
-          </a:bodyPr>
-          <a:lstStyle/>
-          <a:p>
-            <a:pPr algn="l">
-              <a:lnSpc>
-                <a:spcPct val="110000"/>
+          <p:cNvPr id="5" name="Rounded Rectangle 4"/>
+          <p:cNvSpPr/>
+          <p:nvPr/>
+        </p:nvSpPr>
+        <p:spPr>
+          <a:xfrm>
+            <a:off x="566928" y="4617720"/>
+            <a:ext cx="3502152" cy="1691640"/>
+          </a:xfrm>
+          <a:prstGeom prst="roundRect">
+            <a:avLst>
+              <a:gd name="adj" fmla="val 8000"/>
+            </a:avLst>
+          </a:prstGeom>
+          <a:solidFill>
+            <a:srgbClr val="FFFFFF"/>
+          </a:solidFill>
+          <a:ln w="12700">
+            <a:solidFill>
+              <a:srgbClr val="D7DAE0"/>
+            </a:solidFill>
+          </a:ln>
+          <a:effectLst/>
+        </p:spPr>
+        <p:style>
+          <a:lnRef idx="1">
+            <a:schemeClr val="accent1"/>
+          </a:lnRef>
+          <a:fillRef idx="3">
+            <a:schemeClr val="accent1"/>
+          </a:fillRef>
+          <a:effectRef idx="2">
+            <a:schemeClr val="accent1"/>
+          </a:effectRef>
+          <a:fontRef idx="minor">
+            <a:schemeClr val="lt1"/>
+          </a:fontRef>
+        </p:style>
+        <p:txBody>
+          <a:bodyPr rtlCol="0" anchor="ctr"/>
+          <a:lstStyle/>
+          <a:p>
+            <a:pPr algn="ctr"/>
+          </a:p>
+        </p:txBody>
+      </p:sp>
+      <p:sp>
+        <p:nvSpPr>
+          <p:cNvPr id="6" name="TextBox 5"/>
+          <p:cNvSpPr txBox="1"/>
+          <p:nvPr/>
+        </p:nvSpPr>
+        <p:spPr>
+          <a:xfrm>
+            <a:off x="804672" y="4754880"/>
+            <a:ext cx="3044952" cy="457200"/>
+          </a:xfrm>
+          <a:prstGeom prst="rect">
+            <a:avLst/>
+          </a:prstGeom>
+          <a:noFill/>
+        </p:spPr>
+        <p:txBody>
+          <a:bodyPr wrap="square" anchor="t" lIns="0" rIns="0" tIns="0" bIns="0">
+            <a:spAutoFit/>
+          </a:bodyPr>
+          <a:lstStyle/>
+          <a:p>
+            <a:pPr algn="l">
+              <a:lnSpc>
+                <a:spcPct val="100000"/>
+              </a:lnSpc>
+              <a:spcAft>
+                <a:spcPts val="0"/>
+              </a:spcAft>
+            </a:pPr>
+            <a:r>
+              <a:rPr sz="2100" b="1" i="0">
+                <a:solidFill>
+                  <a:srgbClr val="2E7D32"/>
+                </a:solidFill>
+                <a:latin typeface="Cambria"/>
+              </a:rPr>
+              <a:t>74.5 mph</a:t>
+            </a:r>
+            <a:r>
+              <a:rPr sz="1050" b="0" i="0">
+                <a:solidFill>
+                  <a:srgbClr val="6B7280"/>
+                </a:solidFill>
+                <a:latin typeface="Calibri"/>
+              </a:rPr>
+              <a:t>  avg bat speed, 2026 — UP from 72.7 in '24</a:t>
+            </a:r>
+          </a:p>
+        </p:txBody>
+      </p:sp>
+      <p:sp>
+        <p:nvSpPr>
+          <p:cNvPr id="7" name="TextBox 6"/>
+          <p:cNvSpPr txBox="1"/>
+          <p:nvPr/>
+        </p:nvSpPr>
+        <p:spPr>
+          <a:xfrm>
+            <a:off x="804672" y="5285232"/>
+            <a:ext cx="3044952" cy="914400"/>
+          </a:xfrm>
+          <a:prstGeom prst="rect">
+            <a:avLst/>
+          </a:prstGeom>
+          <a:noFill/>
+        </p:spPr>
+        <p:txBody>
+          <a:bodyPr wrap="square" anchor="t" lIns="0" rIns="0" tIns="0" bIns="0">
+            <a:spAutoFit/>
+          </a:bodyPr>
+          <a:lstStyle/>
+          <a:p>
+            <a:pPr algn="l">
+              <a:lnSpc>
+                <a:spcPct val="107000"/>
               </a:lnSpc>
               <a:spcAft>
                 <a:spcPts val="400"/>
               </a:spcAft>
             </a:pPr>
             <a:r>
-              <a:rPr sz="1400" b="0" i="0">
+              <a:rPr sz="1080" b="0" i="0">
                 <a:solidFill>
                   <a:srgbClr val="20232A"/>
                 </a:solidFill>
                 <a:latin typeface="Calibri"/>
               </a:rPr>
-              <a:t>2024 → 2026 wRC+ fell ~70 points; a normal age 27→29 curve predicts only ~7. </a:t>
-            </a:r>
-            <a:r>
-              <a:rPr sz="1400" b="1" i="0">
+              <a:t>A declining hitter swings slower. Duran is swinging harder, longer and steeper — pressing, not fading.</a:t>
+            </a:r>
+          </a:p>
+        </p:txBody>
+      </p:sp>
+      <p:sp>
+        <p:nvSpPr>
+          <p:cNvPr id="8" name="Rounded Rectangle 7"/>
+          <p:cNvSpPr/>
+          <p:nvPr/>
+        </p:nvSpPr>
+        <p:spPr>
+          <a:xfrm>
+            <a:off x="4352544" y="4617720"/>
+            <a:ext cx="3502152" cy="1691640"/>
+          </a:xfrm>
+          <a:prstGeom prst="roundRect">
+            <a:avLst>
+              <a:gd name="adj" fmla="val 8000"/>
+            </a:avLst>
+          </a:prstGeom>
+          <a:solidFill>
+            <a:srgbClr val="FFFFFF"/>
+          </a:solidFill>
+          <a:ln w="12700">
+            <a:solidFill>
+              <a:srgbClr val="D7DAE0"/>
+            </a:solidFill>
+          </a:ln>
+          <a:effectLst/>
+        </p:spPr>
+        <p:style>
+          <a:lnRef idx="1">
+            <a:schemeClr val="accent1"/>
+          </a:lnRef>
+          <a:fillRef idx="3">
+            <a:schemeClr val="accent1"/>
+          </a:fillRef>
+          <a:effectRef idx="2">
+            <a:schemeClr val="accent1"/>
+          </a:effectRef>
+          <a:fontRef idx="minor">
+            <a:schemeClr val="lt1"/>
+          </a:fontRef>
+        </p:style>
+        <p:txBody>
+          <a:bodyPr rtlCol="0" anchor="ctr"/>
+          <a:lstStyle/>
+          <a:p>
+            <a:pPr algn="ctr"/>
+          </a:p>
+        </p:txBody>
+      </p:sp>
+      <p:sp>
+        <p:nvSpPr>
+          <p:cNvPr id="9" name="TextBox 8"/>
+          <p:cNvSpPr txBox="1"/>
+          <p:nvPr/>
+        </p:nvSpPr>
+        <p:spPr>
+          <a:xfrm>
+            <a:off x="4590288" y="4754880"/>
+            <a:ext cx="3044952" cy="457200"/>
+          </a:xfrm>
+          <a:prstGeom prst="rect">
+            <a:avLst/>
+          </a:prstGeom>
+          <a:noFill/>
+        </p:spPr>
+        <p:txBody>
+          <a:bodyPr wrap="square" anchor="t" lIns="0" rIns="0" tIns="0" bIns="0">
+            <a:spAutoFit/>
+          </a:bodyPr>
+          <a:lstStyle/>
+          <a:p>
+            <a:pPr algn="l">
+              <a:lnSpc>
+                <a:spcPct val="100000"/>
+              </a:lnSpc>
+              <a:spcAft>
+                <a:spcPts val="0"/>
+              </a:spcAft>
+            </a:pPr>
+            <a:r>
+              <a:rPr sz="2100" b="1" i="0">
+                <a:solidFill>
+                  <a:srgbClr val="BD3039"/>
+                </a:solidFill>
+                <a:latin typeface="Cambria"/>
+              </a:rPr>
+              <a:t>29% whiff vs 95+</a:t>
+            </a:r>
+            <a:r>
+              <a:rPr sz="1050" b="0" i="0">
+                <a:solidFill>
+                  <a:srgbClr val="6B7280"/>
+                </a:solidFill>
+                <a:latin typeface="Calibri"/>
+              </a:rPr>
+              <a:t>  up from 16% in '24 — but not bat-death</a:t>
+            </a:r>
+          </a:p>
+        </p:txBody>
+      </p:sp>
+      <p:sp>
+        <p:nvSpPr>
+          <p:cNvPr id="10" name="TextBox 9"/>
+          <p:cNvSpPr txBox="1"/>
+          <p:nvPr/>
+        </p:nvSpPr>
+        <p:spPr>
+          <a:xfrm>
+            <a:off x="4590288" y="5285232"/>
+            <a:ext cx="3044952" cy="914400"/>
+          </a:xfrm>
+          <a:prstGeom prst="rect">
+            <a:avLst/>
+          </a:prstGeom>
+          <a:noFill/>
+        </p:spPr>
+        <p:txBody>
+          <a:bodyPr wrap="square" anchor="t" lIns="0" rIns="0" tIns="0" bIns="0">
+            <a:spAutoFit/>
+          </a:bodyPr>
+          <a:lstStyle/>
+          <a:p>
+            <a:pPr algn="l">
+              <a:lnSpc>
+                <a:spcPct val="107000"/>
+              </a:lnSpc>
+              <a:spcAft>
+                <a:spcPts val="400"/>
+              </a:spcAft>
+            </a:pPr>
+            <a:r>
+              <a:rPr sz="1080" b="0" i="0">
+                <a:solidFill>
+                  <a:srgbClr val="20232A"/>
+                </a:solidFill>
+                <a:latin typeface="Calibri"/>
+              </a:rPr>
+              <a:t>Whiffs on a rising bat speed = selling out. The chase leak is velo/offspeed; breaking-ball chase actually improved.</a:t>
+            </a:r>
+          </a:p>
+        </p:txBody>
+      </p:sp>
+      <p:sp>
+        <p:nvSpPr>
+          <p:cNvPr id="11" name="Rounded Rectangle 10"/>
+          <p:cNvSpPr/>
+          <p:nvPr/>
+        </p:nvSpPr>
+        <p:spPr>
+          <a:xfrm>
+            <a:off x="8138159" y="4617720"/>
+            <a:ext cx="3502152" cy="1691640"/>
+          </a:xfrm>
+          <a:prstGeom prst="roundRect">
+            <a:avLst>
+              <a:gd name="adj" fmla="val 8000"/>
+            </a:avLst>
+          </a:prstGeom>
+          <a:solidFill>
+            <a:srgbClr val="FFFFFF"/>
+          </a:solidFill>
+          <a:ln w="12700">
+            <a:solidFill>
+              <a:srgbClr val="D7DAE0"/>
+            </a:solidFill>
+          </a:ln>
+          <a:effectLst/>
+        </p:spPr>
+        <p:style>
+          <a:lnRef idx="1">
+            <a:schemeClr val="accent1"/>
+          </a:lnRef>
+          <a:fillRef idx="3">
+            <a:schemeClr val="accent1"/>
+          </a:fillRef>
+          <a:effectRef idx="2">
+            <a:schemeClr val="accent1"/>
+          </a:effectRef>
+          <a:fontRef idx="minor">
+            <a:schemeClr val="lt1"/>
+          </a:fontRef>
+        </p:style>
+        <p:txBody>
+          <a:bodyPr rtlCol="0" anchor="ctr"/>
+          <a:lstStyle/>
+          <a:p>
+            <a:pPr algn="ctr"/>
+          </a:p>
+        </p:txBody>
+      </p:sp>
+      <p:sp>
+        <p:nvSpPr>
+          <p:cNvPr id="12" name="TextBox 11"/>
+          <p:cNvSpPr txBox="1"/>
+          <p:nvPr/>
+        </p:nvSpPr>
+        <p:spPr>
+          <a:xfrm>
+            <a:off x="8375903" y="4754880"/>
+            <a:ext cx="3044952" cy="457200"/>
+          </a:xfrm>
+          <a:prstGeom prst="rect">
+            <a:avLst/>
+          </a:prstGeom>
+          <a:noFill/>
+        </p:spPr>
+        <p:txBody>
+          <a:bodyPr wrap="square" anchor="t" lIns="0" rIns="0" tIns="0" bIns="0">
+            <a:spAutoFit/>
+          </a:bodyPr>
+          <a:lstStyle/>
+          <a:p>
+            <a:pPr algn="l">
+              <a:lnSpc>
+                <a:spcPct val="100000"/>
+              </a:lnSpc>
+              <a:spcAft>
+                <a:spcPts val="0"/>
+              </a:spcAft>
+            </a:pPr>
+            <a:r>
+              <a:rPr sz="2100" b="1" i="0">
                 <a:solidFill>
                   <a:srgbClr val="0C2340"/>
                 </a:solidFill>
-                <a:latin typeface="Calibri"/>
-              </a:rPr>
-              <a:t>The gap is mean-reversion from an inflated peak plus a 2026 bad-luck tail — not skill cliff.</a:t>
-            </a:r>
-          </a:p>
-        </p:txBody>
-      </p:sp>
-      <p:sp>
-        <p:nvSpPr>
-          <p:cNvPr id="6" name="TextBox 5"/>
+                <a:latin typeface="Cambria"/>
+              </a:rPr>
+              <a:t>60 / 40</a:t>
+            </a:r>
+            <a:r>
+              <a:rPr sz="1050" b="0" i="0">
+                <a:solidFill>
+                  <a:srgbClr val="6B7280"/>
+                </a:solidFill>
+                <a:latin typeface="Calibri"/>
+              </a:rPr>
+              <a:t>  re-weighted scenario odds → 60% rebound</a:t>
+            </a:r>
+          </a:p>
+        </p:txBody>
+      </p:sp>
+      <p:sp>
+        <p:nvSpPr>
+          <p:cNvPr id="13" name="TextBox 12"/>
+          <p:cNvSpPr txBox="1"/>
+          <p:nvPr/>
+        </p:nvSpPr>
+        <p:spPr>
+          <a:xfrm>
+            <a:off x="8375903" y="5285232"/>
+            <a:ext cx="3044952" cy="914400"/>
+          </a:xfrm>
+          <a:prstGeom prst="rect">
+            <a:avLst/>
+          </a:prstGeom>
+          <a:noFill/>
+        </p:spPr>
+        <p:txBody>
+          <a:bodyPr wrap="square" anchor="t" lIns="0" rIns="0" tIns="0" bIns="0">
+            <a:spAutoFit/>
+          </a:bodyPr>
+          <a:lstStyle/>
+          <a:p>
+            <a:pPr algn="l">
+              <a:lnSpc>
+                <a:spcPct val="107000"/>
+              </a:lnSpc>
+              <a:spcAft>
+                <a:spcPts val="400"/>
+              </a:spcAft>
+            </a:pPr>
+            <a:r>
+              <a:rPr sz="1080" b="0" i="0">
+                <a:solidFill>
+                  <a:srgbClr val="20232A"/>
+                </a:solidFill>
+                <a:latin typeface="Calibri"/>
+              </a:rPr>
+              <a:t>Approach is fixable (see his own 2022→23 chase overhaul); the tools a buyer prices are intact.</a:t>
+            </a:r>
+          </a:p>
+        </p:txBody>
+      </p:sp>
+      <p:sp>
+        <p:nvSpPr>
+          <p:cNvPr id="14" name="TextBox 13"/>
           <p:cNvSpPr txBox="1"/>
           <p:nvPr/>
         </p:nvSpPr>
@@ -8538,7 +9578,7 @@
                 </a:solidFill>
                 <a:latin typeface="Calibri"/>
               </a:rPr>
-              <a:t>WHAT TO GET BACK</a:t>
+              <a:t>CONTEXT</a:t>
             </a:r>
           </a:p>
         </p:txBody>
@@ -8580,20 +9620,44 @@
                 </a:solidFill>
                 <a:latin typeface="Cambria"/>
               </a:rPr>
-              <a:t>Pitching is the strength — spend the surplus on offense</a:t>
-            </a:r>
-          </a:p>
-        </p:txBody>
-      </p:sp>
-      <p:sp>
-        <p:nvSpPr>
-          <p:cNvPr id="4" name="TextBox 3"/>
-          <p:cNvSpPr txBox="1"/>
-          <p:nvPr/>
-        </p:nvSpPr>
-        <p:spPr>
-          <a:xfrm>
-            <a:off x="566928" y="1572768"/>
+              <a:t>Aging doesn't explain the drop — regression and luck do</a:t>
+            </a:r>
+          </a:p>
+        </p:txBody>
+      </p:sp>
+      <p:pic>
+        <p:nvPicPr>
+          <p:cNvPr id="4" name="Picture 3" descr="04_age_curve_overlay.png"/>
+          <p:cNvPicPr>
+            <a:picLocks noChangeAspect="1"/>
+          </p:cNvPicPr>
+          <p:nvPr/>
+        </p:nvPicPr>
+        <p:blipFill>
+          <a:blip r:embed="rId2"/>
+          <a:stretch>
+            <a:fillRect/>
+          </a:stretch>
+        </p:blipFill>
+        <p:spPr>
+          <a:xfrm>
+            <a:off x="2811779" y="1508760"/>
+            <a:ext cx="6583680" cy="4114800"/>
+          </a:xfrm>
+          <a:prstGeom prst="rect">
+            <a:avLst/>
+          </a:prstGeom>
+        </p:spPr>
+      </p:pic>
+      <p:sp>
+        <p:nvSpPr>
+          <p:cNvPr id="5" name="TextBox 4"/>
+          <p:cNvSpPr txBox="1"/>
+          <p:nvPr/>
+        </p:nvSpPr>
+        <p:spPr>
+          <a:xfrm>
+            <a:off x="566928" y="5806440"/>
             <a:ext cx="11064240" cy="640080"/>
           </a:xfrm>
           <a:prstGeom prst="rect">
@@ -8609,633 +9673,36 @@
           <a:p>
             <a:pPr algn="l">
               <a:lnSpc>
-                <a:spcPct val="112000"/>
+                <a:spcPct val="110000"/>
               </a:lnSpc>
               <a:spcAft>
                 <a:spcPts val="400"/>
               </a:spcAft>
             </a:pPr>
             <a:r>
-              <a:rPr sz="1450" b="0" i="0">
+              <a:rPr sz="1400" b="0" i="0">
                 <a:solidFill>
                   <a:srgbClr val="20232A"/>
                 </a:solidFill>
                 <a:latin typeface="Calibri"/>
               </a:rPr>
-              <a:t>With a top-10 rotation (3.76 ERA) already carrying the club, trading bats for arms is backwards. Convert the outfield surplus into what's thin:</a:t>
-            </a:r>
-          </a:p>
-        </p:txBody>
-      </p:sp>
-      <p:sp>
-        <p:nvSpPr>
-          <p:cNvPr id="5" name="Rounded Rectangle 4"/>
-          <p:cNvSpPr/>
-          <p:nvPr/>
-        </p:nvSpPr>
-        <p:spPr>
-          <a:xfrm>
-            <a:off x="566928" y="2468880"/>
-            <a:ext cx="3502152" cy="2514600"/>
-          </a:xfrm>
-          <a:prstGeom prst="roundRect">
-            <a:avLst>
-              <a:gd name="adj" fmla="val 8000"/>
-            </a:avLst>
-          </a:prstGeom>
-          <a:solidFill>
-            <a:srgbClr val="FFFFFF"/>
-          </a:solidFill>
-          <a:ln w="12700">
-            <a:solidFill>
-              <a:srgbClr val="D7DAE0"/>
-            </a:solidFill>
-          </a:ln>
-          <a:effectLst/>
-        </p:spPr>
-        <p:style>
-          <a:lnRef idx="1">
-            <a:schemeClr val="accent1"/>
-          </a:lnRef>
-          <a:fillRef idx="3">
-            <a:schemeClr val="accent1"/>
-          </a:fillRef>
-          <a:effectRef idx="2">
-            <a:schemeClr val="accent1"/>
-          </a:effectRef>
-          <a:fontRef idx="minor">
-            <a:schemeClr val="lt1"/>
-          </a:fontRef>
-        </p:style>
-        <p:txBody>
-          <a:bodyPr rtlCol="0" anchor="ctr"/>
-          <a:lstStyle/>
-          <a:p>
-            <a:pPr algn="ctr"/>
-          </a:p>
-        </p:txBody>
-      </p:sp>
-      <p:sp>
-        <p:nvSpPr>
-          <p:cNvPr id="6" name="Oval 5"/>
-          <p:cNvSpPr/>
-          <p:nvPr/>
-        </p:nvSpPr>
-        <p:spPr>
-          <a:xfrm>
-            <a:off x="841247" y="2724912"/>
-            <a:ext cx="384048" cy="384048"/>
-          </a:xfrm>
-          <a:prstGeom prst="ellipse">
-            <a:avLst/>
-          </a:prstGeom>
-          <a:solidFill>
-            <a:srgbClr val="2E7D32"/>
-          </a:solidFill>
-          <a:ln>
-            <a:noFill/>
-          </a:ln>
-          <a:effectLst/>
-        </p:spPr>
-        <p:style>
-          <a:lnRef idx="1">
-            <a:schemeClr val="accent1"/>
-          </a:lnRef>
-          <a:fillRef idx="3">
-            <a:schemeClr val="accent1"/>
-          </a:fillRef>
-          <a:effectRef idx="2">
-            <a:schemeClr val="accent1"/>
-          </a:effectRef>
-          <a:fontRef idx="minor">
-            <a:schemeClr val="lt1"/>
-          </a:fontRef>
-        </p:style>
-        <p:txBody>
-          <a:bodyPr rtlCol="0" anchor="ctr" wrap="none"/>
-          <a:lstStyle/>
-          <a:p>
-            <a:pPr algn="ctr"/>
-            <a:r>
-              <a:rPr sz="1600" b="1">
-                <a:solidFill>
-                  <a:srgbClr val="FFFFFF"/>
-                </a:solidFill>
-                <a:latin typeface="Cambria"/>
-              </a:rPr>
-              <a:t>1</a:t>
-            </a:r>
-          </a:p>
-        </p:txBody>
-      </p:sp>
-      <p:sp>
-        <p:nvSpPr>
-          <p:cNvPr id="7" name="TextBox 6"/>
-          <p:cNvSpPr txBox="1"/>
-          <p:nvPr/>
-        </p:nvSpPr>
-        <p:spPr>
-          <a:xfrm>
-            <a:off x="841247" y="3310128"/>
-            <a:ext cx="2999232" cy="411480"/>
-          </a:xfrm>
-          <a:prstGeom prst="rect">
-            <a:avLst/>
-          </a:prstGeom>
-          <a:noFill/>
-        </p:spPr>
-        <p:txBody>
-          <a:bodyPr wrap="square" anchor="t" lIns="0" rIns="0" tIns="0" bIns="0">
-            <a:spAutoFit/>
-          </a:bodyPr>
-          <a:lstStyle/>
-          <a:p>
-            <a:pPr algn="l">
-              <a:lnSpc>
-                <a:spcPct val="100000"/>
-              </a:lnSpc>
-              <a:spcAft>
-                <a:spcPts val="0"/>
-              </a:spcAft>
-            </a:pPr>
-            <a:r>
-              <a:rPr sz="1600" b="1" i="0">
+              <a:t>2024 → 2026 wRC+ fell ~70 points; a normal age 27→29 curve predicts only ~7. </a:t>
+            </a:r>
+            <a:r>
+              <a:rPr sz="1400" b="1" i="0">
                 <a:solidFill>
                   <a:srgbClr val="0C2340"/>
                 </a:solidFill>
-                <a:latin typeface="Cambria"/>
-              </a:rPr>
-              <a:t>Controllable bats</a:t>
-            </a:r>
-          </a:p>
-        </p:txBody>
-      </p:sp>
-      <p:sp>
-        <p:nvSpPr>
-          <p:cNvPr id="8" name="TextBox 7"/>
-          <p:cNvSpPr txBox="1"/>
-          <p:nvPr/>
-        </p:nvSpPr>
-        <p:spPr>
-          <a:xfrm>
-            <a:off x="841247" y="3767328"/>
-            <a:ext cx="2999232" cy="1097280"/>
-          </a:xfrm>
-          <a:prstGeom prst="rect">
-            <a:avLst/>
-          </a:prstGeom>
-          <a:noFill/>
-        </p:spPr>
-        <p:txBody>
-          <a:bodyPr wrap="square" anchor="t" lIns="0" rIns="0" tIns="0" bIns="0">
-            <a:spAutoFit/>
-          </a:bodyPr>
-          <a:lstStyle/>
-          <a:p>
-            <a:pPr algn="l">
-              <a:lnSpc>
-                <a:spcPct val="110000"/>
-              </a:lnSpc>
-              <a:spcAft>
-                <a:spcPts val="400"/>
-              </a:spcAft>
-            </a:pPr>
-            <a:r>
-              <a:rPr sz="1280" b="0" i="0">
-                <a:solidFill>
-                  <a:srgbClr val="6B7280"/>
-                </a:solidFill>
-                <a:latin typeface="Calibri"/>
-              </a:rPr>
-              <a:t>Young, cost-controlled position players to fix an inconsistent lineup and lengthen it around the core.</a:t>
-            </a:r>
-          </a:p>
-        </p:txBody>
-      </p:sp>
-      <p:sp>
-        <p:nvSpPr>
-          <p:cNvPr id="9" name="Rounded Rectangle 8"/>
-          <p:cNvSpPr/>
-          <p:nvPr/>
-        </p:nvSpPr>
-        <p:spPr>
-          <a:xfrm>
-            <a:off x="4352544" y="2468880"/>
-            <a:ext cx="3502152" cy="2514600"/>
-          </a:xfrm>
-          <a:prstGeom prst="roundRect">
-            <a:avLst>
-              <a:gd name="adj" fmla="val 8000"/>
-            </a:avLst>
-          </a:prstGeom>
-          <a:solidFill>
-            <a:srgbClr val="FFFFFF"/>
-          </a:solidFill>
-          <a:ln w="12700">
-            <a:solidFill>
-              <a:srgbClr val="D7DAE0"/>
-            </a:solidFill>
-          </a:ln>
-          <a:effectLst/>
-        </p:spPr>
-        <p:style>
-          <a:lnRef idx="1">
-            <a:schemeClr val="accent1"/>
-          </a:lnRef>
-          <a:fillRef idx="3">
-            <a:schemeClr val="accent1"/>
-          </a:fillRef>
-          <a:effectRef idx="2">
-            <a:schemeClr val="accent1"/>
-          </a:effectRef>
-          <a:fontRef idx="minor">
-            <a:schemeClr val="lt1"/>
-          </a:fontRef>
-        </p:style>
-        <p:txBody>
-          <a:bodyPr rtlCol="0" anchor="ctr"/>
-          <a:lstStyle/>
-          <a:p>
-            <a:pPr algn="ctr"/>
-          </a:p>
-        </p:txBody>
-      </p:sp>
-      <p:sp>
-        <p:nvSpPr>
-          <p:cNvPr id="10" name="Oval 9"/>
-          <p:cNvSpPr/>
-          <p:nvPr/>
-        </p:nvSpPr>
-        <p:spPr>
-          <a:xfrm>
-            <a:off x="4626864" y="2724912"/>
-            <a:ext cx="384048" cy="384048"/>
-          </a:xfrm>
-          <a:prstGeom prst="ellipse">
-            <a:avLst/>
-          </a:prstGeom>
-          <a:solidFill>
-            <a:srgbClr val="0C2340"/>
-          </a:solidFill>
-          <a:ln>
-            <a:noFill/>
-          </a:ln>
-          <a:effectLst/>
-        </p:spPr>
-        <p:style>
-          <a:lnRef idx="1">
-            <a:schemeClr val="accent1"/>
-          </a:lnRef>
-          <a:fillRef idx="3">
-            <a:schemeClr val="accent1"/>
-          </a:fillRef>
-          <a:effectRef idx="2">
-            <a:schemeClr val="accent1"/>
-          </a:effectRef>
-          <a:fontRef idx="minor">
-            <a:schemeClr val="lt1"/>
-          </a:fontRef>
-        </p:style>
-        <p:txBody>
-          <a:bodyPr rtlCol="0" anchor="ctr" wrap="none"/>
-          <a:lstStyle/>
-          <a:p>
-            <a:pPr algn="ctr"/>
-            <a:r>
-              <a:rPr sz="1600" b="1">
-                <a:solidFill>
-                  <a:srgbClr val="FFFFFF"/>
-                </a:solidFill>
-                <a:latin typeface="Cambria"/>
-              </a:rPr>
-              <a:t>2</a:t>
-            </a:r>
-          </a:p>
-        </p:txBody>
-      </p:sp>
-      <p:sp>
-        <p:nvSpPr>
-          <p:cNvPr id="11" name="TextBox 10"/>
-          <p:cNvSpPr txBox="1"/>
-          <p:nvPr/>
-        </p:nvSpPr>
-        <p:spPr>
-          <a:xfrm>
-            <a:off x="4626864" y="3310128"/>
-            <a:ext cx="2999232" cy="411480"/>
-          </a:xfrm>
-          <a:prstGeom prst="rect">
-            <a:avLst/>
-          </a:prstGeom>
-          <a:noFill/>
-        </p:spPr>
-        <p:txBody>
-          <a:bodyPr wrap="square" anchor="t" lIns="0" rIns="0" tIns="0" bIns="0">
-            <a:spAutoFit/>
-          </a:bodyPr>
-          <a:lstStyle/>
-          <a:p>
-            <a:pPr algn="l">
-              <a:lnSpc>
-                <a:spcPct val="100000"/>
-              </a:lnSpc>
-              <a:spcAft>
-                <a:spcPts val="0"/>
-              </a:spcAft>
-            </a:pPr>
-            <a:r>
-              <a:rPr sz="1600" b="1" i="0">
-                <a:solidFill>
-                  <a:srgbClr val="0C2340"/>
-                </a:solidFill>
-                <a:latin typeface="Cambria"/>
-              </a:rPr>
-              <a:t>Best talent / upside</a:t>
-            </a:r>
-          </a:p>
-        </p:txBody>
-      </p:sp>
-      <p:sp>
-        <p:nvSpPr>
-          <p:cNvPr id="12" name="TextBox 11"/>
-          <p:cNvSpPr txBox="1"/>
-          <p:nvPr/>
-        </p:nvSpPr>
-        <p:spPr>
-          <a:xfrm>
-            <a:off x="4626864" y="3767328"/>
-            <a:ext cx="2999232" cy="1097280"/>
-          </a:xfrm>
-          <a:prstGeom prst="rect">
-            <a:avLst/>
-          </a:prstGeom>
-          <a:noFill/>
-        </p:spPr>
-        <p:txBody>
-          <a:bodyPr wrap="square" anchor="t" lIns="0" rIns="0" tIns="0" bIns="0">
-            <a:spAutoFit/>
-          </a:bodyPr>
-          <a:lstStyle/>
-          <a:p>
-            <a:pPr algn="l">
-              <a:lnSpc>
-                <a:spcPct val="110000"/>
-              </a:lnSpc>
-              <a:spcAft>
-                <a:spcPts val="400"/>
-              </a:spcAft>
-            </a:pPr>
-            <a:r>
-              <a:rPr sz="1280" b="0" i="0">
-                <a:solidFill>
-                  <a:srgbClr val="6B7280"/>
-                </a:solidFill>
-                <a:latin typeface="Calibri"/>
-              </a:rPr>
-              <a:t>In a retool you take the best player, not the positional patch — prospects and MLB-ready youth over rentals.</a:t>
-            </a:r>
-          </a:p>
-        </p:txBody>
-      </p:sp>
-      <p:sp>
-        <p:nvSpPr>
-          <p:cNvPr id="13" name="Rounded Rectangle 12"/>
-          <p:cNvSpPr/>
-          <p:nvPr/>
-        </p:nvSpPr>
-        <p:spPr>
-          <a:xfrm>
-            <a:off x="8138159" y="2468880"/>
-            <a:ext cx="3502152" cy="2514600"/>
-          </a:xfrm>
-          <a:prstGeom prst="roundRect">
-            <a:avLst>
-              <a:gd name="adj" fmla="val 8000"/>
-            </a:avLst>
-          </a:prstGeom>
-          <a:solidFill>
-            <a:srgbClr val="FFFFFF"/>
-          </a:solidFill>
-          <a:ln w="12700">
-            <a:solidFill>
-              <a:srgbClr val="D7DAE0"/>
-            </a:solidFill>
-          </a:ln>
-          <a:effectLst/>
-        </p:spPr>
-        <p:style>
-          <a:lnRef idx="1">
-            <a:schemeClr val="accent1"/>
-          </a:lnRef>
-          <a:fillRef idx="3">
-            <a:schemeClr val="accent1"/>
-          </a:fillRef>
-          <a:effectRef idx="2">
-            <a:schemeClr val="accent1"/>
-          </a:effectRef>
-          <a:fontRef idx="minor">
-            <a:schemeClr val="lt1"/>
-          </a:fontRef>
-        </p:style>
-        <p:txBody>
-          <a:bodyPr rtlCol="0" anchor="ctr"/>
-          <a:lstStyle/>
-          <a:p>
-            <a:pPr algn="ctr"/>
-          </a:p>
-        </p:txBody>
-      </p:sp>
-      <p:sp>
-        <p:nvSpPr>
-          <p:cNvPr id="14" name="Oval 13"/>
-          <p:cNvSpPr/>
-          <p:nvPr/>
-        </p:nvSpPr>
-        <p:spPr>
-          <a:xfrm>
-            <a:off x="8412480" y="2724912"/>
-            <a:ext cx="384048" cy="384048"/>
-          </a:xfrm>
-          <a:prstGeom prst="ellipse">
-            <a:avLst/>
-          </a:prstGeom>
-          <a:solidFill>
-            <a:srgbClr val="B7892F"/>
-          </a:solidFill>
-          <a:ln>
-            <a:noFill/>
-          </a:ln>
-          <a:effectLst/>
-        </p:spPr>
-        <p:style>
-          <a:lnRef idx="1">
-            <a:schemeClr val="accent1"/>
-          </a:lnRef>
-          <a:fillRef idx="3">
-            <a:schemeClr val="accent1"/>
-          </a:fillRef>
-          <a:effectRef idx="2">
-            <a:schemeClr val="accent1"/>
-          </a:effectRef>
-          <a:fontRef idx="minor">
-            <a:schemeClr val="lt1"/>
-          </a:fontRef>
-        </p:style>
-        <p:txBody>
-          <a:bodyPr rtlCol="0" anchor="ctr" wrap="none"/>
-          <a:lstStyle/>
-          <a:p>
-            <a:pPr algn="ctr"/>
-            <a:r>
-              <a:rPr sz="1600" b="1">
-                <a:solidFill>
-                  <a:srgbClr val="FFFFFF"/>
-                </a:solidFill>
-                <a:latin typeface="Cambria"/>
-              </a:rPr>
-              <a:t>3</a:t>
-            </a:r>
-          </a:p>
-        </p:txBody>
-      </p:sp>
-      <p:sp>
-        <p:nvSpPr>
-          <p:cNvPr id="15" name="TextBox 14"/>
-          <p:cNvSpPr txBox="1"/>
-          <p:nvPr/>
-        </p:nvSpPr>
-        <p:spPr>
-          <a:xfrm>
-            <a:off x="8412480" y="3310128"/>
-            <a:ext cx="2999232" cy="411480"/>
-          </a:xfrm>
-          <a:prstGeom prst="rect">
-            <a:avLst/>
-          </a:prstGeom>
-          <a:noFill/>
-        </p:spPr>
-        <p:txBody>
-          <a:bodyPr wrap="square" anchor="t" lIns="0" rIns="0" tIns="0" bIns="0">
-            <a:spAutoFit/>
-          </a:bodyPr>
-          <a:lstStyle/>
-          <a:p>
-            <a:pPr algn="l">
-              <a:lnSpc>
-                <a:spcPct val="100000"/>
-              </a:lnSpc>
-              <a:spcAft>
-                <a:spcPts val="0"/>
-              </a:spcAft>
-            </a:pPr>
-            <a:r>
-              <a:rPr sz="1600" b="1" i="0">
-                <a:solidFill>
-                  <a:srgbClr val="0C2340"/>
-                </a:solidFill>
-                <a:latin typeface="Cambria"/>
-              </a:rPr>
-              <a:t>Salary relief</a:t>
-            </a:r>
-          </a:p>
-        </p:txBody>
-      </p:sp>
-      <p:sp>
-        <p:nvSpPr>
-          <p:cNvPr id="16" name="TextBox 15"/>
-          <p:cNvSpPr txBox="1"/>
-          <p:nvPr/>
-        </p:nvSpPr>
-        <p:spPr>
-          <a:xfrm>
-            <a:off x="8412480" y="3767328"/>
-            <a:ext cx="2999232" cy="1097280"/>
-          </a:xfrm>
-          <a:prstGeom prst="rect">
-            <a:avLst/>
-          </a:prstGeom>
-          <a:noFill/>
-        </p:spPr>
-        <p:txBody>
-          <a:bodyPr wrap="square" anchor="t" lIns="0" rIns="0" tIns="0" bIns="0">
-            <a:spAutoFit/>
-          </a:bodyPr>
-          <a:lstStyle/>
-          <a:p>
-            <a:pPr algn="l">
-              <a:lnSpc>
-                <a:spcPct val="110000"/>
-              </a:lnSpc>
-              <a:spcAft>
-                <a:spcPts val="400"/>
-              </a:spcAft>
-            </a:pPr>
-            <a:r>
-              <a:rPr sz="1280" b="0" i="0">
-                <a:solidFill>
-                  <a:srgbClr val="6B7280"/>
-                </a:solidFill>
-                <a:latin typeface="Calibri"/>
-              </a:rPr>
-              <a:t>Attach Yoshida money where possible; free payroll for the 2027 window.</a:t>
-            </a:r>
-          </a:p>
-        </p:txBody>
-      </p:sp>
-      <p:sp>
-        <p:nvSpPr>
-          <p:cNvPr id="17" name="TextBox 16"/>
-          <p:cNvSpPr txBox="1"/>
-          <p:nvPr/>
-        </p:nvSpPr>
-        <p:spPr>
-          <a:xfrm>
-            <a:off x="566928" y="5257800"/>
-            <a:ext cx="11064240" cy="457200"/>
-          </a:xfrm>
-          <a:prstGeom prst="rect">
-            <a:avLst/>
-          </a:prstGeom>
-          <a:noFill/>
-        </p:spPr>
-        <p:txBody>
-          <a:bodyPr wrap="square" anchor="t" lIns="0" rIns="0" tIns="0" bIns="0">
-            <a:spAutoFit/>
-          </a:bodyPr>
-          <a:lstStyle/>
-          <a:p>
-            <a:pPr algn="l">
-              <a:lnSpc>
-                <a:spcPct val="100000"/>
-              </a:lnSpc>
-              <a:spcAft>
-                <a:spcPts val="0"/>
-              </a:spcAft>
-            </a:pPr>
-            <a:r>
-              <a:rPr sz="1400" b="1" i="1">
-                <a:solidFill>
-                  <a:srgbClr val="0C2340"/>
-                </a:solidFill>
-                <a:latin typeface="Calibri"/>
-              </a:rPr>
-              <a:t>Keep the arms. Cash the outfield. </a:t>
-            </a:r>
-            <a:r>
-              <a:rPr sz="1400" b="0" i="1">
-                <a:solidFill>
-                  <a:srgbClr val="6B7280"/>
-                </a:solidFill>
-                <a:latin typeface="Calibri"/>
-              </a:rPr>
-              <a:t>Build the 2027 lineup, don't rent the 2026 one.</a:t>
-            </a:r>
-          </a:p>
-        </p:txBody>
-      </p:sp>
-      <p:sp>
-        <p:nvSpPr>
-          <p:cNvPr id="18" name="TextBox 17"/>
+                <a:latin typeface="Calibri"/>
+              </a:rPr>
+              <a:t>The gap is mean-reversion from an inflated peak plus a 2026 bad-luck tail — not skill cliff.</a:t>
+            </a:r>
+          </a:p>
+        </p:txBody>
+      </p:sp>
+      <p:sp>
+        <p:nvSpPr>
+          <p:cNvPr id="6" name="TextBox 5"/>
           <p:cNvSpPr txBox="1"/>
           <p:nvPr/>
         </p:nvSpPr>
@@ -9347,7 +9814,7 @@
                 </a:solidFill>
                 <a:latin typeface="Calibri"/>
               </a:rPr>
-              <a:t>THE MARKET</a:t>
+              <a:t>WHAT TO GET BACK</a:t>
             </a:r>
           </a:p>
         </p:txBody>
@@ -9389,74 +9856,98 @@
                 </a:solidFill>
                 <a:latin typeface="Cambria"/>
               </a:rPr>
-              <a:t>Who pays: contenders with a hole in the outfield</a:t>
-            </a:r>
-          </a:p>
-        </p:txBody>
-      </p:sp>
-      <p:pic>
-        <p:nvPicPr>
-          <p:cNvPr id="4" name="Picture 3" descr="08_trade_fit_targets.png"/>
-          <p:cNvPicPr>
-            <a:picLocks noChangeAspect="1"/>
-          </p:cNvPicPr>
-          <p:nvPr/>
-        </p:nvPicPr>
-        <p:blipFill>
-          <a:blip r:embed="rId2"/>
-          <a:stretch>
-            <a:fillRect/>
-          </a:stretch>
-        </p:blipFill>
-        <p:spPr>
-          <a:xfrm>
-            <a:off x="757237" y="1463040"/>
-            <a:ext cx="6715125" cy="4297680"/>
-          </a:xfrm>
-          <a:prstGeom prst="rect">
-            <a:avLst/>
-          </a:prstGeom>
-        </p:spPr>
-      </p:pic>
-      <p:sp>
-        <p:nvSpPr>
-          <p:cNvPr id="5" name="TextBox 4"/>
-          <p:cNvSpPr txBox="1"/>
-          <p:nvPr/>
-        </p:nvSpPr>
-        <p:spPr>
-          <a:xfrm>
-            <a:off x="8183879" y="1691640"/>
-            <a:ext cx="3657600" cy="457200"/>
-          </a:xfrm>
-          <a:prstGeom prst="rect">
-            <a:avLst/>
-          </a:prstGeom>
-          <a:noFill/>
-        </p:spPr>
-        <p:txBody>
-          <a:bodyPr wrap="square" anchor="t" lIns="0" rIns="0" tIns="0" bIns="0">
-            <a:spAutoFit/>
-          </a:bodyPr>
-          <a:lstStyle/>
-          <a:p>
-            <a:pPr algn="l">
-              <a:lnSpc>
-                <a:spcPct val="100000"/>
-              </a:lnSpc>
-              <a:spcAft>
-                <a:spcPts val="0"/>
-              </a:spcAft>
-            </a:pPr>
-            <a:r>
-              <a:rPr sz="1500" b="1" i="0">
-                <a:solidFill>
-                  <a:srgbClr val="0C2340"/>
-                </a:solidFill>
-                <a:latin typeface="Cambria"/>
-              </a:rPr>
-              <a:t>Best-fit buyers</a:t>
-            </a:r>
+              <a:t>Pitching is the strength — spend the surplus on offense</a:t>
+            </a:r>
+          </a:p>
+        </p:txBody>
+      </p:sp>
+      <p:sp>
+        <p:nvSpPr>
+          <p:cNvPr id="4" name="TextBox 3"/>
+          <p:cNvSpPr txBox="1"/>
+          <p:nvPr/>
+        </p:nvSpPr>
+        <p:spPr>
+          <a:xfrm>
+            <a:off x="566928" y="1572768"/>
+            <a:ext cx="11064240" cy="640080"/>
+          </a:xfrm>
+          <a:prstGeom prst="rect">
+            <a:avLst/>
+          </a:prstGeom>
+          <a:noFill/>
+        </p:spPr>
+        <p:txBody>
+          <a:bodyPr wrap="square" anchor="t" lIns="0" rIns="0" tIns="0" bIns="0">
+            <a:spAutoFit/>
+          </a:bodyPr>
+          <a:lstStyle/>
+          <a:p>
+            <a:pPr algn="l">
+              <a:lnSpc>
+                <a:spcPct val="112000"/>
+              </a:lnSpc>
+              <a:spcAft>
+                <a:spcPts val="400"/>
+              </a:spcAft>
+            </a:pPr>
+            <a:r>
+              <a:rPr sz="1450" b="0" i="0">
+                <a:solidFill>
+                  <a:srgbClr val="20232A"/>
+                </a:solidFill>
+                <a:latin typeface="Calibri"/>
+              </a:rPr>
+              <a:t>With a top-10 rotation (3.76 ERA) already carrying the club, trading bats for arms is backwards. Convert the outfield surplus into what's thin:</a:t>
+            </a:r>
+          </a:p>
+        </p:txBody>
+      </p:sp>
+      <p:sp>
+        <p:nvSpPr>
+          <p:cNvPr id="5" name="Rounded Rectangle 4"/>
+          <p:cNvSpPr/>
+          <p:nvPr/>
+        </p:nvSpPr>
+        <p:spPr>
+          <a:xfrm>
+            <a:off x="566928" y="2468880"/>
+            <a:ext cx="3502152" cy="2514600"/>
+          </a:xfrm>
+          <a:prstGeom prst="roundRect">
+            <a:avLst>
+              <a:gd name="adj" fmla="val 8000"/>
+            </a:avLst>
+          </a:prstGeom>
+          <a:solidFill>
+            <a:srgbClr val="FFFFFF"/>
+          </a:solidFill>
+          <a:ln w="12700">
+            <a:solidFill>
+              <a:srgbClr val="D7DAE0"/>
+            </a:solidFill>
+          </a:ln>
+          <a:effectLst/>
+        </p:spPr>
+        <p:style>
+          <a:lnRef idx="1">
+            <a:schemeClr val="accent1"/>
+          </a:lnRef>
+          <a:fillRef idx="3">
+            <a:schemeClr val="accent1"/>
+          </a:fillRef>
+          <a:effectRef idx="2">
+            <a:schemeClr val="accent1"/>
+          </a:effectRef>
+          <a:fontRef idx="minor">
+            <a:schemeClr val="lt1"/>
+          </a:fontRef>
+        </p:style>
+        <p:txBody>
+          <a:bodyPr rtlCol="0" anchor="ctr"/>
+          <a:lstStyle/>
+          <a:p>
+            <a:pPr algn="ctr"/>
           </a:p>
         </p:txBody>
       </p:sp>
@@ -9468,14 +9959,14 @@
         </p:nvSpPr>
         <p:spPr>
           <a:xfrm>
-            <a:off x="8183879" y="2221991"/>
-            <a:ext cx="128016" cy="128016"/>
+            <a:off x="841247" y="2724912"/>
+            <a:ext cx="384048" cy="384048"/>
           </a:xfrm>
           <a:prstGeom prst="ellipse">
             <a:avLst/>
           </a:prstGeom>
           <a:solidFill>
-            <a:srgbClr val="BD3039"/>
+            <a:srgbClr val="2E7D32"/>
           </a:solidFill>
           <a:ln>
             <a:noFill/>
@@ -9497,6 +9988,147 @@
           </a:fontRef>
         </p:style>
         <p:txBody>
+          <a:bodyPr rtlCol="0" anchor="ctr" wrap="none"/>
+          <a:lstStyle/>
+          <a:p>
+            <a:pPr algn="ctr"/>
+            <a:r>
+              <a:rPr sz="1600" b="1">
+                <a:solidFill>
+                  <a:srgbClr val="FFFFFF"/>
+                </a:solidFill>
+                <a:latin typeface="Cambria"/>
+              </a:rPr>
+              <a:t>1</a:t>
+            </a:r>
+          </a:p>
+        </p:txBody>
+      </p:sp>
+      <p:sp>
+        <p:nvSpPr>
+          <p:cNvPr id="7" name="TextBox 6"/>
+          <p:cNvSpPr txBox="1"/>
+          <p:nvPr/>
+        </p:nvSpPr>
+        <p:spPr>
+          <a:xfrm>
+            <a:off x="841247" y="3310128"/>
+            <a:ext cx="2999232" cy="411480"/>
+          </a:xfrm>
+          <a:prstGeom prst="rect">
+            <a:avLst/>
+          </a:prstGeom>
+          <a:noFill/>
+        </p:spPr>
+        <p:txBody>
+          <a:bodyPr wrap="square" anchor="t" lIns="0" rIns="0" tIns="0" bIns="0">
+            <a:spAutoFit/>
+          </a:bodyPr>
+          <a:lstStyle/>
+          <a:p>
+            <a:pPr algn="l">
+              <a:lnSpc>
+                <a:spcPct val="100000"/>
+              </a:lnSpc>
+              <a:spcAft>
+                <a:spcPts val="0"/>
+              </a:spcAft>
+            </a:pPr>
+            <a:r>
+              <a:rPr sz="1600" b="1" i="0">
+                <a:solidFill>
+                  <a:srgbClr val="0C2340"/>
+                </a:solidFill>
+                <a:latin typeface="Cambria"/>
+              </a:rPr>
+              <a:t>Controllable bats</a:t>
+            </a:r>
+          </a:p>
+        </p:txBody>
+      </p:sp>
+      <p:sp>
+        <p:nvSpPr>
+          <p:cNvPr id="8" name="TextBox 7"/>
+          <p:cNvSpPr txBox="1"/>
+          <p:nvPr/>
+        </p:nvSpPr>
+        <p:spPr>
+          <a:xfrm>
+            <a:off x="841247" y="3767328"/>
+            <a:ext cx="2999232" cy="1097280"/>
+          </a:xfrm>
+          <a:prstGeom prst="rect">
+            <a:avLst/>
+          </a:prstGeom>
+          <a:noFill/>
+        </p:spPr>
+        <p:txBody>
+          <a:bodyPr wrap="square" anchor="t" lIns="0" rIns="0" tIns="0" bIns="0">
+            <a:spAutoFit/>
+          </a:bodyPr>
+          <a:lstStyle/>
+          <a:p>
+            <a:pPr algn="l">
+              <a:lnSpc>
+                <a:spcPct val="110000"/>
+              </a:lnSpc>
+              <a:spcAft>
+                <a:spcPts val="400"/>
+              </a:spcAft>
+            </a:pPr>
+            <a:r>
+              <a:rPr sz="1280" b="0" i="0">
+                <a:solidFill>
+                  <a:srgbClr val="6B7280"/>
+                </a:solidFill>
+                <a:latin typeface="Calibri"/>
+              </a:rPr>
+              <a:t>Young, cost-controlled position players to fix an inconsistent lineup and lengthen it around the core.</a:t>
+            </a:r>
+          </a:p>
+        </p:txBody>
+      </p:sp>
+      <p:sp>
+        <p:nvSpPr>
+          <p:cNvPr id="9" name="Rounded Rectangle 8"/>
+          <p:cNvSpPr/>
+          <p:nvPr/>
+        </p:nvSpPr>
+        <p:spPr>
+          <a:xfrm>
+            <a:off x="4352544" y="2468880"/>
+            <a:ext cx="3502152" cy="2514600"/>
+          </a:xfrm>
+          <a:prstGeom prst="roundRect">
+            <a:avLst>
+              <a:gd name="adj" fmla="val 8000"/>
+            </a:avLst>
+          </a:prstGeom>
+          <a:solidFill>
+            <a:srgbClr val="FFFFFF"/>
+          </a:solidFill>
+          <a:ln w="12700">
+            <a:solidFill>
+              <a:srgbClr val="D7DAE0"/>
+            </a:solidFill>
+          </a:ln>
+          <a:effectLst/>
+        </p:spPr>
+        <p:style>
+          <a:lnRef idx="1">
+            <a:schemeClr val="accent1"/>
+          </a:lnRef>
+          <a:fillRef idx="3">
+            <a:schemeClr val="accent1"/>
+          </a:fillRef>
+          <a:effectRef idx="2">
+            <a:schemeClr val="accent1"/>
+          </a:effectRef>
+          <a:fontRef idx="minor">
+            <a:schemeClr val="lt1"/>
+          </a:fontRef>
+        </p:style>
+        <p:txBody>
           <a:bodyPr rtlCol="0" anchor="ctr"/>
           <a:lstStyle/>
           <a:p>
@@ -9506,71 +10138,20 @@
       </p:sp>
       <p:sp>
         <p:nvSpPr>
-          <p:cNvPr id="7" name="TextBox 6"/>
-          <p:cNvSpPr txBox="1"/>
-          <p:nvPr/>
-        </p:nvSpPr>
-        <p:spPr>
-          <a:xfrm>
-            <a:off x="8439911" y="2194560"/>
-            <a:ext cx="3566160" cy="457200"/>
-          </a:xfrm>
-          <a:prstGeom prst="rect">
-            <a:avLst/>
-          </a:prstGeom>
-          <a:noFill/>
-        </p:spPr>
-        <p:txBody>
-          <a:bodyPr wrap="square" anchor="t" lIns="0" rIns="0" tIns="0" bIns="0">
-            <a:spAutoFit/>
-          </a:bodyPr>
-          <a:lstStyle/>
-          <a:p>
-            <a:pPr algn="l">
-              <a:lnSpc>
-                <a:spcPct val="100000"/>
-              </a:lnSpc>
-              <a:spcAft>
-                <a:spcPts val="0"/>
-              </a:spcAft>
-            </a:pPr>
-            <a:r>
-              <a:rPr sz="1400" b="1" i="0">
-                <a:solidFill>
-                  <a:srgbClr val="0C2340"/>
-                </a:solidFill>
-                <a:latin typeface="Calibri"/>
-              </a:rPr>
-              <a:t>Phillies  </a:t>
-            </a:r>
-            <a:r>
-              <a:rPr sz="1200" b="0" i="0">
-                <a:solidFill>
-                  <a:srgbClr val="6B7280"/>
-                </a:solidFill>
-                <a:latin typeface="Calibri"/>
-              </a:rPr>
-              <a:t>contender, 88 OF wRC+</a:t>
-            </a:r>
-          </a:p>
-        </p:txBody>
-      </p:sp>
-      <p:sp>
-        <p:nvSpPr>
-          <p:cNvPr id="8" name="Oval 7"/>
+          <p:cNvPr id="10" name="Oval 9"/>
           <p:cNvSpPr/>
           <p:nvPr/>
         </p:nvSpPr>
         <p:spPr>
           <a:xfrm>
-            <a:off x="8183879" y="2788920"/>
-            <a:ext cx="128016" cy="128016"/>
+            <a:off x="4626864" y="2724912"/>
+            <a:ext cx="384048" cy="384048"/>
           </a:xfrm>
           <a:prstGeom prst="ellipse">
             <a:avLst/>
           </a:prstGeom>
           <a:solidFill>
-            <a:srgbClr val="BD3039"/>
+            <a:srgbClr val="0C2340"/>
           </a:solidFill>
           <a:ln>
             <a:noFill/>
@@ -9592,6 +10173,147 @@
           </a:fontRef>
         </p:style>
         <p:txBody>
+          <a:bodyPr rtlCol="0" anchor="ctr" wrap="none"/>
+          <a:lstStyle/>
+          <a:p>
+            <a:pPr algn="ctr"/>
+            <a:r>
+              <a:rPr sz="1600" b="1">
+                <a:solidFill>
+                  <a:srgbClr val="FFFFFF"/>
+                </a:solidFill>
+                <a:latin typeface="Cambria"/>
+              </a:rPr>
+              <a:t>2</a:t>
+            </a:r>
+          </a:p>
+        </p:txBody>
+      </p:sp>
+      <p:sp>
+        <p:nvSpPr>
+          <p:cNvPr id="11" name="TextBox 10"/>
+          <p:cNvSpPr txBox="1"/>
+          <p:nvPr/>
+        </p:nvSpPr>
+        <p:spPr>
+          <a:xfrm>
+            <a:off x="4626864" y="3310128"/>
+            <a:ext cx="2999232" cy="411480"/>
+          </a:xfrm>
+          <a:prstGeom prst="rect">
+            <a:avLst/>
+          </a:prstGeom>
+          <a:noFill/>
+        </p:spPr>
+        <p:txBody>
+          <a:bodyPr wrap="square" anchor="t" lIns="0" rIns="0" tIns="0" bIns="0">
+            <a:spAutoFit/>
+          </a:bodyPr>
+          <a:lstStyle/>
+          <a:p>
+            <a:pPr algn="l">
+              <a:lnSpc>
+                <a:spcPct val="100000"/>
+              </a:lnSpc>
+              <a:spcAft>
+                <a:spcPts val="0"/>
+              </a:spcAft>
+            </a:pPr>
+            <a:r>
+              <a:rPr sz="1600" b="1" i="0">
+                <a:solidFill>
+                  <a:srgbClr val="0C2340"/>
+                </a:solidFill>
+                <a:latin typeface="Cambria"/>
+              </a:rPr>
+              <a:t>Best talent / upside</a:t>
+            </a:r>
+          </a:p>
+        </p:txBody>
+      </p:sp>
+      <p:sp>
+        <p:nvSpPr>
+          <p:cNvPr id="12" name="TextBox 11"/>
+          <p:cNvSpPr txBox="1"/>
+          <p:nvPr/>
+        </p:nvSpPr>
+        <p:spPr>
+          <a:xfrm>
+            <a:off x="4626864" y="3767328"/>
+            <a:ext cx="2999232" cy="1097280"/>
+          </a:xfrm>
+          <a:prstGeom prst="rect">
+            <a:avLst/>
+          </a:prstGeom>
+          <a:noFill/>
+        </p:spPr>
+        <p:txBody>
+          <a:bodyPr wrap="square" anchor="t" lIns="0" rIns="0" tIns="0" bIns="0">
+            <a:spAutoFit/>
+          </a:bodyPr>
+          <a:lstStyle/>
+          <a:p>
+            <a:pPr algn="l">
+              <a:lnSpc>
+                <a:spcPct val="110000"/>
+              </a:lnSpc>
+              <a:spcAft>
+                <a:spcPts val="400"/>
+              </a:spcAft>
+            </a:pPr>
+            <a:r>
+              <a:rPr sz="1280" b="0" i="0">
+                <a:solidFill>
+                  <a:srgbClr val="6B7280"/>
+                </a:solidFill>
+                <a:latin typeface="Calibri"/>
+              </a:rPr>
+              <a:t>In a retool you take the best player, not the positional patch — prospects and MLB-ready youth over rentals.</a:t>
+            </a:r>
+          </a:p>
+        </p:txBody>
+      </p:sp>
+      <p:sp>
+        <p:nvSpPr>
+          <p:cNvPr id="13" name="Rounded Rectangle 12"/>
+          <p:cNvSpPr/>
+          <p:nvPr/>
+        </p:nvSpPr>
+        <p:spPr>
+          <a:xfrm>
+            <a:off x="8138159" y="2468880"/>
+            <a:ext cx="3502152" cy="2514600"/>
+          </a:xfrm>
+          <a:prstGeom prst="roundRect">
+            <a:avLst>
+              <a:gd name="adj" fmla="val 8000"/>
+            </a:avLst>
+          </a:prstGeom>
+          <a:solidFill>
+            <a:srgbClr val="FFFFFF"/>
+          </a:solidFill>
+          <a:ln w="12700">
+            <a:solidFill>
+              <a:srgbClr val="D7DAE0"/>
+            </a:solidFill>
+          </a:ln>
+          <a:effectLst/>
+        </p:spPr>
+        <p:style>
+          <a:lnRef idx="1">
+            <a:schemeClr val="accent1"/>
+          </a:lnRef>
+          <a:fillRef idx="3">
+            <a:schemeClr val="accent1"/>
+          </a:fillRef>
+          <a:effectRef idx="2">
+            <a:schemeClr val="accent1"/>
+          </a:effectRef>
+          <a:fontRef idx="minor">
+            <a:schemeClr val="lt1"/>
+          </a:fontRef>
+        </p:style>
+        <p:txBody>
           <a:bodyPr rtlCol="0" anchor="ctr"/>
           <a:lstStyle/>
           <a:p>
@@ -9601,71 +10323,20 @@
       </p:sp>
       <p:sp>
         <p:nvSpPr>
-          <p:cNvPr id="9" name="TextBox 8"/>
-          <p:cNvSpPr txBox="1"/>
-          <p:nvPr/>
-        </p:nvSpPr>
-        <p:spPr>
-          <a:xfrm>
-            <a:off x="8439911" y="2761488"/>
-            <a:ext cx="3566160" cy="457200"/>
-          </a:xfrm>
-          <a:prstGeom prst="rect">
-            <a:avLst/>
-          </a:prstGeom>
-          <a:noFill/>
-        </p:spPr>
-        <p:txBody>
-          <a:bodyPr wrap="square" anchor="t" lIns="0" rIns="0" tIns="0" bIns="0">
-            <a:spAutoFit/>
-          </a:bodyPr>
-          <a:lstStyle/>
-          <a:p>
-            <a:pPr algn="l">
-              <a:lnSpc>
-                <a:spcPct val="100000"/>
-              </a:lnSpc>
-              <a:spcAft>
-                <a:spcPts val="0"/>
-              </a:spcAft>
-            </a:pPr>
-            <a:r>
-              <a:rPr sz="1400" b="1" i="0">
-                <a:solidFill>
-                  <a:srgbClr val="0C2340"/>
-                </a:solidFill>
-                <a:latin typeface="Calibri"/>
-              </a:rPr>
-              <a:t>Rays  </a:t>
-            </a:r>
-            <a:r>
-              <a:rPr sz="1200" b="0" i="0">
-                <a:solidFill>
-                  <a:srgbClr val="6B7280"/>
-                </a:solidFill>
-                <a:latin typeface="Calibri"/>
-              </a:rPr>
-              <a:t>.602, weak OF</a:t>
-            </a:r>
-          </a:p>
-        </p:txBody>
-      </p:sp>
-      <p:sp>
-        <p:nvSpPr>
-          <p:cNvPr id="10" name="Oval 9"/>
+          <p:cNvPr id="14" name="Oval 13"/>
           <p:cNvSpPr/>
           <p:nvPr/>
         </p:nvSpPr>
         <p:spPr>
           <a:xfrm>
-            <a:off x="8183879" y="3355847"/>
-            <a:ext cx="128016" cy="128016"/>
+            <a:off x="8412480" y="2724912"/>
+            <a:ext cx="384048" cy="384048"/>
           </a:xfrm>
           <a:prstGeom prst="ellipse">
             <a:avLst/>
           </a:prstGeom>
           <a:solidFill>
-            <a:srgbClr val="BD3039"/>
+            <a:srgbClr val="B7892F"/>
           </a:solidFill>
           <a:ln>
             <a:noFill/>
@@ -9687,23 +10358,32 @@
           </a:fontRef>
         </p:style>
         <p:txBody>
-          <a:bodyPr rtlCol="0" anchor="ctr"/>
+          <a:bodyPr rtlCol="0" anchor="ctr" wrap="none"/>
           <a:lstStyle/>
           <a:p>
             <a:pPr algn="ctr"/>
-          </a:p>
-        </p:txBody>
-      </p:sp>
-      <p:sp>
-        <p:nvSpPr>
-          <p:cNvPr id="11" name="TextBox 10"/>
-          <p:cNvSpPr txBox="1"/>
-          <p:nvPr/>
-        </p:nvSpPr>
-        <p:spPr>
-          <a:xfrm>
-            <a:off x="8439911" y="3328415"/>
-            <a:ext cx="3566160" cy="457200"/>
+            <a:r>
+              <a:rPr sz="1600" b="1">
+                <a:solidFill>
+                  <a:srgbClr val="FFFFFF"/>
+                </a:solidFill>
+                <a:latin typeface="Cambria"/>
+              </a:rPr>
+              <a:t>3</a:t>
+            </a:r>
+          </a:p>
+        </p:txBody>
+      </p:sp>
+      <p:sp>
+        <p:nvSpPr>
+          <p:cNvPr id="15" name="TextBox 14"/>
+          <p:cNvSpPr txBox="1"/>
+          <p:nvPr/>
+        </p:nvSpPr>
+        <p:spPr>
+          <a:xfrm>
+            <a:off x="8412480" y="3310128"/>
+            <a:ext cx="2999232" cy="411480"/>
           </a:xfrm>
           <a:prstGeom prst="rect">
             <a:avLst/>
@@ -9725,80 +10405,69 @@
               </a:spcAft>
             </a:pPr>
             <a:r>
-              <a:rPr sz="1400" b="1" i="0">
+              <a:rPr sz="1600" b="1" i="0">
                 <a:solidFill>
                   <a:srgbClr val="0C2340"/>
                 </a:solidFill>
-                <a:latin typeface="Calibri"/>
-              </a:rPr>
-              <a:t>Marlins  </a:t>
-            </a:r>
-            <a:r>
-              <a:rPr sz="1200" b="0" i="0">
+                <a:latin typeface="Cambria"/>
+              </a:rPr>
+              <a:t>Salary relief</a:t>
+            </a:r>
+          </a:p>
+        </p:txBody>
+      </p:sp>
+      <p:sp>
+        <p:nvSpPr>
+          <p:cNvPr id="16" name="TextBox 15"/>
+          <p:cNvSpPr txBox="1"/>
+          <p:nvPr/>
+        </p:nvSpPr>
+        <p:spPr>
+          <a:xfrm>
+            <a:off x="8412480" y="3767328"/>
+            <a:ext cx="2999232" cy="1097280"/>
+          </a:xfrm>
+          <a:prstGeom prst="rect">
+            <a:avLst/>
+          </a:prstGeom>
+          <a:noFill/>
+        </p:spPr>
+        <p:txBody>
+          <a:bodyPr wrap="square" anchor="t" lIns="0" rIns="0" tIns="0" bIns="0">
+            <a:spAutoFit/>
+          </a:bodyPr>
+          <a:lstStyle/>
+          <a:p>
+            <a:pPr algn="l">
+              <a:lnSpc>
+                <a:spcPct val="110000"/>
+              </a:lnSpc>
+              <a:spcAft>
+                <a:spcPts val="400"/>
+              </a:spcAft>
+            </a:pPr>
+            <a:r>
+              <a:rPr sz="1280" b="0" i="0">
                 <a:solidFill>
                   <a:srgbClr val="6B7280"/>
                 </a:solidFill>
                 <a:latin typeface="Calibri"/>
               </a:rPr>
-              <a:t>in the hunt, thin OF</a:t>
-            </a:r>
-          </a:p>
-        </p:txBody>
-      </p:sp>
-      <p:sp>
-        <p:nvSpPr>
-          <p:cNvPr id="12" name="Oval 11"/>
-          <p:cNvSpPr/>
-          <p:nvPr/>
-        </p:nvSpPr>
-        <p:spPr>
-          <a:xfrm>
-            <a:off x="8183879" y="3922776"/>
-            <a:ext cx="128016" cy="128016"/>
-          </a:xfrm>
-          <a:prstGeom prst="ellipse">
-            <a:avLst/>
-          </a:prstGeom>
-          <a:solidFill>
-            <a:srgbClr val="BD3039"/>
-          </a:solidFill>
-          <a:ln>
-            <a:noFill/>
-          </a:ln>
-          <a:effectLst/>
-        </p:spPr>
-        <p:style>
-          <a:lnRef idx="1">
-            <a:schemeClr val="accent1"/>
-          </a:lnRef>
-          <a:fillRef idx="3">
-            <a:schemeClr val="accent1"/>
-          </a:fillRef>
-          <a:effectRef idx="2">
-            <a:schemeClr val="accent1"/>
-          </a:effectRef>
-          <a:fontRef idx="minor">
-            <a:schemeClr val="lt1"/>
-          </a:fontRef>
-        </p:style>
-        <p:txBody>
-          <a:bodyPr rtlCol="0" anchor="ctr"/>
-          <a:lstStyle/>
-          <a:p>
-            <a:pPr algn="ctr"/>
-          </a:p>
-        </p:txBody>
-      </p:sp>
-      <p:sp>
-        <p:nvSpPr>
-          <p:cNvPr id="13" name="TextBox 12"/>
-          <p:cNvSpPr txBox="1"/>
-          <p:nvPr/>
-        </p:nvSpPr>
-        <p:spPr>
-          <a:xfrm>
-            <a:off x="8439911" y="3895344"/>
-            <a:ext cx="3566160" cy="457200"/>
+              <a:t>Attach Yoshida money where possible; free payroll for the 2027 window.</a:t>
+            </a:r>
+          </a:p>
+        </p:txBody>
+      </p:sp>
+      <p:sp>
+        <p:nvSpPr>
+          <p:cNvPr id="17" name="TextBox 16"/>
+          <p:cNvSpPr txBox="1"/>
+          <p:nvPr/>
+        </p:nvSpPr>
+        <p:spPr>
+          <a:xfrm>
+            <a:off x="566928" y="5257800"/>
+            <a:ext cx="11064240" cy="457200"/>
           </a:xfrm>
           <a:prstGeom prst="rect">
             <a:avLst/>
@@ -9820,89 +10489,29 @@
               </a:spcAft>
             </a:pPr>
             <a:r>
-              <a:rPr sz="1400" b="1" i="0">
+              <a:rPr sz="1400" b="1" i="1">
                 <a:solidFill>
                   <a:srgbClr val="0C2340"/>
                 </a:solidFill>
                 <a:latin typeface="Calibri"/>
               </a:rPr>
-              <a:t>Guardians  </a:t>
-            </a:r>
-            <a:r>
-              <a:rPr sz="1200" b="0" i="0">
+              <a:t>Keep the arms. Cash the outfield. </a:t>
+            </a:r>
+            <a:r>
+              <a:rPr sz="1400" b="0" i="1">
                 <a:solidFill>
                   <a:srgbClr val="6B7280"/>
                 </a:solidFill>
                 <a:latin typeface="Calibri"/>
               </a:rPr>
-              <a:t>contender, OF need</a:t>
-            </a:r>
-          </a:p>
-        </p:txBody>
-      </p:sp>
-      <p:sp>
-        <p:nvSpPr>
-          <p:cNvPr id="14" name="TextBox 13"/>
-          <p:cNvSpPr txBox="1"/>
-          <p:nvPr/>
-        </p:nvSpPr>
-        <p:spPr>
-          <a:xfrm>
-            <a:off x="8183879" y="4709160"/>
-            <a:ext cx="3657600" cy="1005840"/>
-          </a:xfrm>
-          <a:prstGeom prst="rect">
-            <a:avLst/>
-          </a:prstGeom>
-          <a:noFill/>
-        </p:spPr>
-        <p:txBody>
-          <a:bodyPr wrap="square" anchor="t" lIns="0" rIns="0" tIns="0" bIns="0">
-            <a:spAutoFit/>
-          </a:bodyPr>
-          <a:lstStyle/>
-          <a:p>
-            <a:pPr algn="l">
-              <a:lnSpc>
-                <a:spcPct val="112000"/>
-              </a:lnSpc>
-              <a:spcAft>
-                <a:spcPts val="400"/>
-              </a:spcAft>
-            </a:pPr>
-            <a:r>
-              <a:rPr sz="1250" b="0" i="0">
-                <a:solidFill>
-                  <a:srgbClr val="20232A"/>
-                </a:solidFill>
-                <a:latin typeface="Calibri"/>
-              </a:rPr>
-              <a:t>Trade a redundant bat to a team that needs one — and take back the </a:t>
-            </a:r>
-            <a:r>
-              <a:rPr sz="1250" b="1" i="0">
-                <a:solidFill>
-                  <a:srgbClr val="2E7D32"/>
-                </a:solidFill>
-                <a:latin typeface="Calibri"/>
-              </a:rPr>
-              <a:t>hitting/youth</a:t>
-            </a:r>
-            <a:r>
-              <a:rPr sz="1250" b="0" i="0">
-                <a:solidFill>
-                  <a:srgbClr val="20232A"/>
-                </a:solidFill>
-                <a:latin typeface="Calibri"/>
-              </a:rPr>
-              <a:t> Boston is short on.</a:t>
-            </a:r>
-          </a:p>
-        </p:txBody>
-      </p:sp>
-      <p:sp>
-        <p:nvSpPr>
-          <p:cNvPr id="15" name="TextBox 14"/>
+              <a:t>Build the 2027 lineup, don't rent the 2026 one.</a:t>
+            </a:r>
+          </a:p>
+        </p:txBody>
+      </p:sp>
+      <p:sp>
+        <p:nvSpPr>
+          <p:cNvPr id="18" name="TextBox 17"/>
           <p:cNvSpPr txBox="1"/>
           <p:nvPr/>
         </p:nvSpPr>

</xml_diff>

<commit_message>
Lead with the team: 13-straight streak opens article and deck, Duran demoted to closing chapter
- ARTICLE.md restructure (generated in src/deadline.py): streak-first lede
  (dynamic W-streak branch, hardcoded 13 as season fact when cold), then
  buy/sell verdict, positional audit, mock trades, Duran file last as
  'the whole season in one player'
- mock_trades.py splice marker moved so trades land after the audit,
  before the Duran chapter
- Deck: new cover ('They Won 13 Straight. Now Comes the Hard Part'),
  slide 2 stat cards reordered W13 / +45 / 75%

Co-Authored-By: Claude Fable 5 <noreply@anthropic.com>
</commit_message>
<xml_diff>
--- a/outputs/Red_Sox_Outfield_Strategy.pptx
+++ b/outputs/Red_Sox_Outfield_Strategy.pptx
@@ -3193,7 +3193,7 @@
                 </a:solidFill>
                 <a:latin typeface="Arial"/>
               </a:rPr>
-              <a:t>BOSTON RED SOX  ·  ROSTER STRATEGY</a:t>
+              <a:t>BOSTON RED SOX  ·  TRADE DEADLINE 2026</a:t>
             </a:r>
           </a:p>
         </p:txBody>
@@ -3235,7 +3235,7 @@
                 </a:solidFill>
                 <a:latin typeface="Arial"/>
               </a:rPr>
-              <a:t>Turning the Outfield Logjam</a:t>
+              <a:t>They Won 13 Straight.</a:t>
             </a:r>
           </a:p>
           <a:p>
@@ -3254,7 +3254,7 @@
                 </a:solidFill>
                 <a:latin typeface="Arial"/>
               </a:rPr>
-              <a:t>into an Asset</a:t>
+              <a:t>Now Comes the Hard Part</a:t>
             </a:r>
           </a:p>
         </p:txBody>
@@ -3296,7 +3296,7 @@
                 </a:solidFill>
                 <a:latin typeface="Arial"/>
               </a:rPr>
-              <a:t>Five bats for four spots, a playoff spot in hand, and a deadline plan the data actually supports: buy targeted, hold Duran at his nadir, and decide his future in the winter.</a:t>
+              <a:t>The hottest team in baseball was supposed to sell. A deadline case study: why the run differential saw the streak coming, what Boston should buy — and why the left fielder is the whole season in miniature.</a:t>
             </a:r>
           </a:p>
         </p:txBody>
@@ -7695,7 +7695,7 @@
                 </a:solidFill>
                 <a:latin typeface="Arial"/>
               </a:rPr>
-              <a:t>The record is finally catching up to the ballclub</a:t>
+              <a:t>The hottest team in baseball — and the math saw it coming</a:t>
             </a:r>
           </a:p>
         </p:txBody>
@@ -7785,7 +7785,7 @@
                 </a:solidFill>
                 <a:latin typeface="Arial"/>
               </a:rPr>
-              <a:t>75%</a:t>
+              <a:t>W13</a:t>
             </a:r>
           </a:p>
         </p:txBody>
@@ -7827,7 +7827,7 @@
                 </a:solidFill>
                 <a:latin typeface="Arial"/>
               </a:rPr>
-              <a:t>playoff odds</a:t>
+              <a:t>winning streak</a:t>
             </a:r>
           </a:p>
         </p:txBody>
@@ -7869,7 +7869,7 @@
                 </a:solidFill>
                 <a:latin typeface="Arial"/>
               </a:rPr>
-              <a:t>10,000 sims — a playoff team, not a corpse (fig. 12)</a:t>
+              <a:t>longest run in the majors this season</a:t>
             </a:r>
           </a:p>
         </p:txBody>
@@ -8133,7 +8133,7 @@
                 </a:solidFill>
                 <a:latin typeface="Arial"/>
               </a:rPr>
-              <a:t>WC3</a:t>
+              <a:t>75%</a:t>
             </a:r>
           </a:p>
         </p:txBody>
@@ -8175,7 +8175,7 @@
                 </a:solidFill>
                 <a:latin typeface="Arial"/>
               </a:rPr>
-              <a:t>spot currently held</a:t>
+              <a:t>playoff odds</a:t>
             </a:r>
           </a:p>
         </p:txBody>
@@ -8217,7 +8217,7 @@
                 </a:solidFill>
                 <a:latin typeface="Arial"/>
               </a:rPr>
-              <a:t>after a 13-game winning streak</a:t>
+              <a:t>10,000 sims — holding the final wild card (fig. 12)</a:t>
             </a:r>
           </a:p>
         </p:txBody>

</xml_diff>

<commit_message>
Chemistry-first deadline plan: trades ranked by clubhouse disruption
- mock_trades.md: new 'chemistry constraint' premise; trades reordered
  least-to-most disruptive (Weaver -> Langeliers -> Arraez -> Neto), each
  with an explicit clubhouse-cost verdict; Neto flagged 'probably wait';
  sell-branch note on what trading Contreras would signal to the room
- ARTICLE.md: BUY section adds the don't-disturb-the-room constraint;
  vets bullet notes they're the room's spine; trades section renamed
  'ranked by what they cost the room' with matching order
- Deck: trades slide reordered with disruption tags; BUY-slide rule now
  'Add without disturbing the room'
- Fixed garbled sentence in old Langeliers block

Co-Authored-By: Claude Fable 5 <noreply@anthropic.com>
</commit_message>
<xml_diff>
--- a/outputs/Red_Sox_Outfield_Strategy.pptx
+++ b/outputs/Red_Sox_Outfield_Strategy.pptx
@@ -4061,7 +4061,7 @@
                 </a:solidFill>
                 <a:latin typeface="Arial"/>
               </a:rPr>
-              <a:t>Four trades that fit — arms out, bats and leverage in</a:t>
+              <a:t>Four trades that fit — ranked by what they cost the room</a:t>
             </a:r>
           </a:p>
         </p:txBody>
@@ -4147,11 +4147,11 @@
             <a:r>
               <a:rPr sz="1100" b="1" i="0">
                 <a:solidFill>
-                  <a:srgbClr val="E8615A"/>
-                </a:solidFill>
-                <a:latin typeface="Arial"/>
-              </a:rPr>
-              <a:t>1 · THE BIG SWING</a:t>
+                  <a:srgbClr val="58C08D"/>
+                </a:solidFill>
+                <a:latin typeface="Arial"/>
+              </a:rPr>
+              <a:t>1 · THE PEN FIX · ZERO DISRUPTION</a:t>
             </a:r>
           </a:p>
         </p:txBody>
@@ -4193,7 +4193,7 @@
                 </a:solidFill>
                 <a:latin typeface="Arial"/>
               </a:rPr>
-              <a:t>SS Zach Neto (LAA)</a:t>
+              <a:t>RHP Luke Weaver (NYM)</a:t>
             </a:r>
           </a:p>
         </p:txBody>
@@ -4235,7 +4235,7 @@
                 </a:solidFill>
                 <a:latin typeface="Arial"/>
               </a:rPr>
-              <a:t>For Tolle + Early + a 45 FV. Controlled through 2029; ~$80M of value each way. Painful, franchise-window correct.</a:t>
+              <a:t>For a 45 FV + 40 FV — prospects only, nobody loses a job or an inning. Elite relief year, signed through '27. The highest-probability marginal win on the board.</a:t>
             </a:r>
           </a:p>
         </p:txBody>
@@ -4321,11 +4321,11 @@
             <a:r>
               <a:rPr sz="1100" b="1" i="0">
                 <a:solidFill>
-                  <a:srgbClr val="EAF0F8"/>
-                </a:solidFill>
-                <a:latin typeface="Arial"/>
-              </a:rPr>
-              <a:t>2 · THE STABILIZER</a:t>
+                  <a:srgbClr val="E3B14E"/>
+                </a:solidFill>
+                <a:latin typeface="Arial"/>
+              </a:rPr>
+              <a:t>2 · THE CATCHER FIX · LOW</a:t>
             </a:r>
           </a:p>
         </p:txBody>
@@ -4367,7 +4367,7 @@
                 </a:solidFill>
                 <a:latin typeface="Arial"/>
               </a:rPr>
-              <a:t>2B Luis Arraez (SFG)</a:t>
+              <a:t>C Shea Langeliers (ATH)</a:t>
             </a:r>
           </a:p>
         </p:txBody>
@@ -4409,7 +4409,7 @@
                 </a:solidFill>
                 <a:latin typeface="Arial"/>
               </a:rPr>
-              <a:t>For Brayan Bello. Pure rental; Arraez takes 2B, Mayer slides to SS. Zero prospect cost — the most odds-proportionate move.</a:t>
+              <a:t>For Bennett + a 45 FV. Bennett is the 8th starter on a 5-slot staff; catcher is the one spot with no hot incumbent. Controlled through 2028.</a:t>
             </a:r>
           </a:p>
         </p:txBody>
@@ -4495,11 +4495,11 @@
             <a:r>
               <a:rPr sz="1100" b="1" i="0">
                 <a:solidFill>
-                  <a:srgbClr val="58C08D"/>
-                </a:solidFill>
-                <a:latin typeface="Arial"/>
-              </a:rPr>
-              <a:t>3 · THE PEN FIX</a:t>
+                  <a:srgbClr val="EAF0F8"/>
+                </a:solidFill>
+                <a:latin typeface="Arial"/>
+              </a:rPr>
+              <a:t>3 · THE STABILIZER · MODERATE</a:t>
             </a:r>
           </a:p>
         </p:txBody>
@@ -4541,7 +4541,7 @@
                 </a:solidFill>
                 <a:latin typeface="Arial"/>
               </a:rPr>
-              <a:t>RHP Luke Weaver (NYM)</a:t>
+              <a:t>2B Luis Arraez (SFG)</a:t>
             </a:r>
           </a:p>
         </p:txBody>
@@ -4583,7 +4583,7 @@
                 </a:solidFill>
                 <a:latin typeface="Arial"/>
               </a:rPr>
-              <a:t>For a 45 FV + 40 FV. Elite relief year, signed through '27. The highest-probability marginal win on the board.</a:t>
+              <a:t>For Brayan Bello — the first deal that touches the active roster. Zero prospect cost; Arraez fills a patchwork platoon spot, not a hot regular's.</a:t>
             </a:r>
           </a:p>
         </p:txBody>
@@ -4669,11 +4669,11 @@
             <a:r>
               <a:rPr sz="1100" b="1" i="0">
                 <a:solidFill>
-                  <a:srgbClr val="E3B14E"/>
-                </a:solidFill>
-                <a:latin typeface="Arial"/>
-              </a:rPr>
-              <a:t>4 · THE CATCHER FIX</a:t>
+                  <a:srgbClr val="E8615A"/>
+                </a:solidFill>
+                <a:latin typeface="Arial"/>
+              </a:rPr>
+              <a:t>4 · THE BIG SWING · HIGH — WAIT?</a:t>
             </a:r>
           </a:p>
         </p:txBody>
@@ -4715,7 +4715,7 @@
                 </a:solidFill>
                 <a:latin typeface="Arial"/>
               </a:rPr>
-              <a:t>C Shea Langeliers (ATH)</a:t>
+              <a:t>SS Zach Neto (LAA)</a:t>
             </a:r>
           </a:p>
         </p:txBody>
@@ -4757,7 +4757,7 @@
                 </a:solidFill>
                 <a:latin typeface="Arial"/>
               </a:rPr>
-              <a:t>For Bennett + a 45 FV. 120+ wRC+ catcher controlled through 2028; the A's always need cheap innings.</a:t>
+              <a:t>For Tolle + Early + a 45 FV: two arms out of a winning rotation mid-streak. Franchise-window correct — and still there in the winter. Controlled through 2029.</a:t>
             </a:r>
           </a:p>
         </p:txBody>
@@ -8773,7 +8773,7 @@
                 </a:solidFill>
                 <a:latin typeface="Arial"/>
               </a:rPr>
-              <a:t>Add at the holes</a:t>
+              <a:t>Add without disturbing the room</a:t>
             </a:r>
           </a:p>
           <a:p>
@@ -8792,7 +8792,7 @@
                 </a:solidFill>
                 <a:latin typeface="Arial"/>
               </a:rPr>
-              <a:t>A controllable infield bat, a reliever, and a catcher upgrade — targeted, no rental splurges (see the audit).</a:t>
+              <a:t>A reliever, a catcher, an infield bat — paid for in prospects before big-leaguers, filling empty spots, not hot ones.</a:t>
             </a:r>
           </a:p>
         </p:txBody>

</xml_diff>

<commit_message>
Deadline countdown and a full voice pass: no em dashes, plainer sentences
- Article and deck now carry a live countdown to the August 3 deadline
  (subtitle, thesis paragraph, deck cover), computed from today's date
- Every em dash removed from the generated article and all deck copy;
  replaced with commas, periods, colons, or parentheses
- Writerly phrases flattened: 'sits at its nadir' -> 'at rock bottom',
  'wearing a record' -> 'record sat near .500', 'mildly gilded' ->
  'mildly inflated', 'surrender priced as prudence' -> 'met with
  outrage', 'the easy take wrote itself' -> 'the obvious move was to
  sell', section retitled 'If they buy, where?' and 'Three trades that
  fit, and one to skip'
- LF audit bullet rewritten shorter and cleaner; speed-model paragraph
  reworded ('Testing the speed claim directly')
- Site pages rebuilt; deck at 18 slides; 80 tests green, lint clean

Co-Authored-By: Claude Fable 5 <noreply@anthropic.com>
</commit_message>
<xml_diff>
--- a/outputs/Red_Sox_Outfield_Strategy.pptx
+++ b/outputs/Red_Sox_Outfield_Strategy.pptx
@@ -3299,7 +3299,7 @@
                 </a:solidFill>
                 <a:latin typeface="Arial"/>
               </a:rPr>
-              <a:t>The hottest team in baseball was supposed to sell. A lookahead to trade deadline thoughts.</a:t>
+              <a:t>The hottest team in baseball was supposed to sell. A lookahead to the trade deadline, now 11 days away.</a:t>
             </a:r>
           </a:p>
         </p:txBody>
@@ -3409,7 +3409,7 @@
                 </a:solidFill>
                 <a:latin typeface="Courier New"/>
               </a:rPr>
-              <a:t>// IF THEY BUY — WHERE?</a:t>
+              <a:t>// IF THEY BUY, WHERE?</a:t>
             </a:r>
           </a:p>
         </p:txBody>
@@ -3582,7 +3582,7 @@
                 </a:solidFill>
                 <a:latin typeface="Arial"/>
               </a:rPr>
-              <a:t>Duran's regression — now sheltered by a Jahmai Jones platoon — plus Anthony's eventual return. Free.</a:t>
+              <a:t>Duran's regression, now sheltered by a Jahmai Jones platoon, plus Anthony's eventual return. Free.</a:t>
             </a:r>
           </a:p>
         </p:txBody>
@@ -3796,7 +3796,7 @@
                 </a:solidFill>
                 <a:latin typeface="Arial"/>
               </a:rPr>
-              <a:t>ERA top-10 but FIP and reliever WAR rank far worse — it will regress without help.</a:t>
+              <a:t>ERA top-10 but FIP and reliever WAR rank far worse, it will regress without help.</a:t>
             </a:r>
           </a:p>
         </p:txBody>
@@ -4195,7 +4195,7 @@
                 </a:solidFill>
                 <a:latin typeface="Arial"/>
               </a:rPr>
-              <a:t>Waiver claims, up-down arms and career minor-leaguers holding real roles — +3.0 WAR combined.</a:t>
+              <a:t>Waiver claims, up-down arms and career minor-leaguers holding real roles, +3.0 WAR combined.</a:t>
             </a:r>
           </a:p>
         </p:txBody>
@@ -4409,7 +4409,7 @@
                 </a:solidFill>
                 <a:latin typeface="Arial"/>
               </a:rPr>
-              <a:t>Results sit within a few points of expected — they're earning it. The risk is track record: careers, not heaters, predict August.</a:t>
+              <a:t>Results sit within a few points of expected, they're earning it. The risk is track record: careers, not heaters, predict August.</a:t>
             </a:r>
           </a:p>
         </p:txBody>
@@ -4808,7 +4808,7 @@
                 </a:solidFill>
                 <a:latin typeface="Arial"/>
               </a:rPr>
-              <a:t>3.42 RA9 with Wong, 4.20 with Narváez — the run-prevention core of the streak.</a:t>
+              <a:t>3.42 RA9 with Wong, 4.20 with Narváez, the run-prevention core of the streak.</a:t>
             </a:r>
           </a:p>
         </p:txBody>
@@ -4915,7 +4915,7 @@
                 </a:solidFill>
                 <a:latin typeface="Arial"/>
               </a:rPr>
-              <a:t>Raw pairings look dramatic (fig. 14) — but small samples shrink hard (fig. 15). What survives: settled, deliberate assignments.</a:t>
+              <a:t>Raw pairings look dramatic (fig. 14), but small samples shrink hard (fig. 15). What survives: settled, deliberate assignments.</a:t>
             </a:r>
           </a:p>
         </p:txBody>
@@ -5022,7 +5022,7 @@
                 </a:solidFill>
                 <a:latin typeface="Arial"/>
               </a:rPr>
-              <a:t>Leverage relievers ride with a settled catcher — these innings aren't assigned at random.</a:t>
+              <a:t>Leverage relievers ride with a settled catcher, these innings aren't assigned at random.</a:t>
             </a:r>
           </a:p>
         </p:txBody>
@@ -5528,7 +5528,7 @@
                 </a:solidFill>
                 <a:latin typeface="Arial"/>
               </a:rPr>
-              <a:t>Speed-blind xstats under-predict the fastest decile by +20 pts of BABIP. Duran's speed term: +23 pts of wOBA on contact — inside the +5–14 band derived independently.</a:t>
+              <a:t>Speed-blind xstats under-predict the fastest decile by +20 pts of BABIP. Duran's speed term: +23 pts of wOBA on contact, inside the +5–14 band derived independently.</a:t>
             </a:r>
           </a:p>
         </p:txBody>
@@ -5742,7 +5742,7 @@
                 </a:solidFill>
                 <a:latin typeface="Arial"/>
               </a:rPr>
-              <a:t>Out-of-sample everywhere, CIs on every headline, and frozen pre-registered predictions graded in October — flattering or not.</a:t>
+              <a:t>Out-of-sample everywhere, CIs on every headline, and frozen pre-registered predictions graded in October, flattering or not.</a:t>
             </a:r>
           </a:p>
         </p:txBody>
@@ -6077,7 +6077,7 @@
                 </a:solidFill>
                 <a:latin typeface="Arial"/>
               </a:rPr>
-              <a:t>For a 45 FV + 40 FV — prospects only, nobody loses a job or an inning. Elite relief year, signed through '27. The highest-probability marginal win on the board.</a:t>
+              <a:t>For a 45 FV + 40 FV, prospects only, nobody loses a job or an inning. Elite relief year, signed through '27. The highest-probability marginal win on the board.</a:t>
             </a:r>
           </a:p>
         </p:txBody>
@@ -6251,7 +6251,7 @@
                 </a:solidFill>
                 <a:latin typeface="Arial"/>
               </a:rPr>
-              <a:t>For Brayan Bello — the first deal that touches the active roster. Zero prospect cost; Arraez fills a patchwork platoon spot, not a hot regular's.</a:t>
+              <a:t>For Brayan Bello, the first deal that touches the active roster. Zero prospect cost; Arraez fills a patchwork platoon spot, not a hot regular's.</a:t>
             </a:r>
           </a:p>
         </p:txBody>
@@ -6425,7 +6425,7 @@
                 </a:solidFill>
                 <a:latin typeface="Arial"/>
               </a:rPr>
-              <a:t>For Tolle + Early + a 45 FV: two arms out of a winning rotation mid-streak. Franchise-window correct — and still there in the winter. Controlled through 2029.</a:t>
+              <a:t>For Tolle + Early + a 45 FV: two arms out of a winning rotation mid-streak. Franchise-window correct, and still there in the winter. Controlled through 2029.</a:t>
             </a:r>
           </a:p>
         </p:txBody>
@@ -6641,7 +6641,7 @@
                 </a:solidFill>
                 <a:latin typeface="Arial"/>
               </a:rPr>
-              <a:t>A menu, not a plan — Boston can afford about two. </a:t>
+              <a:t>A menu, not a plan, Boston can afford about two. </a:t>
             </a:r>
             <a:r>
               <a:rPr sz="1250" b="0" i="0">
@@ -6853,7 +6853,7 @@
                 </a:solidFill>
                 <a:latin typeface="Arial"/>
               </a:rPr>
-              <a:t>If winter comes and Duran's rebound has shown up, this is what a deal should return. With a top-6 rotation (3.65 ERA) carrying the club, trading bats for arms is backwards — convert the outfield surplus into what's thin:</a:t>
+              <a:t>If winter comes and Duran's rebound has shown up, this is what a deal should return. With a top-6 rotation (3.65 ERA) carrying the club, trading bats for arms is backwards, convert the outfield surplus into what's thin:</a:t>
             </a:r>
           </a:p>
         </p:txBody>
@@ -7227,7 +7227,7 @@
                 </a:solidFill>
                 <a:latin typeface="Arial"/>
               </a:rPr>
-              <a:t>In a retool you take the best player, not the positional patch — prospects and MLB-ready youth over rentals.</a:t>
+              <a:t>In a retool you take the best player, not the positional patch, prospects and MLB-ready youth over rentals.</a:t>
             </a:r>
           </a:p>
         </p:txBody>
@@ -8122,7 +8122,7 @@
                 </a:solidFill>
                 <a:latin typeface="Arial"/>
               </a:rPr>
-              <a:t>Trade a redundant bat to a team that needs one — and take back the </a:t>
+              <a:t>Trade a redundant bat to a team that needs one, and take back the </a:t>
             </a:r>
             <a:r>
               <a:rPr sz="1250" b="1" i="0">
@@ -8417,7 +8417,7 @@
                 </a:solidFill>
                 <a:latin typeface="Arial"/>
               </a:rPr>
-              <a:t>A controllable infield bat and a reliever, funded from the pitching surplus. Keep the vets — they're playoff innings now.</a:t>
+              <a:t>A controllable infield bat and a reliever, funded from the pitching surplus. Keep the vets, they're playoff innings now.</a:t>
             </a:r>
           </a:p>
         </p:txBody>
@@ -9182,7 +9182,7 @@
                 </a:solidFill>
                 <a:latin typeface="Arial"/>
               </a:rPr>
-              <a:t>77% playoff odds, +45 run differential, a wild card in hand — buy small (a reliever first), keep the vets, and let the record keep catching up to the process.</a:t>
+              <a:t>77% playoff odds, +45 run differential, a wild card in hand, buy small (a reliever first), keep the vets, and let the record keep catching up to the process.</a:t>
             </a:r>
           </a:p>
         </p:txBody>
@@ -9279,7 +9279,7 @@
                 </a:solidFill>
                 <a:latin typeface="Arial"/>
               </a:rPr>
-              <a:t>Hold Duran through the deadline; re-price him in winter — extend or trade the 2025 player, never the unlucky 2026 one.</a:t>
+              <a:t>Hold Duran through the deadline; re-price him in winter, extend or trade the 2025 player, never the unlucky 2026 one.</a:t>
             </a:r>
           </a:p>
         </p:txBody>
@@ -9427,7 +9427,7 @@
                 </a:solidFill>
                 <a:latin typeface="Arial"/>
               </a:rPr>
-              <a:t>high that 2024 shouldn't be the anchor and pitching is a strength; the open question is how much of 2026's skill dip (chase, whiff, hard-hit are all worse) persists — the one thing to watch before selling.</a:t>
+              <a:t>high that 2024 shouldn't be the anchor and pitching is a strength; the open question is how much of 2026's skill dip (chase, whiff, hard-hit are all worse) persists, the one thing to watch before selling.</a:t>
             </a:r>
           </a:p>
         </p:txBody>
@@ -10634,7 +10634,7 @@
                 </a:solidFill>
                 <a:latin typeface="Arial"/>
               </a:rPr>
-              <a:t>A reliever first, maybe an infield bat — prospects before big-leaguers, empty spots before hot ones. The catcher tandem stays.</a:t>
+              <a:t>A reliever first, maybe an infield bat, prospects before big-leaguers, empty spots before hot ones. The catcher tandem stays.</a:t>
             </a:r>
           </a:p>
         </p:txBody>
@@ -12991,7 +12991,7 @@
                 </a:solidFill>
                 <a:latin typeface="Arial"/>
               </a:rPr>
-              <a:t>wOBA .263 BELOW its .293 xwOBA — 34 to 43 pts under his own norm; BABIP .238 vs .309 expected. Erosion real, luck worse.</a:t>
+              <a:t>wOBA .263 BELOW its .293 xwOBA, 34 to 43 pts under his own norm; BABIP .238 vs .309 expected. Erosion real, luck worse.</a:t>
             </a:r>
           </a:p>
         </p:txBody>
@@ -13725,7 +13725,7 @@
                 </a:solidFill>
                 <a:latin typeface="Arial"/>
               </a:rPr>
-              <a:t>the 22-point probability gap is the price of the worse chase / whiff / hard-hit rates. Hold-through-2026 survives the erosion stress test — but with less confidence in the rebound narrative itself.</a:t>
+              <a:t>the 22-point probability gap is the price of the worse chase / whiff / hard-hit rates. Hold-through-2026 survives the erosion stress test, but with less confidence in the rebound narrative itself.</a:t>
             </a:r>
           </a:p>
         </p:txBody>
@@ -14009,7 +14009,7 @@
                 </a:solidFill>
                 <a:latin typeface="Arial"/>
               </a:rPr>
-              <a:t>  avg bat speed, 2026 — UP from 72.7 in '24</a:t>
+              <a:t>  avg bat speed 2026, up from 72.7 in '24</a:t>
             </a:r>
           </a:p>
         </p:txBody>

</xml_diff>